<commit_message>
Lagt inn bilde i powerpoint, TCA0 eksempelvektor
Konflikter i remote og lokal, håper å fikse det
</commit_message>
<xml_diff>
--- a/Kursdag 2/Dag to.pptx
+++ b/Kursdag 2/Dag to.pptx
@@ -4,21 +4,28 @@
   <p:sldMasterIdLst>
     <p:sldMasterId id="2147483648" r:id="rId1"/>
   </p:sldMasterIdLst>
+  <p:notesMasterIdLst>
+    <p:notesMasterId r:id="rId20"/>
+  </p:notesMasterIdLst>
   <p:sldIdLst>
     <p:sldId id="256" r:id="rId2"/>
     <p:sldId id="257" r:id="rId3"/>
     <p:sldId id="260" r:id="rId4"/>
     <p:sldId id="269" r:id="rId5"/>
-    <p:sldId id="267" r:id="rId6"/>
-    <p:sldId id="268" r:id="rId7"/>
-    <p:sldId id="259" r:id="rId8"/>
-    <p:sldId id="261" r:id="rId9"/>
-    <p:sldId id="262" r:id="rId10"/>
-    <p:sldId id="263" r:id="rId11"/>
-    <p:sldId id="264" r:id="rId12"/>
-    <p:sldId id="265" r:id="rId13"/>
-    <p:sldId id="266" r:id="rId14"/>
-    <p:sldId id="258" r:id="rId15"/>
+    <p:sldId id="270" r:id="rId6"/>
+    <p:sldId id="267" r:id="rId7"/>
+    <p:sldId id="268" r:id="rId8"/>
+    <p:sldId id="259" r:id="rId9"/>
+    <p:sldId id="261" r:id="rId10"/>
+    <p:sldId id="262" r:id="rId11"/>
+    <p:sldId id="263" r:id="rId12"/>
+    <p:sldId id="264" r:id="rId13"/>
+    <p:sldId id="265" r:id="rId14"/>
+    <p:sldId id="266" r:id="rId15"/>
+    <p:sldId id="258" r:id="rId16"/>
+    <p:sldId id="271" r:id="rId17"/>
+    <p:sldId id="272" r:id="rId18"/>
+    <p:sldId id="273" r:id="rId19"/>
   </p:sldIdLst>
   <p:sldSz cx="12192000" cy="6858000"/>
   <p:notesSz cx="6858000" cy="9144000"/>
@@ -125,6 +132,442 @@
 </p:presentation>
 </file>
 
+<file path=ppt/notesMasters/notesMaster1.xml><?xml version="1.0" encoding="utf-8"?>
+<p:notesMaster xmlns:a="http://schemas.openxmlformats.org/drawingml/2006/main" xmlns:r="http://schemas.openxmlformats.org/officeDocument/2006/relationships" xmlns:p="http://schemas.openxmlformats.org/presentationml/2006/main">
+  <p:cSld>
+    <p:bg>
+      <p:bgRef idx="1001">
+        <a:schemeClr val="bg1"/>
+      </p:bgRef>
+    </p:bg>
+    <p:spTree>
+      <p:nvGrpSpPr>
+        <p:cNvPr id="1" name=""/>
+        <p:cNvGrpSpPr/>
+        <p:nvPr/>
+      </p:nvGrpSpPr>
+      <p:grpSpPr>
+        <a:xfrm>
+          <a:off x="0" y="0"/>
+          <a:ext cx="0" cy="0"/>
+          <a:chOff x="0" y="0"/>
+          <a:chExt cx="0" cy="0"/>
+        </a:xfrm>
+      </p:grpSpPr>
+      <p:sp>
+        <p:nvSpPr>
+          <p:cNvPr id="2" name="Plassholder for topptekst 1"/>
+          <p:cNvSpPr>
+            <a:spLocks noGrp="1"/>
+          </p:cNvSpPr>
+          <p:nvPr>
+            <p:ph type="hdr" sz="quarter"/>
+          </p:nvPr>
+        </p:nvSpPr>
+        <p:spPr>
+          <a:xfrm>
+            <a:off x="0" y="0"/>
+            <a:ext cx="2971800" cy="458788"/>
+          </a:xfrm>
+          <a:prstGeom prst="rect">
+            <a:avLst/>
+          </a:prstGeom>
+        </p:spPr>
+        <p:txBody>
+          <a:bodyPr vert="horz" lIns="91440" tIns="45720" rIns="91440" bIns="45720" rtlCol="0"/>
+          <a:lstStyle>
+            <a:lvl1pPr algn="l">
+              <a:defRPr sz="1200"/>
+            </a:lvl1pPr>
+          </a:lstStyle>
+          <a:p>
+            <a:endParaRPr lang="nb-NO"/>
+          </a:p>
+        </p:txBody>
+      </p:sp>
+      <p:sp>
+        <p:nvSpPr>
+          <p:cNvPr id="3" name="Plassholder for dato 2"/>
+          <p:cNvSpPr>
+            <a:spLocks noGrp="1"/>
+          </p:cNvSpPr>
+          <p:nvPr>
+            <p:ph type="dt" idx="1"/>
+          </p:nvPr>
+        </p:nvSpPr>
+        <p:spPr>
+          <a:xfrm>
+            <a:off x="3884613" y="0"/>
+            <a:ext cx="2971800" cy="458788"/>
+          </a:xfrm>
+          <a:prstGeom prst="rect">
+            <a:avLst/>
+          </a:prstGeom>
+        </p:spPr>
+        <p:txBody>
+          <a:bodyPr vert="horz" lIns="91440" tIns="45720" rIns="91440" bIns="45720" rtlCol="0"/>
+          <a:lstStyle>
+            <a:lvl1pPr algn="r">
+              <a:defRPr sz="1200"/>
+            </a:lvl1pPr>
+          </a:lstStyle>
+          <a:p>
+            <a:fld id="{ACB6A25B-A690-4E14-9ED0-D2ECF6431ED6}" type="datetimeFigureOut">
+              <a:rPr lang="nb-NO" smtClean="0"/>
+              <a:t>14.03.2026</a:t>
+            </a:fld>
+            <a:endParaRPr lang="nb-NO"/>
+          </a:p>
+        </p:txBody>
+      </p:sp>
+      <p:sp>
+        <p:nvSpPr>
+          <p:cNvPr id="4" name="Plassholder for lysbilde 3"/>
+          <p:cNvSpPr>
+            <a:spLocks noGrp="1" noRot="1" noChangeAspect="1"/>
+          </p:cNvSpPr>
+          <p:nvPr>
+            <p:ph type="sldImg" idx="2"/>
+          </p:nvPr>
+        </p:nvSpPr>
+        <p:spPr>
+          <a:xfrm>
+            <a:off x="685800" y="1143000"/>
+            <a:ext cx="5486400" cy="3086100"/>
+          </a:xfrm>
+          <a:prstGeom prst="rect">
+            <a:avLst/>
+          </a:prstGeom>
+          <a:noFill/>
+          <a:ln w="12700">
+            <a:solidFill>
+              <a:prstClr val="black"/>
+            </a:solidFill>
+          </a:ln>
+        </p:spPr>
+        <p:txBody>
+          <a:bodyPr vert="horz" lIns="91440" tIns="45720" rIns="91440" bIns="45720" rtlCol="0" anchor="ctr"/>
+          <a:lstStyle/>
+          <a:p>
+            <a:endParaRPr lang="nb-NO"/>
+          </a:p>
+        </p:txBody>
+      </p:sp>
+      <p:sp>
+        <p:nvSpPr>
+          <p:cNvPr id="5" name="Plassholder for notater 4"/>
+          <p:cNvSpPr>
+            <a:spLocks noGrp="1"/>
+          </p:cNvSpPr>
+          <p:nvPr>
+            <p:ph type="body" sz="quarter" idx="3"/>
+          </p:nvPr>
+        </p:nvSpPr>
+        <p:spPr>
+          <a:xfrm>
+            <a:off x="685800" y="4400550"/>
+            <a:ext cx="5486400" cy="3600450"/>
+          </a:xfrm>
+          <a:prstGeom prst="rect">
+            <a:avLst/>
+          </a:prstGeom>
+        </p:spPr>
+        <p:txBody>
+          <a:bodyPr vert="horz" lIns="91440" tIns="45720" rIns="91440" bIns="45720" rtlCol="0"/>
+          <a:lstStyle/>
+          <a:p>
+            <a:pPr lvl="0"/>
+            <a:r>
+              <a:rPr lang="nb-NO"/>
+              <a:t>Klikk for å redigere tekststiler i malen</a:t>
+            </a:r>
+          </a:p>
+          <a:p>
+            <a:pPr lvl="1"/>
+            <a:r>
+              <a:rPr lang="nb-NO"/>
+              <a:t>Andre nivå</a:t>
+            </a:r>
+          </a:p>
+          <a:p>
+            <a:pPr lvl="2"/>
+            <a:r>
+              <a:rPr lang="nb-NO"/>
+              <a:t>Tredje nivå</a:t>
+            </a:r>
+          </a:p>
+          <a:p>
+            <a:pPr lvl="3"/>
+            <a:r>
+              <a:rPr lang="nb-NO"/>
+              <a:t>Fjerde nivå</a:t>
+            </a:r>
+          </a:p>
+          <a:p>
+            <a:pPr lvl="4"/>
+            <a:r>
+              <a:rPr lang="nb-NO"/>
+              <a:t>Femte nivå</a:t>
+            </a:r>
+          </a:p>
+        </p:txBody>
+      </p:sp>
+      <p:sp>
+        <p:nvSpPr>
+          <p:cNvPr id="6" name="Plassholder for bunntekst 5"/>
+          <p:cNvSpPr>
+            <a:spLocks noGrp="1"/>
+          </p:cNvSpPr>
+          <p:nvPr>
+            <p:ph type="ftr" sz="quarter" idx="4"/>
+          </p:nvPr>
+        </p:nvSpPr>
+        <p:spPr>
+          <a:xfrm>
+            <a:off x="0" y="8685213"/>
+            <a:ext cx="2971800" cy="458787"/>
+          </a:xfrm>
+          <a:prstGeom prst="rect">
+            <a:avLst/>
+          </a:prstGeom>
+        </p:spPr>
+        <p:txBody>
+          <a:bodyPr vert="horz" lIns="91440" tIns="45720" rIns="91440" bIns="45720" rtlCol="0" anchor="b"/>
+          <a:lstStyle>
+            <a:lvl1pPr algn="l">
+              <a:defRPr sz="1200"/>
+            </a:lvl1pPr>
+          </a:lstStyle>
+          <a:p>
+            <a:endParaRPr lang="nb-NO"/>
+          </a:p>
+        </p:txBody>
+      </p:sp>
+      <p:sp>
+        <p:nvSpPr>
+          <p:cNvPr id="7" name="Plassholder for lysbildenummer 6"/>
+          <p:cNvSpPr>
+            <a:spLocks noGrp="1"/>
+          </p:cNvSpPr>
+          <p:nvPr>
+            <p:ph type="sldNum" sz="quarter" idx="5"/>
+          </p:nvPr>
+        </p:nvSpPr>
+        <p:spPr>
+          <a:xfrm>
+            <a:off x="3884613" y="8685213"/>
+            <a:ext cx="2971800" cy="458787"/>
+          </a:xfrm>
+          <a:prstGeom prst="rect">
+            <a:avLst/>
+          </a:prstGeom>
+        </p:spPr>
+        <p:txBody>
+          <a:bodyPr vert="horz" lIns="91440" tIns="45720" rIns="91440" bIns="45720" rtlCol="0" anchor="b"/>
+          <a:lstStyle>
+            <a:lvl1pPr algn="r">
+              <a:defRPr sz="1200"/>
+            </a:lvl1pPr>
+          </a:lstStyle>
+          <a:p>
+            <a:fld id="{56CEED96-8DE0-441C-B2ED-FF713A48F07D}" type="slidenum">
+              <a:rPr lang="nb-NO" smtClean="0"/>
+              <a:t>‹#›</a:t>
+            </a:fld>
+            <a:endParaRPr lang="nb-NO"/>
+          </a:p>
+        </p:txBody>
+      </p:sp>
+    </p:spTree>
+    <p:extLst>
+      <p:ext uri="{BB962C8B-B14F-4D97-AF65-F5344CB8AC3E}">
+        <p14:creationId xmlns:p14="http://schemas.microsoft.com/office/powerpoint/2010/main" val="2918529522"/>
+      </p:ext>
+    </p:extLst>
+  </p:cSld>
+  <p:clrMap bg1="lt1" tx1="dk1" bg2="lt2" tx2="dk2" accent1="accent1" accent2="accent2" accent3="accent3" accent4="accent4" accent5="accent5" accent6="accent6" hlink="hlink" folHlink="folHlink"/>
+  <p:notesStyle>
+    <a:lvl1pPr marL="0" algn="l" defTabSz="914400" rtl="0" eaLnBrk="1" latinLnBrk="0" hangingPunct="1">
+      <a:defRPr sz="1200" kern="1200">
+        <a:solidFill>
+          <a:schemeClr val="tx1"/>
+        </a:solidFill>
+        <a:latin typeface="+mn-lt"/>
+        <a:ea typeface="+mn-ea"/>
+        <a:cs typeface="+mn-cs"/>
+      </a:defRPr>
+    </a:lvl1pPr>
+    <a:lvl2pPr marL="457200" algn="l" defTabSz="914400" rtl="0" eaLnBrk="1" latinLnBrk="0" hangingPunct="1">
+      <a:defRPr sz="1200" kern="1200">
+        <a:solidFill>
+          <a:schemeClr val="tx1"/>
+        </a:solidFill>
+        <a:latin typeface="+mn-lt"/>
+        <a:ea typeface="+mn-ea"/>
+        <a:cs typeface="+mn-cs"/>
+      </a:defRPr>
+    </a:lvl2pPr>
+    <a:lvl3pPr marL="914400" algn="l" defTabSz="914400" rtl="0" eaLnBrk="1" latinLnBrk="0" hangingPunct="1">
+      <a:defRPr sz="1200" kern="1200">
+        <a:solidFill>
+          <a:schemeClr val="tx1"/>
+        </a:solidFill>
+        <a:latin typeface="+mn-lt"/>
+        <a:ea typeface="+mn-ea"/>
+        <a:cs typeface="+mn-cs"/>
+      </a:defRPr>
+    </a:lvl3pPr>
+    <a:lvl4pPr marL="1371600" algn="l" defTabSz="914400" rtl="0" eaLnBrk="1" latinLnBrk="0" hangingPunct="1">
+      <a:defRPr sz="1200" kern="1200">
+        <a:solidFill>
+          <a:schemeClr val="tx1"/>
+        </a:solidFill>
+        <a:latin typeface="+mn-lt"/>
+        <a:ea typeface="+mn-ea"/>
+        <a:cs typeface="+mn-cs"/>
+      </a:defRPr>
+    </a:lvl4pPr>
+    <a:lvl5pPr marL="1828800" algn="l" defTabSz="914400" rtl="0" eaLnBrk="1" latinLnBrk="0" hangingPunct="1">
+      <a:defRPr sz="1200" kern="1200">
+        <a:solidFill>
+          <a:schemeClr val="tx1"/>
+        </a:solidFill>
+        <a:latin typeface="+mn-lt"/>
+        <a:ea typeface="+mn-ea"/>
+        <a:cs typeface="+mn-cs"/>
+      </a:defRPr>
+    </a:lvl5pPr>
+    <a:lvl6pPr marL="2286000" algn="l" defTabSz="914400" rtl="0" eaLnBrk="1" latinLnBrk="0" hangingPunct="1">
+      <a:defRPr sz="1200" kern="1200">
+        <a:solidFill>
+          <a:schemeClr val="tx1"/>
+        </a:solidFill>
+        <a:latin typeface="+mn-lt"/>
+        <a:ea typeface="+mn-ea"/>
+        <a:cs typeface="+mn-cs"/>
+      </a:defRPr>
+    </a:lvl6pPr>
+    <a:lvl7pPr marL="2743200" algn="l" defTabSz="914400" rtl="0" eaLnBrk="1" latinLnBrk="0" hangingPunct="1">
+      <a:defRPr sz="1200" kern="1200">
+        <a:solidFill>
+          <a:schemeClr val="tx1"/>
+        </a:solidFill>
+        <a:latin typeface="+mn-lt"/>
+        <a:ea typeface="+mn-ea"/>
+        <a:cs typeface="+mn-cs"/>
+      </a:defRPr>
+    </a:lvl7pPr>
+    <a:lvl8pPr marL="3200400" algn="l" defTabSz="914400" rtl="0" eaLnBrk="1" latinLnBrk="0" hangingPunct="1">
+      <a:defRPr sz="1200" kern="1200">
+        <a:solidFill>
+          <a:schemeClr val="tx1"/>
+        </a:solidFill>
+        <a:latin typeface="+mn-lt"/>
+        <a:ea typeface="+mn-ea"/>
+        <a:cs typeface="+mn-cs"/>
+      </a:defRPr>
+    </a:lvl8pPr>
+    <a:lvl9pPr marL="3657600" algn="l" defTabSz="914400" rtl="0" eaLnBrk="1" latinLnBrk="0" hangingPunct="1">
+      <a:defRPr sz="1200" kern="1200">
+        <a:solidFill>
+          <a:schemeClr val="tx1"/>
+        </a:solidFill>
+        <a:latin typeface="+mn-lt"/>
+        <a:ea typeface="+mn-ea"/>
+        <a:cs typeface="+mn-cs"/>
+      </a:defRPr>
+    </a:lvl9pPr>
+  </p:notesStyle>
+</p:notesMaster>
+</file>
+
+<file path=ppt/notesSlides/notesSlide1.xml><?xml version="1.0" encoding="utf-8"?>
+<p:notes xmlns:a="http://schemas.openxmlformats.org/drawingml/2006/main" xmlns:r="http://schemas.openxmlformats.org/officeDocument/2006/relationships" xmlns:p="http://schemas.openxmlformats.org/presentationml/2006/main">
+  <p:cSld>
+    <p:spTree>
+      <p:nvGrpSpPr>
+        <p:cNvPr id="1" name=""/>
+        <p:cNvGrpSpPr/>
+        <p:nvPr/>
+      </p:nvGrpSpPr>
+      <p:grpSpPr>
+        <a:xfrm>
+          <a:off x="0" y="0"/>
+          <a:ext cx="0" cy="0"/>
+          <a:chOff x="0" y="0"/>
+          <a:chExt cx="0" cy="0"/>
+        </a:xfrm>
+      </p:grpSpPr>
+      <p:sp>
+        <p:nvSpPr>
+          <p:cNvPr id="2" name="Plassholder for lysbilde 1"/>
+          <p:cNvSpPr>
+            <a:spLocks noGrp="1" noRot="1" noChangeAspect="1"/>
+          </p:cNvSpPr>
+          <p:nvPr>
+            <p:ph type="sldImg"/>
+          </p:nvPr>
+        </p:nvSpPr>
+        <p:spPr/>
+      </p:sp>
+      <p:sp>
+        <p:nvSpPr>
+          <p:cNvPr id="3" name="Plassholder for notater 2"/>
+          <p:cNvSpPr>
+            <a:spLocks noGrp="1"/>
+          </p:cNvSpPr>
+          <p:nvPr>
+            <p:ph type="body" idx="1"/>
+          </p:nvPr>
+        </p:nvSpPr>
+        <p:spPr/>
+        <p:txBody>
+          <a:bodyPr/>
+          <a:lstStyle/>
+          <a:p>
+            <a:r>
+              <a:rPr lang="nb-NO" dirty="0"/>
+              <a:t>Bemerk at en seriell kommunikasjonsprotokoll sender data bitvis, en og en</a:t>
+            </a:r>
+          </a:p>
+        </p:txBody>
+      </p:sp>
+      <p:sp>
+        <p:nvSpPr>
+          <p:cNvPr id="4" name="Plassholder for lysbildenummer 3"/>
+          <p:cNvSpPr>
+            <a:spLocks noGrp="1"/>
+          </p:cNvSpPr>
+          <p:nvPr>
+            <p:ph type="sldNum" sz="quarter" idx="5"/>
+          </p:nvPr>
+        </p:nvSpPr>
+        <p:spPr/>
+        <p:txBody>
+          <a:bodyPr/>
+          <a:lstStyle/>
+          <a:p>
+            <a:fld id="{56CEED96-8DE0-441C-B2ED-FF713A48F07D}" type="slidenum">
+              <a:rPr lang="nb-NO" smtClean="0"/>
+              <a:t>18</a:t>
+            </a:fld>
+            <a:endParaRPr lang="nb-NO"/>
+          </a:p>
+        </p:txBody>
+      </p:sp>
+    </p:spTree>
+    <p:extLst>
+      <p:ext uri="{BB962C8B-B14F-4D97-AF65-F5344CB8AC3E}">
+        <p14:creationId xmlns:p14="http://schemas.microsoft.com/office/powerpoint/2010/main" val="34616909"/>
+      </p:ext>
+    </p:extLst>
+  </p:cSld>
+  <p:clrMapOvr>
+    <a:masterClrMapping/>
+  </p:clrMapOvr>
+</p:notes>
+</file>
+
 <file path=ppt/slideLayouts/slideLayout1.xml><?xml version="1.0" encoding="utf-8"?>
 <p:sldLayout xmlns:a="http://schemas.openxmlformats.org/drawingml/2006/main" xmlns:r="http://schemas.openxmlformats.org/officeDocument/2006/relationships" xmlns:p="http://schemas.openxmlformats.org/presentationml/2006/main" type="title" preserve="1">
   <p:cSld name="Tittellysbilde">
@@ -272,7 +715,7 @@
           <a:p>
             <a:fld id="{B9F7994A-41AD-4027-8E6D-AD66A7C6695C}" type="datetimeFigureOut">
               <a:rPr lang="nb-NO" smtClean="0"/>
-              <a:t>13.03.2026</a:t>
+              <a:t>14.03.2026</a:t>
             </a:fld>
             <a:endParaRPr lang="nb-NO"/>
           </a:p>
@@ -470,7 +913,7 @@
           <a:p>
             <a:fld id="{B9F7994A-41AD-4027-8E6D-AD66A7C6695C}" type="datetimeFigureOut">
               <a:rPr lang="nb-NO" smtClean="0"/>
-              <a:t>13.03.2026</a:t>
+              <a:t>14.03.2026</a:t>
             </a:fld>
             <a:endParaRPr lang="nb-NO"/>
           </a:p>
@@ -678,7 +1121,7 @@
           <a:p>
             <a:fld id="{B9F7994A-41AD-4027-8E6D-AD66A7C6695C}" type="datetimeFigureOut">
               <a:rPr lang="nb-NO" smtClean="0"/>
-              <a:t>13.03.2026</a:t>
+              <a:t>14.03.2026</a:t>
             </a:fld>
             <a:endParaRPr lang="nb-NO"/>
           </a:p>
@@ -876,7 +1319,7 @@
           <a:p>
             <a:fld id="{B9F7994A-41AD-4027-8E6D-AD66A7C6695C}" type="datetimeFigureOut">
               <a:rPr lang="nb-NO" smtClean="0"/>
-              <a:t>13.03.2026</a:t>
+              <a:t>14.03.2026</a:t>
             </a:fld>
             <a:endParaRPr lang="nb-NO"/>
           </a:p>
@@ -1151,7 +1594,7 @@
           <a:p>
             <a:fld id="{B9F7994A-41AD-4027-8E6D-AD66A7C6695C}" type="datetimeFigureOut">
               <a:rPr lang="nb-NO" smtClean="0"/>
-              <a:t>13.03.2026</a:t>
+              <a:t>14.03.2026</a:t>
             </a:fld>
             <a:endParaRPr lang="nb-NO"/>
           </a:p>
@@ -1416,7 +1859,7 @@
           <a:p>
             <a:fld id="{B9F7994A-41AD-4027-8E6D-AD66A7C6695C}" type="datetimeFigureOut">
               <a:rPr lang="nb-NO" smtClean="0"/>
-              <a:t>13.03.2026</a:t>
+              <a:t>14.03.2026</a:t>
             </a:fld>
             <a:endParaRPr lang="nb-NO"/>
           </a:p>
@@ -1828,7 +2271,7 @@
           <a:p>
             <a:fld id="{B9F7994A-41AD-4027-8E6D-AD66A7C6695C}" type="datetimeFigureOut">
               <a:rPr lang="nb-NO" smtClean="0"/>
-              <a:t>13.03.2026</a:t>
+              <a:t>14.03.2026</a:t>
             </a:fld>
             <a:endParaRPr lang="nb-NO"/>
           </a:p>
@@ -1969,7 +2412,7 @@
           <a:p>
             <a:fld id="{B9F7994A-41AD-4027-8E6D-AD66A7C6695C}" type="datetimeFigureOut">
               <a:rPr lang="nb-NO" smtClean="0"/>
-              <a:t>13.03.2026</a:t>
+              <a:t>14.03.2026</a:t>
             </a:fld>
             <a:endParaRPr lang="nb-NO"/>
           </a:p>
@@ -2082,7 +2525,7 @@
           <a:p>
             <a:fld id="{B9F7994A-41AD-4027-8E6D-AD66A7C6695C}" type="datetimeFigureOut">
               <a:rPr lang="nb-NO" smtClean="0"/>
-              <a:t>13.03.2026</a:t>
+              <a:t>14.03.2026</a:t>
             </a:fld>
             <a:endParaRPr lang="nb-NO"/>
           </a:p>
@@ -2393,7 +2836,7 @@
           <a:p>
             <a:fld id="{B9F7994A-41AD-4027-8E6D-AD66A7C6695C}" type="datetimeFigureOut">
               <a:rPr lang="nb-NO" smtClean="0"/>
-              <a:t>13.03.2026</a:t>
+              <a:t>14.03.2026</a:t>
             </a:fld>
             <a:endParaRPr lang="nb-NO"/>
           </a:p>
@@ -2681,7 +3124,7 @@
           <a:p>
             <a:fld id="{B9F7994A-41AD-4027-8E6D-AD66A7C6695C}" type="datetimeFigureOut">
               <a:rPr lang="nb-NO" smtClean="0"/>
-              <a:t>13.03.2026</a:t>
+              <a:t>14.03.2026</a:t>
             </a:fld>
             <a:endParaRPr lang="nb-NO"/>
           </a:p>
@@ -2922,7 +3365,7 @@
           <a:p>
             <a:fld id="{B9F7994A-41AD-4027-8E6D-AD66A7C6695C}" type="datetimeFigureOut">
               <a:rPr lang="nb-NO" smtClean="0"/>
-              <a:t>13.03.2026</a:t>
+              <a:t>14.03.2026</a:t>
             </a:fld>
             <a:endParaRPr lang="nb-NO"/>
           </a:p>
@@ -3498,6 +3941,153 @@
   <p:cSld>
     <p:spTree>
       <p:nvGrpSpPr>
+        <p:cNvPr id="1" name=""/>
+        <p:cNvGrpSpPr/>
+        <p:nvPr/>
+      </p:nvGrpSpPr>
+      <p:grpSpPr>
+        <a:xfrm>
+          <a:off x="0" y="0"/>
+          <a:ext cx="0" cy="0"/>
+          <a:chOff x="0" y="0"/>
+          <a:chExt cx="0" cy="0"/>
+        </a:xfrm>
+      </p:grpSpPr>
+      <p:sp>
+        <p:nvSpPr>
+          <p:cNvPr id="2" name="Tittel 1">
+            <a:extLst>
+              <a:ext uri="{FF2B5EF4-FFF2-40B4-BE49-F238E27FC236}">
+                <a16:creationId xmlns:a16="http://schemas.microsoft.com/office/drawing/2014/main" id="{6287AB4D-FBC1-DE6B-F806-E6B2EC6AAF9E}"/>
+              </a:ext>
+            </a:extLst>
+          </p:cNvPr>
+          <p:cNvSpPr>
+            <a:spLocks noGrp="1"/>
+          </p:cNvSpPr>
+          <p:nvPr>
+            <p:ph type="title"/>
+          </p:nvPr>
+        </p:nvSpPr>
+        <p:spPr/>
+        <p:txBody>
+          <a:bodyPr/>
+          <a:lstStyle/>
+          <a:p>
+            <a:r>
+              <a:rPr lang="nb-NO" dirty="0"/>
+              <a:t>Konfigurering - MCC</a:t>
+            </a:r>
+          </a:p>
+        </p:txBody>
+      </p:sp>
+      <p:sp>
+        <p:nvSpPr>
+          <p:cNvPr id="3" name="Plassholder for innhold 2">
+            <a:extLst>
+              <a:ext uri="{FF2B5EF4-FFF2-40B4-BE49-F238E27FC236}">
+                <a16:creationId xmlns:a16="http://schemas.microsoft.com/office/drawing/2014/main" id="{52BBE370-2AFA-931B-E991-D2534F9AA97D}"/>
+              </a:ext>
+            </a:extLst>
+          </p:cNvPr>
+          <p:cNvSpPr>
+            <a:spLocks noGrp="1"/>
+          </p:cNvSpPr>
+          <p:nvPr>
+            <p:ph idx="1"/>
+          </p:nvPr>
+        </p:nvSpPr>
+        <p:spPr/>
+        <p:txBody>
+          <a:bodyPr/>
+          <a:lstStyle/>
+          <a:p>
+            <a:r>
+              <a:rPr lang="nb-NO" dirty="0"/>
+              <a:t>Legg til ADC som komponent</a:t>
+            </a:r>
+          </a:p>
+        </p:txBody>
+      </p:sp>
+      <p:pic>
+        <p:nvPicPr>
+          <p:cNvPr id="5" name="Bilde 4">
+            <a:extLst>
+              <a:ext uri="{FF2B5EF4-FFF2-40B4-BE49-F238E27FC236}">
+                <a16:creationId xmlns:a16="http://schemas.microsoft.com/office/drawing/2014/main" id="{E4A6B338-0160-ABCB-2C33-D032A4DDE7E1}"/>
+              </a:ext>
+            </a:extLst>
+          </p:cNvPr>
+          <p:cNvPicPr>
+            <a:picLocks noChangeAspect="1"/>
+          </p:cNvPicPr>
+          <p:nvPr/>
+        </p:nvPicPr>
+        <p:blipFill>
+          <a:blip r:embed="rId2"/>
+          <a:stretch>
+            <a:fillRect/>
+          </a:stretch>
+        </p:blipFill>
+        <p:spPr>
+          <a:xfrm>
+            <a:off x="152400" y="4922280"/>
+            <a:ext cx="9929720" cy="1905165"/>
+          </a:xfrm>
+          <a:prstGeom prst="rect">
+            <a:avLst/>
+          </a:prstGeom>
+        </p:spPr>
+      </p:pic>
+      <p:pic>
+        <p:nvPicPr>
+          <p:cNvPr id="7" name="Bilde 6">
+            <a:extLst>
+              <a:ext uri="{FF2B5EF4-FFF2-40B4-BE49-F238E27FC236}">
+                <a16:creationId xmlns:a16="http://schemas.microsoft.com/office/drawing/2014/main" id="{BB5C1C8B-1D78-0384-5D81-8A619E87EC6A}"/>
+              </a:ext>
+            </a:extLst>
+          </p:cNvPr>
+          <p:cNvPicPr>
+            <a:picLocks noChangeAspect="1"/>
+          </p:cNvPicPr>
+          <p:nvPr/>
+        </p:nvPicPr>
+        <p:blipFill>
+          <a:blip r:embed="rId3"/>
+          <a:srcRect r="39600" b="25299"/>
+          <a:stretch>
+            <a:fillRect/>
+          </a:stretch>
+        </p:blipFill>
+        <p:spPr>
+          <a:xfrm>
+            <a:off x="6096000" y="1027906"/>
+            <a:ext cx="5546488" cy="3404235"/>
+          </a:xfrm>
+          <a:prstGeom prst="rect">
+            <a:avLst/>
+          </a:prstGeom>
+        </p:spPr>
+      </p:pic>
+    </p:spTree>
+    <p:extLst>
+      <p:ext uri="{BB962C8B-B14F-4D97-AF65-F5344CB8AC3E}">
+        <p14:creationId xmlns:p14="http://schemas.microsoft.com/office/powerpoint/2010/main" val="523849282"/>
+      </p:ext>
+    </p:extLst>
+  </p:cSld>
+  <p:clrMapOvr>
+    <a:masterClrMapping/>
+  </p:clrMapOvr>
+</p:sld>
+</file>
+
+<file path=ppt/slides/slide11.xml><?xml version="1.0" encoding="utf-8"?>
+<p:sld xmlns:a="http://schemas.openxmlformats.org/drawingml/2006/main" xmlns:r="http://schemas.openxmlformats.org/officeDocument/2006/relationships" xmlns:p="http://schemas.openxmlformats.org/presentationml/2006/main">
+  <p:cSld>
+    <p:spTree>
+      <p:nvGrpSpPr>
         <p:cNvPr id="1" name="">
           <a:extLst>
             <a:ext uri="{FF2B5EF4-FFF2-40B4-BE49-F238E27FC236}">
@@ -3574,21 +4164,21 @@
             <a:pPr lvl="1"/>
             <a:r>
               <a:rPr lang="nb-NO" dirty="0"/>
-              <a:t>Hvilken pinne hver inngang går til står i </a:t>
+              <a:t>Hvilken digitalpinne hver Ain er koblet </a:t>
             </a:r>
             <a:br>
               <a:rPr lang="nb-NO" dirty="0"/>
             </a:br>
             <a:r>
               <a:rPr lang="nb-NO" dirty="0"/>
-              <a:t>databladet, og dukker opp nederst på</a:t>
+              <a:t>til dukker opp nederst på</a:t>
             </a:r>
             <a:br>
               <a:rPr lang="nb-NO" dirty="0"/>
             </a:br>
             <a:r>
               <a:rPr lang="nb-NO" dirty="0"/>
-              <a:t>skjermen</a:t>
+              <a:t>skjermen, og finnes i databladet</a:t>
             </a:r>
           </a:p>
         </p:txBody>
@@ -3636,7 +4226,7 @@
 </p:sld>
 </file>
 
-<file path=ppt/slides/slide11.xml><?xml version="1.0" encoding="utf-8"?>
+<file path=ppt/slides/slide12.xml><?xml version="1.0" encoding="utf-8"?>
 <p:sld xmlns:a="http://schemas.openxmlformats.org/drawingml/2006/main" xmlns:r="http://schemas.openxmlformats.org/officeDocument/2006/relationships" xmlns:p="http://schemas.openxmlformats.org/presentationml/2006/main">
   <p:cSld>
     <p:spTree>
@@ -3717,6 +4307,65 @@
               <a:t> og grenseverdier</a:t>
             </a:r>
           </a:p>
+          <a:p>
+            <a:pPr lvl="1">
+              <a:lnSpc>
+                <a:spcPct val="150000"/>
+              </a:lnSpc>
+            </a:pPr>
+            <a:r>
+              <a:rPr lang="nb-NO" dirty="0"/>
+              <a:t>Over nedre grenseverdi</a:t>
+            </a:r>
+          </a:p>
+          <a:p>
+            <a:pPr lvl="1">
+              <a:lnSpc>
+                <a:spcPct val="150000"/>
+              </a:lnSpc>
+            </a:pPr>
+            <a:r>
+              <a:rPr lang="nb-NO" dirty="0"/>
+              <a:t>Under øvre grenseverdi</a:t>
+            </a:r>
+          </a:p>
+          <a:p>
+            <a:pPr lvl="1">
+              <a:lnSpc>
+                <a:spcPct val="150000"/>
+              </a:lnSpc>
+            </a:pPr>
+            <a:r>
+              <a:rPr lang="nb-NO" dirty="0"/>
+              <a:t>Mellom grenseverdiene</a:t>
+            </a:r>
+          </a:p>
+          <a:p>
+            <a:pPr lvl="1">
+              <a:lnSpc>
+                <a:spcPct val="100000"/>
+              </a:lnSpc>
+            </a:pPr>
+            <a:r>
+              <a:rPr lang="nb-NO" dirty="0"/>
+              <a:t>Større enn øvre eller</a:t>
+            </a:r>
+            <a:br>
+              <a:rPr lang="nb-NO" dirty="0"/>
+            </a:br>
+            <a:r>
+              <a:rPr lang="nb-NO" dirty="0"/>
+              <a:t>mindre enn </a:t>
+            </a:r>
+            <a:r>
+              <a:rPr lang="nb-NO" dirty="0" err="1"/>
+              <a:t>lavre</a:t>
+            </a:r>
+            <a:r>
+              <a:rPr lang="nb-NO" dirty="0"/>
+              <a:t> grenseverdi</a:t>
+            </a:r>
+          </a:p>
         </p:txBody>
       </p:sp>
       <p:pic>
@@ -3741,7 +4390,7 @@
         </p:blipFill>
         <p:spPr>
           <a:xfrm>
-            <a:off x="5669281" y="1308000"/>
+            <a:off x="5688946" y="1825625"/>
             <a:ext cx="6156960" cy="4242000"/>
           </a:xfrm>
           <a:prstGeom prst="rect">
@@ -3762,7 +4411,7 @@
 </p:sld>
 </file>
 
-<file path=ppt/slides/slide12.xml><?xml version="1.0" encoding="utf-8"?>
+<file path=ppt/slides/slide13.xml><?xml version="1.0" encoding="utf-8"?>
 <p:sld xmlns:a="http://schemas.openxmlformats.org/drawingml/2006/main" xmlns:r="http://schemas.openxmlformats.org/officeDocument/2006/relationships" xmlns:p="http://schemas.openxmlformats.org/presentationml/2006/main">
   <p:cSld>
     <p:spTree>
@@ -3848,22 +4497,14 @@
             <a:pPr lvl="1"/>
             <a:r>
               <a:rPr lang="nb-NO" dirty="0"/>
-              <a:t>Justerer over hvor lang </a:t>
+              <a:t>Justerer hvor raskt </a:t>
             </a:r>
             <a:br>
               <a:rPr lang="nb-NO" dirty="0"/>
             </a:br>
             <a:r>
               <a:rPr lang="nb-NO" dirty="0"/>
-              <a:t>tid </a:t>
-            </a:r>
-            <a:r>
-              <a:rPr lang="nb-NO" dirty="0" err="1"/>
-              <a:t>ADCen</a:t>
-            </a:r>
-            <a:r>
-              <a:rPr lang="nb-NO" dirty="0"/>
-              <a:t> måler</a:t>
+              <a:t>målingen utføres</a:t>
             </a:r>
           </a:p>
         </p:txBody>
@@ -3911,92 +4552,6 @@
 </p:sld>
 </file>
 
-<file path=ppt/slides/slide13.xml><?xml version="1.0" encoding="utf-8"?>
-<p:sld xmlns:a="http://schemas.openxmlformats.org/drawingml/2006/main" xmlns:r="http://schemas.openxmlformats.org/officeDocument/2006/relationships" xmlns:p="http://schemas.openxmlformats.org/presentationml/2006/main">
-  <p:cSld>
-    <p:spTree>
-      <p:nvGrpSpPr>
-        <p:cNvPr id="1" name=""/>
-        <p:cNvGrpSpPr/>
-        <p:nvPr/>
-      </p:nvGrpSpPr>
-      <p:grpSpPr>
-        <a:xfrm>
-          <a:off x="0" y="0"/>
-          <a:ext cx="0" cy="0"/>
-          <a:chOff x="0" y="0"/>
-          <a:chExt cx="0" cy="0"/>
-        </a:xfrm>
-      </p:grpSpPr>
-      <p:sp>
-        <p:nvSpPr>
-          <p:cNvPr id="2" name="Tittel 1">
-            <a:extLst>
-              <a:ext uri="{FF2B5EF4-FFF2-40B4-BE49-F238E27FC236}">
-                <a16:creationId xmlns:a16="http://schemas.microsoft.com/office/drawing/2014/main" id="{E3CC2766-9F34-9AE6-7CF7-9524B9CDC5BD}"/>
-              </a:ext>
-            </a:extLst>
-          </p:cNvPr>
-          <p:cNvSpPr>
-            <a:spLocks noGrp="1"/>
-          </p:cNvSpPr>
-          <p:nvPr>
-            <p:ph type="title"/>
-          </p:nvPr>
-        </p:nvSpPr>
-        <p:spPr/>
-        <p:txBody>
-          <a:bodyPr/>
-          <a:lstStyle/>
-          <a:p>
-            <a:r>
-              <a:rPr lang="nb-NO" dirty="0"/>
-              <a:t>Kode</a:t>
-            </a:r>
-          </a:p>
-        </p:txBody>
-      </p:sp>
-      <p:sp>
-        <p:nvSpPr>
-          <p:cNvPr id="3" name="Plassholder for innhold 2">
-            <a:extLst>
-              <a:ext uri="{FF2B5EF4-FFF2-40B4-BE49-F238E27FC236}">
-                <a16:creationId xmlns:a16="http://schemas.microsoft.com/office/drawing/2014/main" id="{6299A0F9-3095-6AB3-BFBE-EF5513911279}"/>
-              </a:ext>
-            </a:extLst>
-          </p:cNvPr>
-          <p:cNvSpPr>
-            <a:spLocks noGrp="1"/>
-          </p:cNvSpPr>
-          <p:nvPr>
-            <p:ph idx="1"/>
-          </p:nvPr>
-        </p:nvSpPr>
-        <p:spPr/>
-        <p:txBody>
-          <a:bodyPr/>
-          <a:lstStyle/>
-          <a:p>
-            <a:r>
-              <a:rPr lang="nb-NO" dirty="0"/>
-              <a:t>Viktig kode her</a:t>
-            </a:r>
-          </a:p>
-        </p:txBody>
-      </p:sp>
-    </p:spTree>
-    <p:extLst>
-      <p:ext uri="{BB962C8B-B14F-4D97-AF65-F5344CB8AC3E}">
-        <p14:creationId xmlns:p14="http://schemas.microsoft.com/office/powerpoint/2010/main" val="104226834"/>
-      </p:ext>
-    </p:extLst>
-  </p:cSld>
-  <p:clrMapOvr>
-    <a:masterClrMapping/>
-  </p:clrMapOvr>
-</p:sld>
-</file>
-
 <file path=ppt/slides/slide14.xml><?xml version="1.0" encoding="utf-8"?>
 <p:sld xmlns:a="http://schemas.openxmlformats.org/drawingml/2006/main" xmlns:r="http://schemas.openxmlformats.org/officeDocument/2006/relationships" xmlns:p="http://schemas.openxmlformats.org/presentationml/2006/main">
   <p:cSld>
@@ -4019,6 +4574,122 @@
           <p:cNvPr id="2" name="Tittel 1">
             <a:extLst>
               <a:ext uri="{FF2B5EF4-FFF2-40B4-BE49-F238E27FC236}">
+                <a16:creationId xmlns:a16="http://schemas.microsoft.com/office/drawing/2014/main" id="{E3CC2766-9F34-9AE6-7CF7-9524B9CDC5BD}"/>
+              </a:ext>
+            </a:extLst>
+          </p:cNvPr>
+          <p:cNvSpPr>
+            <a:spLocks noGrp="1"/>
+          </p:cNvSpPr>
+          <p:nvPr>
+            <p:ph type="title"/>
+          </p:nvPr>
+        </p:nvSpPr>
+        <p:spPr/>
+        <p:txBody>
+          <a:bodyPr/>
+          <a:lstStyle/>
+          <a:p>
+            <a:r>
+              <a:rPr lang="nb-NO" dirty="0"/>
+              <a:t>Kode</a:t>
+            </a:r>
+          </a:p>
+        </p:txBody>
+      </p:sp>
+      <p:sp>
+        <p:nvSpPr>
+          <p:cNvPr id="3" name="Plassholder for innhold 2">
+            <a:extLst>
+              <a:ext uri="{FF2B5EF4-FFF2-40B4-BE49-F238E27FC236}">
+                <a16:creationId xmlns:a16="http://schemas.microsoft.com/office/drawing/2014/main" id="{6299A0F9-3095-6AB3-BFBE-EF5513911279}"/>
+              </a:ext>
+            </a:extLst>
+          </p:cNvPr>
+          <p:cNvSpPr>
+            <a:spLocks noGrp="1"/>
+          </p:cNvSpPr>
+          <p:nvPr>
+            <p:ph idx="1"/>
+          </p:nvPr>
+        </p:nvSpPr>
+        <p:spPr/>
+        <p:txBody>
+          <a:bodyPr/>
+          <a:lstStyle/>
+          <a:p>
+            <a:r>
+              <a:rPr lang="nb-NO" dirty="0"/>
+              <a:t>MCC genererte funksjoner</a:t>
+            </a:r>
+          </a:p>
+        </p:txBody>
+      </p:sp>
+      <p:pic>
+        <p:nvPicPr>
+          <p:cNvPr id="5" name="Bilde 4">
+            <a:extLst>
+              <a:ext uri="{FF2B5EF4-FFF2-40B4-BE49-F238E27FC236}">
+                <a16:creationId xmlns:a16="http://schemas.microsoft.com/office/drawing/2014/main" id="{D83505C7-A04A-3A53-B569-2EFC0CA1EEFC}"/>
+              </a:ext>
+            </a:extLst>
+          </p:cNvPr>
+          <p:cNvPicPr>
+            <a:picLocks noChangeAspect="1"/>
+          </p:cNvPicPr>
+          <p:nvPr/>
+        </p:nvPicPr>
+        <p:blipFill>
+          <a:blip r:embed="rId2"/>
+          <a:stretch>
+            <a:fillRect/>
+          </a:stretch>
+        </p:blipFill>
+        <p:spPr>
+          <a:xfrm>
+            <a:off x="732676" y="2772397"/>
+            <a:ext cx="10726647" cy="2457793"/>
+          </a:xfrm>
+          <a:prstGeom prst="rect">
+            <a:avLst/>
+          </a:prstGeom>
+        </p:spPr>
+      </p:pic>
+    </p:spTree>
+    <p:extLst>
+      <p:ext uri="{BB962C8B-B14F-4D97-AF65-F5344CB8AC3E}">
+        <p14:creationId xmlns:p14="http://schemas.microsoft.com/office/powerpoint/2010/main" val="104226834"/>
+      </p:ext>
+    </p:extLst>
+  </p:cSld>
+  <p:clrMapOvr>
+    <a:masterClrMapping/>
+  </p:clrMapOvr>
+</p:sld>
+</file>
+
+<file path=ppt/slides/slide15.xml><?xml version="1.0" encoding="utf-8"?>
+<p:sld xmlns:a="http://schemas.openxmlformats.org/drawingml/2006/main" xmlns:r="http://schemas.openxmlformats.org/officeDocument/2006/relationships" xmlns:p="http://schemas.openxmlformats.org/presentationml/2006/main">
+  <p:cSld>
+    <p:spTree>
+      <p:nvGrpSpPr>
+        <p:cNvPr id="1" name=""/>
+        <p:cNvGrpSpPr/>
+        <p:nvPr/>
+      </p:nvGrpSpPr>
+      <p:grpSpPr>
+        <a:xfrm>
+          <a:off x="0" y="0"/>
+          <a:ext cx="0" cy="0"/>
+          <a:chOff x="0" y="0"/>
+          <a:chExt cx="0" cy="0"/>
+        </a:xfrm>
+      </p:grpSpPr>
+      <p:sp>
+        <p:nvSpPr>
+          <p:cNvPr id="2" name="Tittel 1">
+            <a:extLst>
+              <a:ext uri="{FF2B5EF4-FFF2-40B4-BE49-F238E27FC236}">
                 <a16:creationId xmlns:a16="http://schemas.microsoft.com/office/drawing/2014/main" id="{56A8F48D-AD2E-A23C-9842-E1B1A67318DA}"/>
               </a:ext>
             </a:extLst>
@@ -4037,7 +4708,7 @@
           <a:p>
             <a:r>
               <a:rPr lang="nb-NO" dirty="0"/>
-              <a:t>Teller</a:t>
+              <a:t>Teller/Timer</a:t>
             </a:r>
           </a:p>
         </p:txBody>
@@ -4072,6 +4743,38 @@
             <a:r>
               <a:rPr lang="nb-NO" dirty="0"/>
               <a:t>Vi fokuserer på type A (TCA0 og TCA1)</a:t>
+            </a:r>
+          </a:p>
+          <a:p>
+            <a:r>
+              <a:rPr lang="nb-NO" dirty="0"/>
+              <a:t>I16-biters register</a:t>
+            </a:r>
+          </a:p>
+          <a:p>
+            <a:pPr lvl="1"/>
+            <a:r>
+              <a:rPr lang="nb-NO" dirty="0"/>
+              <a:t>Kan deles i to 8-bit tellere</a:t>
+            </a:r>
+          </a:p>
+          <a:p>
+            <a:r>
+              <a:rPr lang="nb-NO" dirty="0"/>
+              <a:t>Verdien økes med 1 ved gitte</a:t>
+            </a:r>
+            <a:br>
+              <a:rPr lang="nb-NO" dirty="0"/>
+            </a:br>
+            <a:r>
+              <a:rPr lang="nb-NO" dirty="0"/>
+              <a:t>tilfeller </a:t>
+            </a:r>
+          </a:p>
+          <a:p>
+            <a:r>
+              <a:rPr lang="nb-NO" dirty="0"/>
+              <a:t>Tellerverdien kan leses av manuelt, eller automatikk kan gjennomføres når den når visse verdier</a:t>
             </a:r>
           </a:p>
         </p:txBody>
@@ -4090,7 +4793,7 @@
         </p:nvGrpSpPr>
         <p:grpSpPr>
           <a:xfrm>
-            <a:off x="4545206" y="2917682"/>
+            <a:off x="5647600" y="2853932"/>
             <a:ext cx="6308426" cy="1390157"/>
             <a:chOff x="5491868" y="2409683"/>
             <a:chExt cx="4625587" cy="1019318"/>
@@ -4171,6 +4874,427 @@
 </p:sld>
 </file>
 
+<file path=ppt/slides/slide16.xml><?xml version="1.0" encoding="utf-8"?>
+<p:sld xmlns:a="http://schemas.openxmlformats.org/drawingml/2006/main" xmlns:r="http://schemas.openxmlformats.org/officeDocument/2006/relationships" xmlns:p="http://schemas.openxmlformats.org/presentationml/2006/main">
+  <p:cSld>
+    <p:spTree>
+      <p:nvGrpSpPr>
+        <p:cNvPr id="1" name=""/>
+        <p:cNvGrpSpPr/>
+        <p:nvPr/>
+      </p:nvGrpSpPr>
+      <p:grpSpPr>
+        <a:xfrm>
+          <a:off x="0" y="0"/>
+          <a:ext cx="0" cy="0"/>
+          <a:chOff x="0" y="0"/>
+          <a:chExt cx="0" cy="0"/>
+        </a:xfrm>
+      </p:grpSpPr>
+      <p:sp>
+        <p:nvSpPr>
+          <p:cNvPr id="2" name="Tittel 1">
+            <a:extLst>
+              <a:ext uri="{FF2B5EF4-FFF2-40B4-BE49-F238E27FC236}">
+                <a16:creationId xmlns:a16="http://schemas.microsoft.com/office/drawing/2014/main" id="{166B4FD7-2B0F-EF85-8C22-D719CF0B97B7}"/>
+              </a:ext>
+            </a:extLst>
+          </p:cNvPr>
+          <p:cNvSpPr>
+            <a:spLocks noGrp="1"/>
+          </p:cNvSpPr>
+          <p:nvPr>
+            <p:ph type="title"/>
+          </p:nvPr>
+        </p:nvSpPr>
+        <p:spPr/>
+        <p:txBody>
+          <a:bodyPr/>
+          <a:lstStyle/>
+          <a:p>
+            <a:r>
+              <a:rPr lang="nb-NO" dirty="0"/>
+              <a:t>Teller</a:t>
+            </a:r>
+          </a:p>
+        </p:txBody>
+      </p:sp>
+      <p:sp>
+        <p:nvSpPr>
+          <p:cNvPr id="3" name="Plassholder for innhold 2">
+            <a:extLst>
+              <a:ext uri="{FF2B5EF4-FFF2-40B4-BE49-F238E27FC236}">
+                <a16:creationId xmlns:a16="http://schemas.microsoft.com/office/drawing/2014/main" id="{C659E690-B089-6306-B129-9385C388F676}"/>
+              </a:ext>
+            </a:extLst>
+          </p:cNvPr>
+          <p:cNvSpPr>
+            <a:spLocks noGrp="1"/>
+          </p:cNvSpPr>
+          <p:nvPr>
+            <p:ph idx="1"/>
+          </p:nvPr>
+        </p:nvSpPr>
+        <p:spPr/>
+        <p:txBody>
+          <a:bodyPr/>
+          <a:lstStyle/>
+          <a:p>
+            <a:r>
+              <a:rPr lang="nb-NO" dirty="0"/>
+              <a:t>Betegnes som regel når registeret øker verdi ved gitte hendelser</a:t>
+            </a:r>
+          </a:p>
+          <a:p>
+            <a:r>
+              <a:rPr lang="nb-NO" dirty="0"/>
+              <a:t>Konfigureres gjennom </a:t>
+            </a:r>
+            <a:r>
+              <a:rPr lang="nb-NO" dirty="0" err="1"/>
+              <a:t>eventsystem</a:t>
+            </a:r>
+            <a:endParaRPr lang="nb-NO" dirty="0"/>
+          </a:p>
+          <a:p>
+            <a:endParaRPr lang="nb-NO" dirty="0"/>
+          </a:p>
+          <a:p>
+            <a:r>
+              <a:rPr lang="nb-NO" dirty="0"/>
+              <a:t>Eks. </a:t>
+            </a:r>
+          </a:p>
+          <a:p>
+            <a:pPr lvl="1"/>
+            <a:r>
+              <a:rPr lang="nb-NO" dirty="0"/>
+              <a:t>Tell antall knappetrykk og utfør kommando når det passerer 20</a:t>
+            </a:r>
+          </a:p>
+        </p:txBody>
+      </p:sp>
+    </p:spTree>
+    <p:extLst>
+      <p:ext uri="{BB962C8B-B14F-4D97-AF65-F5344CB8AC3E}">
+        <p14:creationId xmlns:p14="http://schemas.microsoft.com/office/powerpoint/2010/main" val="960884609"/>
+      </p:ext>
+    </p:extLst>
+  </p:cSld>
+  <p:clrMapOvr>
+    <a:masterClrMapping/>
+  </p:clrMapOvr>
+</p:sld>
+</file>
+
+<file path=ppt/slides/slide17.xml><?xml version="1.0" encoding="utf-8"?>
+<p:sld xmlns:a="http://schemas.openxmlformats.org/drawingml/2006/main" xmlns:r="http://schemas.openxmlformats.org/officeDocument/2006/relationships" xmlns:p="http://schemas.openxmlformats.org/presentationml/2006/main">
+  <p:cSld>
+    <p:spTree>
+      <p:nvGrpSpPr>
+        <p:cNvPr id="1" name=""/>
+        <p:cNvGrpSpPr/>
+        <p:nvPr/>
+      </p:nvGrpSpPr>
+      <p:grpSpPr>
+        <a:xfrm>
+          <a:off x="0" y="0"/>
+          <a:ext cx="0" cy="0"/>
+          <a:chOff x="0" y="0"/>
+          <a:chExt cx="0" cy="0"/>
+        </a:xfrm>
+      </p:grpSpPr>
+      <p:sp>
+        <p:nvSpPr>
+          <p:cNvPr id="2" name="Tittel 1">
+            <a:extLst>
+              <a:ext uri="{FF2B5EF4-FFF2-40B4-BE49-F238E27FC236}">
+                <a16:creationId xmlns:a16="http://schemas.microsoft.com/office/drawing/2014/main" id="{1D94A9E1-E6D9-1388-EE9E-B3052F57975C}"/>
+              </a:ext>
+            </a:extLst>
+          </p:cNvPr>
+          <p:cNvSpPr>
+            <a:spLocks noGrp="1"/>
+          </p:cNvSpPr>
+          <p:nvPr>
+            <p:ph type="title"/>
+          </p:nvPr>
+        </p:nvSpPr>
+        <p:spPr/>
+        <p:txBody>
+          <a:bodyPr/>
+          <a:lstStyle/>
+          <a:p>
+            <a:r>
+              <a:rPr lang="nb-NO" dirty="0"/>
+              <a:t>Timer – Denne er litt lang, bør deles, fler bilder</a:t>
+            </a:r>
+          </a:p>
+        </p:txBody>
+      </p:sp>
+      <p:sp>
+        <p:nvSpPr>
+          <p:cNvPr id="3" name="Plassholder for innhold 2">
+            <a:extLst>
+              <a:ext uri="{FF2B5EF4-FFF2-40B4-BE49-F238E27FC236}">
+                <a16:creationId xmlns:a16="http://schemas.microsoft.com/office/drawing/2014/main" id="{ED7B5FE9-127F-6C1B-B4CA-508C3446EC21}"/>
+              </a:ext>
+            </a:extLst>
+          </p:cNvPr>
+          <p:cNvSpPr>
+            <a:spLocks noGrp="1"/>
+          </p:cNvSpPr>
+          <p:nvPr>
+            <p:ph idx="1"/>
+          </p:nvPr>
+        </p:nvSpPr>
+        <p:spPr/>
+        <p:txBody>
+          <a:bodyPr/>
+          <a:lstStyle/>
+          <a:p>
+            <a:r>
+              <a:rPr lang="nb-NO" dirty="0"/>
+              <a:t>Teller oppover per </a:t>
+            </a:r>
+            <a:r>
+              <a:rPr lang="nb-NO" i="1" dirty="0"/>
+              <a:t>n</a:t>
+            </a:r>
+            <a:r>
+              <a:rPr lang="nb-NO" dirty="0"/>
+              <a:t> antall klokkeslag</a:t>
+            </a:r>
+          </a:p>
+          <a:p>
+            <a:r>
+              <a:rPr lang="nb-NO" dirty="0"/>
+              <a:t>Egen klokke, skjer automatisk</a:t>
+            </a:r>
+          </a:p>
+          <a:p>
+            <a:r>
+              <a:rPr lang="nb-NO" i="1" dirty="0"/>
+              <a:t>n </a:t>
+            </a:r>
+            <a:r>
+              <a:rPr lang="nb-NO" dirty="0"/>
+              <a:t>gis av </a:t>
+            </a:r>
+            <a:r>
+              <a:rPr lang="nb-NO" dirty="0" err="1"/>
+              <a:t>prescaler</a:t>
+            </a:r>
+            <a:r>
+              <a:rPr lang="nb-NO" dirty="0"/>
+              <a:t>, hvor mange ganger skal klokkesignalet </a:t>
+            </a:r>
+            <a:r>
+              <a:rPr lang="nb-NO" dirty="0" err="1"/>
+              <a:t>halvveres</a:t>
+            </a:r>
+            <a:endParaRPr lang="nb-NO" dirty="0"/>
+          </a:p>
+          <a:p>
+            <a:pPr lvl="1"/>
+            <a:r>
+              <a:rPr lang="nb-NO" i="1" dirty="0"/>
+              <a:t>n = </a:t>
+            </a:r>
+            <a:r>
+              <a:rPr lang="nb-NO" dirty="0"/>
+              <a:t>2, 4, 8, 16, 32…</a:t>
+            </a:r>
+          </a:p>
+          <a:p>
+            <a:r>
+              <a:rPr lang="nb-NO" dirty="0"/>
+              <a:t>Lengre periode, lavere oppløsning</a:t>
+            </a:r>
+          </a:p>
+          <a:p>
+            <a:r>
+              <a:rPr lang="nb-NO" dirty="0"/>
+              <a:t>Flere </a:t>
+            </a:r>
+            <a:r>
+              <a:rPr lang="nb-NO" dirty="0" err="1"/>
+              <a:t>interrupts</a:t>
+            </a:r>
+            <a:r>
+              <a:rPr lang="nb-NO" dirty="0"/>
+              <a:t>, utføring av kommandoer med presis </a:t>
+            </a:r>
+          </a:p>
+        </p:txBody>
+      </p:sp>
+    </p:spTree>
+    <p:extLst>
+      <p:ext uri="{BB962C8B-B14F-4D97-AF65-F5344CB8AC3E}">
+        <p14:creationId xmlns:p14="http://schemas.microsoft.com/office/powerpoint/2010/main" val="1897542684"/>
+      </p:ext>
+    </p:extLst>
+  </p:cSld>
+  <p:clrMapOvr>
+    <a:masterClrMapping/>
+  </p:clrMapOvr>
+</p:sld>
+</file>
+
+<file path=ppt/slides/slide18.xml><?xml version="1.0" encoding="utf-8"?>
+<p:sld xmlns:a="http://schemas.openxmlformats.org/drawingml/2006/main" xmlns:r="http://schemas.openxmlformats.org/officeDocument/2006/relationships" xmlns:p="http://schemas.openxmlformats.org/presentationml/2006/main">
+  <p:cSld>
+    <p:spTree>
+      <p:nvGrpSpPr>
+        <p:cNvPr id="1" name=""/>
+        <p:cNvGrpSpPr/>
+        <p:nvPr/>
+      </p:nvGrpSpPr>
+      <p:grpSpPr>
+        <a:xfrm>
+          <a:off x="0" y="0"/>
+          <a:ext cx="0" cy="0"/>
+          <a:chOff x="0" y="0"/>
+          <a:chExt cx="0" cy="0"/>
+        </a:xfrm>
+      </p:grpSpPr>
+      <p:sp>
+        <p:nvSpPr>
+          <p:cNvPr id="2" name="Tittel 1">
+            <a:extLst>
+              <a:ext uri="{FF2B5EF4-FFF2-40B4-BE49-F238E27FC236}">
+                <a16:creationId xmlns:a16="http://schemas.microsoft.com/office/drawing/2014/main" id="{89114275-8F53-5A5B-0B26-723B5F426A45}"/>
+              </a:ext>
+            </a:extLst>
+          </p:cNvPr>
+          <p:cNvSpPr>
+            <a:spLocks noGrp="1"/>
+          </p:cNvSpPr>
+          <p:nvPr>
+            <p:ph type="title"/>
+          </p:nvPr>
+        </p:nvSpPr>
+        <p:spPr/>
+        <p:txBody>
+          <a:bodyPr/>
+          <a:lstStyle/>
+          <a:p>
+            <a:r>
+              <a:rPr lang="nb-NO" dirty="0"/>
+              <a:t>USART/UART</a:t>
+            </a:r>
+          </a:p>
+        </p:txBody>
+      </p:sp>
+      <p:sp>
+        <p:nvSpPr>
+          <p:cNvPr id="3" name="Plassholder for innhold 2">
+            <a:extLst>
+              <a:ext uri="{FF2B5EF4-FFF2-40B4-BE49-F238E27FC236}">
+                <a16:creationId xmlns:a16="http://schemas.microsoft.com/office/drawing/2014/main" id="{3D304FCB-FCE3-5BD9-D7F2-4E5117B9370A}"/>
+              </a:ext>
+            </a:extLst>
+          </p:cNvPr>
+          <p:cNvSpPr>
+            <a:spLocks noGrp="1"/>
+          </p:cNvSpPr>
+          <p:nvPr>
+            <p:ph idx="1"/>
+          </p:nvPr>
+        </p:nvSpPr>
+        <p:spPr/>
+        <p:txBody>
+          <a:bodyPr/>
+          <a:lstStyle/>
+          <a:p>
+            <a:r>
+              <a:rPr lang="nb-NO" dirty="0"/>
+              <a:t>Universal (</a:t>
+            </a:r>
+            <a:r>
+              <a:rPr lang="nb-NO" dirty="0" err="1"/>
+              <a:t>Synchronous</a:t>
+            </a:r>
+            <a:r>
+              <a:rPr lang="nb-NO" dirty="0"/>
+              <a:t>/)</a:t>
+            </a:r>
+            <a:r>
+              <a:rPr lang="nb-NO" dirty="0" err="1"/>
+              <a:t>Asynchronous</a:t>
+            </a:r>
+            <a:r>
+              <a:rPr lang="nb-NO" dirty="0"/>
+              <a:t> </a:t>
+            </a:r>
+            <a:r>
+              <a:rPr lang="nb-NO" dirty="0" err="1"/>
+              <a:t>Reciever</a:t>
+            </a:r>
+            <a:r>
+              <a:rPr lang="nb-NO" dirty="0"/>
+              <a:t>-Transmitter</a:t>
+            </a:r>
+          </a:p>
+          <a:p>
+            <a:r>
+              <a:rPr lang="nb-NO" dirty="0"/>
+              <a:t>Seriell kommunikasjonsprotokoll</a:t>
+            </a:r>
+          </a:p>
+          <a:p>
+            <a:r>
+              <a:rPr lang="nb-NO" dirty="0"/>
+              <a:t>Rx og </a:t>
+            </a:r>
+            <a:r>
+              <a:rPr lang="nb-NO" dirty="0" err="1"/>
+              <a:t>Tx</a:t>
+            </a:r>
+            <a:r>
+              <a:rPr lang="nb-NO" dirty="0"/>
+              <a:t> (Full Duplex) eller én leder(Halv Duplex)</a:t>
+            </a:r>
+          </a:p>
+          <a:p>
+            <a:r>
+              <a:rPr lang="nb-NO" dirty="0"/>
+              <a:t>Forhåndsgitt baud</a:t>
+            </a:r>
+          </a:p>
+          <a:p>
+            <a:pPr lvl="1"/>
+            <a:r>
+              <a:rPr lang="nb-NO" dirty="0"/>
+              <a:t>Baud = bits/sekund</a:t>
+            </a:r>
+          </a:p>
+          <a:p>
+            <a:pPr lvl="1"/>
+            <a:endParaRPr lang="nb-NO" dirty="0"/>
+          </a:p>
+          <a:p>
+            <a:r>
+              <a:rPr lang="nb-NO"/>
+              <a:t>Sende informasjon til </a:t>
+            </a:r>
+            <a:endParaRPr lang="nb-NO" dirty="0"/>
+          </a:p>
+        </p:txBody>
+      </p:sp>
+    </p:spTree>
+    <p:extLst>
+      <p:ext uri="{BB962C8B-B14F-4D97-AF65-F5344CB8AC3E}">
+        <p14:creationId xmlns:p14="http://schemas.microsoft.com/office/powerpoint/2010/main" val="979311525"/>
+      </p:ext>
+    </p:extLst>
+  </p:cSld>
+  <p:clrMapOvr>
+    <a:masterClrMapping/>
+  </p:clrMapOvr>
+</p:sld>
+</file>
+
 <file path=ppt/slides/slide2.xml><?xml version="1.0" encoding="utf-8"?>
 <p:sld xmlns:a="http://schemas.openxmlformats.org/drawingml/2006/main" xmlns:r="http://schemas.openxmlformats.org/officeDocument/2006/relationships" xmlns:p="http://schemas.openxmlformats.org/presentationml/2006/main">
   <p:cSld>
@@ -4561,6 +5685,12 @@
           </a:p>
           <a:p>
             <a:r>
+              <a:rPr lang="nb-NO" dirty="0"/>
+              <a:t>Tilsvarer en dedikert adresse i minnet</a:t>
+            </a:r>
+          </a:p>
+          <a:p>
+            <a:r>
               <a:rPr lang="nb-NO" i="1" dirty="0" err="1">
                 <a:solidFill>
                   <a:schemeClr val="bg1">
@@ -4599,45 +5729,28 @@
               <a:rPr lang="nb-NO" dirty="0"/>
               <a:t>Vektornavn finnes i beskrivelsen for hver </a:t>
             </a:r>
-          </a:p>
-          <a:p>
+            <a:br>
+              <a:rPr lang="nb-NO" dirty="0"/>
+            </a:br>
             <a:r>
               <a:rPr lang="nb-NO" dirty="0"/>
               <a:t>periferienhet</a:t>
             </a:r>
           </a:p>
-        </p:txBody>
-      </p:sp>
-      <p:pic>
-        <p:nvPicPr>
-          <p:cNvPr id="5" name="Bilde 4">
-            <a:extLst>
-              <a:ext uri="{FF2B5EF4-FFF2-40B4-BE49-F238E27FC236}">
-                <a16:creationId xmlns:a16="http://schemas.microsoft.com/office/drawing/2014/main" id="{8B62ABFA-0191-C477-7E00-6328B5501D75}"/>
-              </a:ext>
-            </a:extLst>
-          </p:cNvPr>
-          <p:cNvPicPr>
-            <a:picLocks noChangeAspect="1"/>
-          </p:cNvPicPr>
-          <p:nvPr/>
-        </p:nvPicPr>
-        <p:blipFill>
-          <a:blip r:embed="rId2"/>
-          <a:stretch>
-            <a:fillRect/>
-          </a:stretch>
-        </p:blipFill>
-        <p:spPr>
-          <a:xfrm>
-            <a:off x="7300919" y="3425397"/>
-            <a:ext cx="4315427" cy="3067478"/>
-          </a:xfrm>
-          <a:prstGeom prst="rect">
-            <a:avLst/>
-          </a:prstGeom>
-        </p:spPr>
-      </p:pic>
+          <a:p>
+            <a:pPr marL="0" indent="0">
+              <a:buNone/>
+            </a:pPr>
+            <a:endParaRPr lang="nb-NO" dirty="0"/>
+          </a:p>
+          <a:p>
+            <a:r>
+              <a:rPr lang="nb-NO" dirty="0"/>
+              <a:t>Funksjoner bør være korte, «flagg» kan vurderes</a:t>
+            </a:r>
+          </a:p>
+        </p:txBody>
+      </p:sp>
     </p:spTree>
     <p:extLst>
       <p:ext uri="{BB962C8B-B14F-4D97-AF65-F5344CB8AC3E}">
@@ -4652,6 +5765,183 @@
 </file>
 
 <file path=ppt/slides/slide5.xml><?xml version="1.0" encoding="utf-8"?>
+<p:sld xmlns:a="http://schemas.openxmlformats.org/drawingml/2006/main" xmlns:r="http://schemas.openxmlformats.org/officeDocument/2006/relationships" xmlns:p="http://schemas.openxmlformats.org/presentationml/2006/main">
+  <p:cSld>
+    <p:spTree>
+      <p:nvGrpSpPr>
+        <p:cNvPr id="1" name=""/>
+        <p:cNvGrpSpPr/>
+        <p:nvPr/>
+      </p:nvGrpSpPr>
+      <p:grpSpPr>
+        <a:xfrm>
+          <a:off x="0" y="0"/>
+          <a:ext cx="0" cy="0"/>
+          <a:chOff x="0" y="0"/>
+          <a:chExt cx="0" cy="0"/>
+        </a:xfrm>
+      </p:grpSpPr>
+      <p:sp>
+        <p:nvSpPr>
+          <p:cNvPr id="2" name="Tittel 1">
+            <a:extLst>
+              <a:ext uri="{FF2B5EF4-FFF2-40B4-BE49-F238E27FC236}">
+                <a16:creationId xmlns:a16="http://schemas.microsoft.com/office/drawing/2014/main" id="{89E49625-2BD4-EF7C-25A6-43EEDDBE740A}"/>
+              </a:ext>
+            </a:extLst>
+          </p:cNvPr>
+          <p:cNvSpPr>
+            <a:spLocks noGrp="1"/>
+          </p:cNvSpPr>
+          <p:nvPr>
+            <p:ph type="title"/>
+          </p:nvPr>
+        </p:nvSpPr>
+        <p:spPr/>
+        <p:txBody>
+          <a:bodyPr/>
+          <a:lstStyle/>
+          <a:p>
+            <a:r>
+              <a:rPr lang="nb-NO" dirty="0" err="1"/>
+              <a:t>Interrupt</a:t>
+            </a:r>
+            <a:r>
+              <a:rPr lang="nb-NO" dirty="0"/>
+              <a:t> vektor – Eksempel</a:t>
+            </a:r>
+          </a:p>
+        </p:txBody>
+      </p:sp>
+      <p:sp>
+        <p:nvSpPr>
+          <p:cNvPr id="3" name="Plassholder for innhold 2">
+            <a:extLst>
+              <a:ext uri="{FF2B5EF4-FFF2-40B4-BE49-F238E27FC236}">
+                <a16:creationId xmlns:a16="http://schemas.microsoft.com/office/drawing/2014/main" id="{66B72835-6CD2-245E-8B36-0123C3B5BF06}"/>
+              </a:ext>
+            </a:extLst>
+          </p:cNvPr>
+          <p:cNvSpPr>
+            <a:spLocks noGrp="1"/>
+          </p:cNvSpPr>
+          <p:nvPr>
+            <p:ph idx="1"/>
+          </p:nvPr>
+        </p:nvSpPr>
+        <p:spPr/>
+        <p:txBody>
+          <a:bodyPr/>
+          <a:lstStyle/>
+          <a:p>
+            <a:r>
+              <a:rPr lang="nb-NO" dirty="0"/>
+              <a:t>OVF – </a:t>
+            </a:r>
+            <a:r>
+              <a:rPr lang="nb-NO" dirty="0" err="1"/>
+              <a:t>Overflow</a:t>
+            </a:r>
+            <a:r>
+              <a:rPr lang="nb-NO" dirty="0"/>
+              <a:t> i TCA0 periferienheten</a:t>
+            </a:r>
+            <a:br>
+              <a:rPr lang="nb-NO" dirty="0"/>
+            </a:br>
+            <a:endParaRPr lang="nb-NO" dirty="0"/>
+          </a:p>
+          <a:p>
+            <a:endParaRPr lang="nb-NO" dirty="0"/>
+          </a:p>
+          <a:p>
+            <a:endParaRPr lang="nb-NO" dirty="0"/>
+          </a:p>
+          <a:p>
+            <a:endParaRPr lang="nb-NO" dirty="0"/>
+          </a:p>
+          <a:p>
+            <a:pPr marL="0" indent="0">
+              <a:buNone/>
+            </a:pPr>
+            <a:endParaRPr lang="nb-NO" dirty="0"/>
+          </a:p>
+        </p:txBody>
+      </p:sp>
+      <p:pic>
+        <p:nvPicPr>
+          <p:cNvPr id="5" name="Bilde 4">
+            <a:extLst>
+              <a:ext uri="{FF2B5EF4-FFF2-40B4-BE49-F238E27FC236}">
+                <a16:creationId xmlns:a16="http://schemas.microsoft.com/office/drawing/2014/main" id="{8B62ABFA-0191-C477-7E00-6328B5501D75}"/>
+              </a:ext>
+            </a:extLst>
+          </p:cNvPr>
+          <p:cNvPicPr>
+            <a:picLocks noChangeAspect="1"/>
+          </p:cNvPicPr>
+          <p:nvPr/>
+        </p:nvPicPr>
+        <p:blipFill>
+          <a:blip r:embed="rId2"/>
+          <a:stretch>
+            <a:fillRect/>
+          </a:stretch>
+        </p:blipFill>
+        <p:spPr>
+          <a:xfrm>
+            <a:off x="7222261" y="2766636"/>
+            <a:ext cx="4315427" cy="3067478"/>
+          </a:xfrm>
+          <a:prstGeom prst="rect">
+            <a:avLst/>
+          </a:prstGeom>
+        </p:spPr>
+      </p:pic>
+      <p:pic>
+        <p:nvPicPr>
+          <p:cNvPr id="6" name="Bilde 5">
+            <a:extLst>
+              <a:ext uri="{FF2B5EF4-FFF2-40B4-BE49-F238E27FC236}">
+                <a16:creationId xmlns:a16="http://schemas.microsoft.com/office/drawing/2014/main" id="{CDE06E3C-D854-6EF1-C1F5-6497903DC584}"/>
+              </a:ext>
+            </a:extLst>
+          </p:cNvPr>
+          <p:cNvPicPr>
+            <a:picLocks noChangeAspect="1"/>
+          </p:cNvPicPr>
+          <p:nvPr/>
+        </p:nvPicPr>
+        <p:blipFill>
+          <a:blip r:embed="rId3"/>
+          <a:stretch>
+            <a:fillRect/>
+          </a:stretch>
+        </p:blipFill>
+        <p:spPr>
+          <a:xfrm>
+            <a:off x="838200" y="2796226"/>
+            <a:ext cx="5486285" cy="2591945"/>
+          </a:xfrm>
+          <a:prstGeom prst="rect">
+            <a:avLst/>
+          </a:prstGeom>
+        </p:spPr>
+      </p:pic>
+    </p:spTree>
+    <p:extLst>
+      <p:ext uri="{BB962C8B-B14F-4D97-AF65-F5344CB8AC3E}">
+        <p14:creationId xmlns:p14="http://schemas.microsoft.com/office/powerpoint/2010/main" val="4118092742"/>
+      </p:ext>
+    </p:extLst>
+  </p:cSld>
+  <p:clrMapOvr>
+    <a:masterClrMapping/>
+  </p:clrMapOvr>
+</p:sld>
+</file>
+
+<file path=ppt/slides/slide6.xml><?xml version="1.0" encoding="utf-8"?>
 <p:sld xmlns:a="http://schemas.openxmlformats.org/drawingml/2006/main" xmlns:r="http://schemas.openxmlformats.org/officeDocument/2006/relationships" xmlns:p="http://schemas.openxmlformats.org/presentationml/2006/main">
   <p:cSld>
     <p:spTree>
@@ -4764,7 +6054,7 @@
 </p:sld>
 </file>
 
-<file path=ppt/slides/slide6.xml><?xml version="1.0" encoding="utf-8"?>
+<file path=ppt/slides/slide7.xml><?xml version="1.0" encoding="utf-8"?>
 <p:sld xmlns:a="http://schemas.openxmlformats.org/drawingml/2006/main" xmlns:r="http://schemas.openxmlformats.org/officeDocument/2006/relationships" xmlns:p="http://schemas.openxmlformats.org/presentationml/2006/main">
   <p:cSld>
     <p:spTree>
@@ -4854,7 +6144,7 @@
 </p:sld>
 </file>
 
-<file path=ppt/slides/slide7.xml><?xml version="1.0" encoding="utf-8"?>
+<file path=ppt/slides/slide8.xml><?xml version="1.0" encoding="utf-8"?>
 <p:sld xmlns:a="http://schemas.openxmlformats.org/drawingml/2006/main" xmlns:r="http://schemas.openxmlformats.org/officeDocument/2006/relationships" xmlns:p="http://schemas.openxmlformats.org/presentationml/2006/main">
   <p:cSld>
     <p:spTree>
@@ -5019,7 +6309,7 @@
         </p:blipFill>
         <p:spPr>
           <a:xfrm>
-            <a:off x="838200" y="4480078"/>
+            <a:off x="1732935" y="4480078"/>
             <a:ext cx="8220778" cy="2682570"/>
           </a:xfrm>
           <a:prstGeom prst="rect">
@@ -5040,7 +6330,7 @@
 </p:sld>
 </file>
 
-<file path=ppt/slides/slide8.xml><?xml version="1.0" encoding="utf-8"?>
+<file path=ppt/slides/slide9.xml><?xml version="1.0" encoding="utf-8"?>
 <p:sld xmlns:a="http://schemas.openxmlformats.org/drawingml/2006/main" xmlns:r="http://schemas.openxmlformats.org/officeDocument/2006/relationships" xmlns:p="http://schemas.openxmlformats.org/presentationml/2006/main">
   <p:cSld>
     <p:spTree>
@@ -5254,153 +6544,6 @@
     <p:extLst>
       <p:ext uri="{BB962C8B-B14F-4D97-AF65-F5344CB8AC3E}">
         <p14:creationId xmlns:p14="http://schemas.microsoft.com/office/powerpoint/2010/main" val="1171314811"/>
-      </p:ext>
-    </p:extLst>
-  </p:cSld>
-  <p:clrMapOvr>
-    <a:masterClrMapping/>
-  </p:clrMapOvr>
-</p:sld>
-</file>
-
-<file path=ppt/slides/slide9.xml><?xml version="1.0" encoding="utf-8"?>
-<p:sld xmlns:a="http://schemas.openxmlformats.org/drawingml/2006/main" xmlns:r="http://schemas.openxmlformats.org/officeDocument/2006/relationships" xmlns:p="http://schemas.openxmlformats.org/presentationml/2006/main">
-  <p:cSld>
-    <p:spTree>
-      <p:nvGrpSpPr>
-        <p:cNvPr id="1" name=""/>
-        <p:cNvGrpSpPr/>
-        <p:nvPr/>
-      </p:nvGrpSpPr>
-      <p:grpSpPr>
-        <a:xfrm>
-          <a:off x="0" y="0"/>
-          <a:ext cx="0" cy="0"/>
-          <a:chOff x="0" y="0"/>
-          <a:chExt cx="0" cy="0"/>
-        </a:xfrm>
-      </p:grpSpPr>
-      <p:sp>
-        <p:nvSpPr>
-          <p:cNvPr id="2" name="Tittel 1">
-            <a:extLst>
-              <a:ext uri="{FF2B5EF4-FFF2-40B4-BE49-F238E27FC236}">
-                <a16:creationId xmlns:a16="http://schemas.microsoft.com/office/drawing/2014/main" id="{6287AB4D-FBC1-DE6B-F806-E6B2EC6AAF9E}"/>
-              </a:ext>
-            </a:extLst>
-          </p:cNvPr>
-          <p:cNvSpPr>
-            <a:spLocks noGrp="1"/>
-          </p:cNvSpPr>
-          <p:nvPr>
-            <p:ph type="title"/>
-          </p:nvPr>
-        </p:nvSpPr>
-        <p:spPr/>
-        <p:txBody>
-          <a:bodyPr/>
-          <a:lstStyle/>
-          <a:p>
-            <a:r>
-              <a:rPr lang="nb-NO" dirty="0"/>
-              <a:t>Konfigurering - MCC</a:t>
-            </a:r>
-          </a:p>
-        </p:txBody>
-      </p:sp>
-      <p:sp>
-        <p:nvSpPr>
-          <p:cNvPr id="3" name="Plassholder for innhold 2">
-            <a:extLst>
-              <a:ext uri="{FF2B5EF4-FFF2-40B4-BE49-F238E27FC236}">
-                <a16:creationId xmlns:a16="http://schemas.microsoft.com/office/drawing/2014/main" id="{52BBE370-2AFA-931B-E991-D2534F9AA97D}"/>
-              </a:ext>
-            </a:extLst>
-          </p:cNvPr>
-          <p:cNvSpPr>
-            <a:spLocks noGrp="1"/>
-          </p:cNvSpPr>
-          <p:nvPr>
-            <p:ph idx="1"/>
-          </p:nvPr>
-        </p:nvSpPr>
-        <p:spPr/>
-        <p:txBody>
-          <a:bodyPr/>
-          <a:lstStyle/>
-          <a:p>
-            <a:r>
-              <a:rPr lang="nb-NO" dirty="0"/>
-              <a:t>Legg til ADC som komponent</a:t>
-            </a:r>
-          </a:p>
-        </p:txBody>
-      </p:sp>
-      <p:pic>
-        <p:nvPicPr>
-          <p:cNvPr id="5" name="Bilde 4">
-            <a:extLst>
-              <a:ext uri="{FF2B5EF4-FFF2-40B4-BE49-F238E27FC236}">
-                <a16:creationId xmlns:a16="http://schemas.microsoft.com/office/drawing/2014/main" id="{E4A6B338-0160-ABCB-2C33-D032A4DDE7E1}"/>
-              </a:ext>
-            </a:extLst>
-          </p:cNvPr>
-          <p:cNvPicPr>
-            <a:picLocks noChangeAspect="1"/>
-          </p:cNvPicPr>
-          <p:nvPr/>
-        </p:nvPicPr>
-        <p:blipFill>
-          <a:blip r:embed="rId2"/>
-          <a:stretch>
-            <a:fillRect/>
-          </a:stretch>
-        </p:blipFill>
-        <p:spPr>
-          <a:xfrm>
-            <a:off x="152400" y="4922280"/>
-            <a:ext cx="9929720" cy="1905165"/>
-          </a:xfrm>
-          <a:prstGeom prst="rect">
-            <a:avLst/>
-          </a:prstGeom>
-        </p:spPr>
-      </p:pic>
-      <p:pic>
-        <p:nvPicPr>
-          <p:cNvPr id="7" name="Bilde 6">
-            <a:extLst>
-              <a:ext uri="{FF2B5EF4-FFF2-40B4-BE49-F238E27FC236}">
-                <a16:creationId xmlns:a16="http://schemas.microsoft.com/office/drawing/2014/main" id="{BB5C1C8B-1D78-0384-5D81-8A619E87EC6A}"/>
-              </a:ext>
-            </a:extLst>
-          </p:cNvPr>
-          <p:cNvPicPr>
-            <a:picLocks noChangeAspect="1"/>
-          </p:cNvPicPr>
-          <p:nvPr/>
-        </p:nvPicPr>
-        <p:blipFill>
-          <a:blip r:embed="rId3"/>
-          <a:srcRect r="39600" b="25299"/>
-          <a:stretch>
-            <a:fillRect/>
-          </a:stretch>
-        </p:blipFill>
-        <p:spPr>
-          <a:xfrm>
-            <a:off x="6096000" y="1027906"/>
-            <a:ext cx="5546488" cy="3404235"/>
-          </a:xfrm>
-          <a:prstGeom prst="rect">
-            <a:avLst/>
-          </a:prstGeom>
-        </p:spPr>
-      </p:pic>
-    </p:spTree>
-    <p:extLst>
-      <p:ext uri="{BB962C8B-B14F-4D97-AF65-F5344CB8AC3E}">
-        <p14:creationId xmlns:p14="http://schemas.microsoft.com/office/powerpoint/2010/main" val="523849282"/>
       </p:ext>
     </p:extLst>
   </p:cSld>
@@ -5723,4 +6866,319 @@
     </a:ext>
   </a:extLst>
 </a:theme>
+</file>
+
+<file path=ppt/theme/theme2.xml><?xml version="1.0" encoding="utf-8"?>
+<a:theme xmlns:a="http://schemas.openxmlformats.org/drawingml/2006/main" name="Office-tema">
+  <a:themeElements>
+    <a:clrScheme name="Office">
+      <a:dk1>
+        <a:sysClr val="windowText" lastClr="000000"/>
+      </a:dk1>
+      <a:lt1>
+        <a:sysClr val="window" lastClr="FFFFFF"/>
+      </a:lt1>
+      <a:dk2>
+        <a:srgbClr val="0E2841"/>
+      </a:dk2>
+      <a:lt2>
+        <a:srgbClr val="E8E8E8"/>
+      </a:lt2>
+      <a:accent1>
+        <a:srgbClr val="156082"/>
+      </a:accent1>
+      <a:accent2>
+        <a:srgbClr val="E97132"/>
+      </a:accent2>
+      <a:accent3>
+        <a:srgbClr val="196B24"/>
+      </a:accent3>
+      <a:accent4>
+        <a:srgbClr val="0F9ED5"/>
+      </a:accent4>
+      <a:accent5>
+        <a:srgbClr val="A02B93"/>
+      </a:accent5>
+      <a:accent6>
+        <a:srgbClr val="4EA72E"/>
+      </a:accent6>
+      <a:hlink>
+        <a:srgbClr val="467886"/>
+      </a:hlink>
+      <a:folHlink>
+        <a:srgbClr val="96607D"/>
+      </a:folHlink>
+    </a:clrScheme>
+    <a:fontScheme name="Office">
+      <a:majorFont>
+        <a:latin typeface="Aptos Display" panose="02110004020202020204"/>
+        <a:ea typeface=""/>
+        <a:cs typeface=""/>
+        <a:font script="Jpan" typeface="游ゴシック Light"/>
+        <a:font script="Hang" typeface="맑은 고딕"/>
+        <a:font script="Hans" typeface="等线 Light"/>
+        <a:font script="Hant" typeface="新細明體"/>
+        <a:font script="Arab" typeface="Times New Roman"/>
+        <a:font script="Hebr" typeface="Times New Roman"/>
+        <a:font script="Thai" typeface="Angsana New"/>
+        <a:font script="Ethi" typeface="Nyala"/>
+        <a:font script="Beng" typeface="Vrinda"/>
+        <a:font script="Gujr" typeface="Shruti"/>
+        <a:font script="Khmr" typeface="MoolBoran"/>
+        <a:font script="Knda" typeface="Tunga"/>
+        <a:font script="Guru" typeface="Raavi"/>
+        <a:font script="Cans" typeface="Euphemia"/>
+        <a:font script="Cher" typeface="Plantagenet Cherokee"/>
+        <a:font script="Yiii" typeface="Microsoft Yi Baiti"/>
+        <a:font script="Tibt" typeface="Microsoft Himalaya"/>
+        <a:font script="Thaa" typeface="MV Boli"/>
+        <a:font script="Deva" typeface="Mangal"/>
+        <a:font script="Telu" typeface="Gautami"/>
+        <a:font script="Taml" typeface="Latha"/>
+        <a:font script="Syrc" typeface="Estrangelo Edessa"/>
+        <a:font script="Orya" typeface="Kalinga"/>
+        <a:font script="Mlym" typeface="Kartika"/>
+        <a:font script="Laoo" typeface="DokChampa"/>
+        <a:font script="Sinh" typeface="Iskoola Pota"/>
+        <a:font script="Mong" typeface="Mongolian Baiti"/>
+        <a:font script="Viet" typeface="Times New Roman"/>
+        <a:font script="Uigh" typeface="Microsoft Uighur"/>
+        <a:font script="Geor" typeface="Sylfaen"/>
+        <a:font script="Armn" typeface="Arial"/>
+        <a:font script="Bugi" typeface="Leelawadee UI"/>
+        <a:font script="Bopo" typeface="Microsoft JhengHei"/>
+        <a:font script="Java" typeface="Javanese Text"/>
+        <a:font script="Lisu" typeface="Segoe UI"/>
+        <a:font script="Mymr" typeface="Myanmar Text"/>
+        <a:font script="Nkoo" typeface="Ebrima"/>
+        <a:font script="Olck" typeface="Nirmala UI"/>
+        <a:font script="Osma" typeface="Ebrima"/>
+        <a:font script="Phag" typeface="Phagspa"/>
+        <a:font script="Syrn" typeface="Estrangelo Edessa"/>
+        <a:font script="Syrj" typeface="Estrangelo Edessa"/>
+        <a:font script="Syre" typeface="Estrangelo Edessa"/>
+        <a:font script="Sora" typeface="Nirmala UI"/>
+        <a:font script="Tale" typeface="Microsoft Tai Le"/>
+        <a:font script="Talu" typeface="Microsoft New Tai Lue"/>
+        <a:font script="Tfng" typeface="Ebrima"/>
+      </a:majorFont>
+      <a:minorFont>
+        <a:latin typeface="Aptos" panose="02110004020202020204"/>
+        <a:ea typeface=""/>
+        <a:cs typeface=""/>
+        <a:font script="Jpan" typeface="游ゴシック"/>
+        <a:font script="Hang" typeface="맑은 고딕"/>
+        <a:font script="Hans" typeface="等线"/>
+        <a:font script="Hant" typeface="新細明體"/>
+        <a:font script="Arab" typeface="Arial"/>
+        <a:font script="Hebr" typeface="Arial"/>
+        <a:font script="Thai" typeface="Cordia New"/>
+        <a:font script="Ethi" typeface="Nyala"/>
+        <a:font script="Beng" typeface="Vrinda"/>
+        <a:font script="Gujr" typeface="Shruti"/>
+        <a:font script="Khmr" typeface="DaunPenh"/>
+        <a:font script="Knda" typeface="Tunga"/>
+        <a:font script="Guru" typeface="Raavi"/>
+        <a:font script="Cans" typeface="Euphemia"/>
+        <a:font script="Cher" typeface="Plantagenet Cherokee"/>
+        <a:font script="Yiii" typeface="Microsoft Yi Baiti"/>
+        <a:font script="Tibt" typeface="Microsoft Himalaya"/>
+        <a:font script="Thaa" typeface="MV Boli"/>
+        <a:font script="Deva" typeface="Mangal"/>
+        <a:font script="Telu" typeface="Gautami"/>
+        <a:font script="Taml" typeface="Latha"/>
+        <a:font script="Syrc" typeface="Estrangelo Edessa"/>
+        <a:font script="Orya" typeface="Kalinga"/>
+        <a:font script="Mlym" typeface="Kartika"/>
+        <a:font script="Laoo" typeface="DokChampa"/>
+        <a:font script="Sinh" typeface="Iskoola Pota"/>
+        <a:font script="Mong" typeface="Mongolian Baiti"/>
+        <a:font script="Viet" typeface="Arial"/>
+        <a:font script="Uigh" typeface="Microsoft Uighur"/>
+        <a:font script="Geor" typeface="Sylfaen"/>
+        <a:font script="Armn" typeface="Arial"/>
+        <a:font script="Bugi" typeface="Leelawadee UI"/>
+        <a:font script="Bopo" typeface="Microsoft JhengHei"/>
+        <a:font script="Java" typeface="Javanese Text"/>
+        <a:font script="Lisu" typeface="Segoe UI"/>
+        <a:font script="Mymr" typeface="Myanmar Text"/>
+        <a:font script="Nkoo" typeface="Ebrima"/>
+        <a:font script="Olck" typeface="Nirmala UI"/>
+        <a:font script="Osma" typeface="Ebrima"/>
+        <a:font script="Phag" typeface="Phagspa"/>
+        <a:font script="Syrn" typeface="Estrangelo Edessa"/>
+        <a:font script="Syrj" typeface="Estrangelo Edessa"/>
+        <a:font script="Syre" typeface="Estrangelo Edessa"/>
+        <a:font script="Sora" typeface="Nirmala UI"/>
+        <a:font script="Tale" typeface="Microsoft Tai Le"/>
+        <a:font script="Talu" typeface="Microsoft New Tai Lue"/>
+        <a:font script="Tfng" typeface="Ebrima"/>
+      </a:minorFont>
+    </a:fontScheme>
+    <a:fmtScheme name="Office">
+      <a:fillStyleLst>
+        <a:solidFill>
+          <a:schemeClr val="phClr"/>
+        </a:solidFill>
+        <a:gradFill rotWithShape="1">
+          <a:gsLst>
+            <a:gs pos="0">
+              <a:schemeClr val="phClr">
+                <a:lumMod val="110000"/>
+                <a:satMod val="105000"/>
+                <a:tint val="67000"/>
+              </a:schemeClr>
+            </a:gs>
+            <a:gs pos="50000">
+              <a:schemeClr val="phClr">
+                <a:lumMod val="105000"/>
+                <a:satMod val="103000"/>
+                <a:tint val="73000"/>
+              </a:schemeClr>
+            </a:gs>
+            <a:gs pos="100000">
+              <a:schemeClr val="phClr">
+                <a:lumMod val="105000"/>
+                <a:satMod val="109000"/>
+                <a:tint val="81000"/>
+              </a:schemeClr>
+            </a:gs>
+          </a:gsLst>
+          <a:lin ang="5400000" scaled="0"/>
+        </a:gradFill>
+        <a:gradFill rotWithShape="1">
+          <a:gsLst>
+            <a:gs pos="0">
+              <a:schemeClr val="phClr">
+                <a:satMod val="103000"/>
+                <a:lumMod val="102000"/>
+                <a:tint val="94000"/>
+              </a:schemeClr>
+            </a:gs>
+            <a:gs pos="50000">
+              <a:schemeClr val="phClr">
+                <a:satMod val="110000"/>
+                <a:lumMod val="100000"/>
+                <a:shade val="100000"/>
+              </a:schemeClr>
+            </a:gs>
+            <a:gs pos="100000">
+              <a:schemeClr val="phClr">
+                <a:lumMod val="99000"/>
+                <a:satMod val="120000"/>
+                <a:shade val="78000"/>
+              </a:schemeClr>
+            </a:gs>
+          </a:gsLst>
+          <a:lin ang="5400000" scaled="0"/>
+        </a:gradFill>
+      </a:fillStyleLst>
+      <a:lnStyleLst>
+        <a:ln w="12700" cap="flat" cmpd="sng" algn="ctr">
+          <a:solidFill>
+            <a:schemeClr val="phClr"/>
+          </a:solidFill>
+          <a:prstDash val="solid"/>
+          <a:miter lim="800000"/>
+        </a:ln>
+        <a:ln w="19050" cap="flat" cmpd="sng" algn="ctr">
+          <a:solidFill>
+            <a:schemeClr val="phClr"/>
+          </a:solidFill>
+          <a:prstDash val="solid"/>
+          <a:miter lim="800000"/>
+        </a:ln>
+        <a:ln w="25400" cap="flat" cmpd="sng" algn="ctr">
+          <a:solidFill>
+            <a:schemeClr val="phClr"/>
+          </a:solidFill>
+          <a:prstDash val="solid"/>
+          <a:miter lim="800000"/>
+        </a:ln>
+      </a:lnStyleLst>
+      <a:effectStyleLst>
+        <a:effectStyle>
+          <a:effectLst/>
+        </a:effectStyle>
+        <a:effectStyle>
+          <a:effectLst/>
+        </a:effectStyle>
+        <a:effectStyle>
+          <a:effectLst>
+            <a:outerShdw blurRad="57150" dist="19050" dir="5400000" algn="ctr" rotWithShape="0">
+              <a:srgbClr val="000000">
+                <a:alpha val="63000"/>
+              </a:srgbClr>
+            </a:outerShdw>
+          </a:effectLst>
+        </a:effectStyle>
+      </a:effectStyleLst>
+      <a:bgFillStyleLst>
+        <a:solidFill>
+          <a:schemeClr val="phClr"/>
+        </a:solidFill>
+        <a:solidFill>
+          <a:schemeClr val="phClr">
+            <a:tint val="95000"/>
+            <a:satMod val="170000"/>
+          </a:schemeClr>
+        </a:solidFill>
+        <a:gradFill rotWithShape="1">
+          <a:gsLst>
+            <a:gs pos="0">
+              <a:schemeClr val="phClr">
+                <a:tint val="93000"/>
+                <a:satMod val="150000"/>
+                <a:shade val="98000"/>
+                <a:lumMod val="102000"/>
+              </a:schemeClr>
+            </a:gs>
+            <a:gs pos="50000">
+              <a:schemeClr val="phClr">
+                <a:tint val="98000"/>
+                <a:satMod val="130000"/>
+                <a:shade val="90000"/>
+                <a:lumMod val="103000"/>
+              </a:schemeClr>
+            </a:gs>
+            <a:gs pos="100000">
+              <a:schemeClr val="phClr">
+                <a:shade val="63000"/>
+                <a:satMod val="120000"/>
+              </a:schemeClr>
+            </a:gs>
+          </a:gsLst>
+          <a:lin ang="5400000" scaled="0"/>
+        </a:gradFill>
+      </a:bgFillStyleLst>
+    </a:fmtScheme>
+  </a:themeElements>
+  <a:objectDefaults>
+    <a:lnDef>
+      <a:spPr/>
+      <a:bodyPr/>
+      <a:lstStyle/>
+      <a:style>
+        <a:lnRef idx="2">
+          <a:schemeClr val="accent1"/>
+        </a:lnRef>
+        <a:fillRef idx="0">
+          <a:schemeClr val="accent1"/>
+        </a:fillRef>
+        <a:effectRef idx="1">
+          <a:schemeClr val="accent1"/>
+        </a:effectRef>
+        <a:fontRef idx="minor">
+          <a:schemeClr val="tx1"/>
+        </a:fontRef>
+      </a:style>
+    </a:lnDef>
+  </a:objectDefaults>
+  <a:extraClrSchemeLst/>
+  <a:extLst>
+    <a:ext uri="{05A4C25C-085E-4340-85A3-A5531E510DB2}">
+      <thm15:themeFamily xmlns:thm15="http://schemas.microsoft.com/office/thememl/2012/main" name="Office Theme" id="{2E142A2C-CD16-42D6-873A-C26D2A0506FA}" vid="{1BDDFF52-6CD6-40A5-AB3C-68EB2F1E4D0A}"/>
+    </a:ext>
+  </a:extLst>
+</a:theme>
 </file>
</xml_diff>

<commit_message>
Endringer som allerede er commited, men som jeg må gjenta for å fikse working tree
</commit_message>
<xml_diff>
--- a/Kursdag 2/Dag to.pptx
+++ b/Kursdag 2/Dag to.pptx
@@ -4,28 +4,21 @@
   <p:sldMasterIdLst>
     <p:sldMasterId id="2147483648" r:id="rId1"/>
   </p:sldMasterIdLst>
-  <p:notesMasterIdLst>
-    <p:notesMasterId r:id="rId20"/>
-  </p:notesMasterIdLst>
   <p:sldIdLst>
     <p:sldId id="256" r:id="rId2"/>
     <p:sldId id="257" r:id="rId3"/>
     <p:sldId id="260" r:id="rId4"/>
     <p:sldId id="269" r:id="rId5"/>
-    <p:sldId id="270" r:id="rId6"/>
-    <p:sldId id="267" r:id="rId7"/>
-    <p:sldId id="268" r:id="rId8"/>
-    <p:sldId id="259" r:id="rId9"/>
-    <p:sldId id="261" r:id="rId10"/>
-    <p:sldId id="262" r:id="rId11"/>
-    <p:sldId id="263" r:id="rId12"/>
-    <p:sldId id="264" r:id="rId13"/>
-    <p:sldId id="265" r:id="rId14"/>
-    <p:sldId id="266" r:id="rId15"/>
-    <p:sldId id="258" r:id="rId16"/>
-    <p:sldId id="271" r:id="rId17"/>
-    <p:sldId id="272" r:id="rId18"/>
-    <p:sldId id="273" r:id="rId19"/>
+    <p:sldId id="267" r:id="rId6"/>
+    <p:sldId id="268" r:id="rId7"/>
+    <p:sldId id="259" r:id="rId8"/>
+    <p:sldId id="261" r:id="rId9"/>
+    <p:sldId id="262" r:id="rId10"/>
+    <p:sldId id="263" r:id="rId11"/>
+    <p:sldId id="264" r:id="rId12"/>
+    <p:sldId id="265" r:id="rId13"/>
+    <p:sldId id="266" r:id="rId14"/>
+    <p:sldId id="258" r:id="rId15"/>
   </p:sldIdLst>
   <p:sldSz cx="12192000" cy="6858000"/>
   <p:notesSz cx="6858000" cy="9144000"/>
@@ -132,442 +125,6 @@
 </p:presentation>
 </file>
 
-<file path=ppt/notesMasters/notesMaster1.xml><?xml version="1.0" encoding="utf-8"?>
-<p:notesMaster xmlns:a="http://schemas.openxmlformats.org/drawingml/2006/main" xmlns:r="http://schemas.openxmlformats.org/officeDocument/2006/relationships" xmlns:p="http://schemas.openxmlformats.org/presentationml/2006/main">
-  <p:cSld>
-    <p:bg>
-      <p:bgRef idx="1001">
-        <a:schemeClr val="bg1"/>
-      </p:bgRef>
-    </p:bg>
-    <p:spTree>
-      <p:nvGrpSpPr>
-        <p:cNvPr id="1" name=""/>
-        <p:cNvGrpSpPr/>
-        <p:nvPr/>
-      </p:nvGrpSpPr>
-      <p:grpSpPr>
-        <a:xfrm>
-          <a:off x="0" y="0"/>
-          <a:ext cx="0" cy="0"/>
-          <a:chOff x="0" y="0"/>
-          <a:chExt cx="0" cy="0"/>
-        </a:xfrm>
-      </p:grpSpPr>
-      <p:sp>
-        <p:nvSpPr>
-          <p:cNvPr id="2" name="Plassholder for topptekst 1"/>
-          <p:cNvSpPr>
-            <a:spLocks noGrp="1"/>
-          </p:cNvSpPr>
-          <p:nvPr>
-            <p:ph type="hdr" sz="quarter"/>
-          </p:nvPr>
-        </p:nvSpPr>
-        <p:spPr>
-          <a:xfrm>
-            <a:off x="0" y="0"/>
-            <a:ext cx="2971800" cy="458788"/>
-          </a:xfrm>
-          <a:prstGeom prst="rect">
-            <a:avLst/>
-          </a:prstGeom>
-        </p:spPr>
-        <p:txBody>
-          <a:bodyPr vert="horz" lIns="91440" tIns="45720" rIns="91440" bIns="45720" rtlCol="0"/>
-          <a:lstStyle>
-            <a:lvl1pPr algn="l">
-              <a:defRPr sz="1200"/>
-            </a:lvl1pPr>
-          </a:lstStyle>
-          <a:p>
-            <a:endParaRPr lang="nb-NO"/>
-          </a:p>
-        </p:txBody>
-      </p:sp>
-      <p:sp>
-        <p:nvSpPr>
-          <p:cNvPr id="3" name="Plassholder for dato 2"/>
-          <p:cNvSpPr>
-            <a:spLocks noGrp="1"/>
-          </p:cNvSpPr>
-          <p:nvPr>
-            <p:ph type="dt" idx="1"/>
-          </p:nvPr>
-        </p:nvSpPr>
-        <p:spPr>
-          <a:xfrm>
-            <a:off x="3884613" y="0"/>
-            <a:ext cx="2971800" cy="458788"/>
-          </a:xfrm>
-          <a:prstGeom prst="rect">
-            <a:avLst/>
-          </a:prstGeom>
-        </p:spPr>
-        <p:txBody>
-          <a:bodyPr vert="horz" lIns="91440" tIns="45720" rIns="91440" bIns="45720" rtlCol="0"/>
-          <a:lstStyle>
-            <a:lvl1pPr algn="r">
-              <a:defRPr sz="1200"/>
-            </a:lvl1pPr>
-          </a:lstStyle>
-          <a:p>
-            <a:fld id="{ACB6A25B-A690-4E14-9ED0-D2ECF6431ED6}" type="datetimeFigureOut">
-              <a:rPr lang="nb-NO" smtClean="0"/>
-              <a:t>14.03.2026</a:t>
-            </a:fld>
-            <a:endParaRPr lang="nb-NO"/>
-          </a:p>
-        </p:txBody>
-      </p:sp>
-      <p:sp>
-        <p:nvSpPr>
-          <p:cNvPr id="4" name="Plassholder for lysbilde 3"/>
-          <p:cNvSpPr>
-            <a:spLocks noGrp="1" noRot="1" noChangeAspect="1"/>
-          </p:cNvSpPr>
-          <p:nvPr>
-            <p:ph type="sldImg" idx="2"/>
-          </p:nvPr>
-        </p:nvSpPr>
-        <p:spPr>
-          <a:xfrm>
-            <a:off x="685800" y="1143000"/>
-            <a:ext cx="5486400" cy="3086100"/>
-          </a:xfrm>
-          <a:prstGeom prst="rect">
-            <a:avLst/>
-          </a:prstGeom>
-          <a:noFill/>
-          <a:ln w="12700">
-            <a:solidFill>
-              <a:prstClr val="black"/>
-            </a:solidFill>
-          </a:ln>
-        </p:spPr>
-        <p:txBody>
-          <a:bodyPr vert="horz" lIns="91440" tIns="45720" rIns="91440" bIns="45720" rtlCol="0" anchor="ctr"/>
-          <a:lstStyle/>
-          <a:p>
-            <a:endParaRPr lang="nb-NO"/>
-          </a:p>
-        </p:txBody>
-      </p:sp>
-      <p:sp>
-        <p:nvSpPr>
-          <p:cNvPr id="5" name="Plassholder for notater 4"/>
-          <p:cNvSpPr>
-            <a:spLocks noGrp="1"/>
-          </p:cNvSpPr>
-          <p:nvPr>
-            <p:ph type="body" sz="quarter" idx="3"/>
-          </p:nvPr>
-        </p:nvSpPr>
-        <p:spPr>
-          <a:xfrm>
-            <a:off x="685800" y="4400550"/>
-            <a:ext cx="5486400" cy="3600450"/>
-          </a:xfrm>
-          <a:prstGeom prst="rect">
-            <a:avLst/>
-          </a:prstGeom>
-        </p:spPr>
-        <p:txBody>
-          <a:bodyPr vert="horz" lIns="91440" tIns="45720" rIns="91440" bIns="45720" rtlCol="0"/>
-          <a:lstStyle/>
-          <a:p>
-            <a:pPr lvl="0"/>
-            <a:r>
-              <a:rPr lang="nb-NO"/>
-              <a:t>Klikk for å redigere tekststiler i malen</a:t>
-            </a:r>
-          </a:p>
-          <a:p>
-            <a:pPr lvl="1"/>
-            <a:r>
-              <a:rPr lang="nb-NO"/>
-              <a:t>Andre nivå</a:t>
-            </a:r>
-          </a:p>
-          <a:p>
-            <a:pPr lvl="2"/>
-            <a:r>
-              <a:rPr lang="nb-NO"/>
-              <a:t>Tredje nivå</a:t>
-            </a:r>
-          </a:p>
-          <a:p>
-            <a:pPr lvl="3"/>
-            <a:r>
-              <a:rPr lang="nb-NO"/>
-              <a:t>Fjerde nivå</a:t>
-            </a:r>
-          </a:p>
-          <a:p>
-            <a:pPr lvl="4"/>
-            <a:r>
-              <a:rPr lang="nb-NO"/>
-              <a:t>Femte nivå</a:t>
-            </a:r>
-          </a:p>
-        </p:txBody>
-      </p:sp>
-      <p:sp>
-        <p:nvSpPr>
-          <p:cNvPr id="6" name="Plassholder for bunntekst 5"/>
-          <p:cNvSpPr>
-            <a:spLocks noGrp="1"/>
-          </p:cNvSpPr>
-          <p:nvPr>
-            <p:ph type="ftr" sz="quarter" idx="4"/>
-          </p:nvPr>
-        </p:nvSpPr>
-        <p:spPr>
-          <a:xfrm>
-            <a:off x="0" y="8685213"/>
-            <a:ext cx="2971800" cy="458787"/>
-          </a:xfrm>
-          <a:prstGeom prst="rect">
-            <a:avLst/>
-          </a:prstGeom>
-        </p:spPr>
-        <p:txBody>
-          <a:bodyPr vert="horz" lIns="91440" tIns="45720" rIns="91440" bIns="45720" rtlCol="0" anchor="b"/>
-          <a:lstStyle>
-            <a:lvl1pPr algn="l">
-              <a:defRPr sz="1200"/>
-            </a:lvl1pPr>
-          </a:lstStyle>
-          <a:p>
-            <a:endParaRPr lang="nb-NO"/>
-          </a:p>
-        </p:txBody>
-      </p:sp>
-      <p:sp>
-        <p:nvSpPr>
-          <p:cNvPr id="7" name="Plassholder for lysbildenummer 6"/>
-          <p:cNvSpPr>
-            <a:spLocks noGrp="1"/>
-          </p:cNvSpPr>
-          <p:nvPr>
-            <p:ph type="sldNum" sz="quarter" idx="5"/>
-          </p:nvPr>
-        </p:nvSpPr>
-        <p:spPr>
-          <a:xfrm>
-            <a:off x="3884613" y="8685213"/>
-            <a:ext cx="2971800" cy="458787"/>
-          </a:xfrm>
-          <a:prstGeom prst="rect">
-            <a:avLst/>
-          </a:prstGeom>
-        </p:spPr>
-        <p:txBody>
-          <a:bodyPr vert="horz" lIns="91440" tIns="45720" rIns="91440" bIns="45720" rtlCol="0" anchor="b"/>
-          <a:lstStyle>
-            <a:lvl1pPr algn="r">
-              <a:defRPr sz="1200"/>
-            </a:lvl1pPr>
-          </a:lstStyle>
-          <a:p>
-            <a:fld id="{56CEED96-8DE0-441C-B2ED-FF713A48F07D}" type="slidenum">
-              <a:rPr lang="nb-NO" smtClean="0"/>
-              <a:t>‹#›</a:t>
-            </a:fld>
-            <a:endParaRPr lang="nb-NO"/>
-          </a:p>
-        </p:txBody>
-      </p:sp>
-    </p:spTree>
-    <p:extLst>
-      <p:ext uri="{BB962C8B-B14F-4D97-AF65-F5344CB8AC3E}">
-        <p14:creationId xmlns:p14="http://schemas.microsoft.com/office/powerpoint/2010/main" val="2918529522"/>
-      </p:ext>
-    </p:extLst>
-  </p:cSld>
-  <p:clrMap bg1="lt1" tx1="dk1" bg2="lt2" tx2="dk2" accent1="accent1" accent2="accent2" accent3="accent3" accent4="accent4" accent5="accent5" accent6="accent6" hlink="hlink" folHlink="folHlink"/>
-  <p:notesStyle>
-    <a:lvl1pPr marL="0" algn="l" defTabSz="914400" rtl="0" eaLnBrk="1" latinLnBrk="0" hangingPunct="1">
-      <a:defRPr sz="1200" kern="1200">
-        <a:solidFill>
-          <a:schemeClr val="tx1"/>
-        </a:solidFill>
-        <a:latin typeface="+mn-lt"/>
-        <a:ea typeface="+mn-ea"/>
-        <a:cs typeface="+mn-cs"/>
-      </a:defRPr>
-    </a:lvl1pPr>
-    <a:lvl2pPr marL="457200" algn="l" defTabSz="914400" rtl="0" eaLnBrk="1" latinLnBrk="0" hangingPunct="1">
-      <a:defRPr sz="1200" kern="1200">
-        <a:solidFill>
-          <a:schemeClr val="tx1"/>
-        </a:solidFill>
-        <a:latin typeface="+mn-lt"/>
-        <a:ea typeface="+mn-ea"/>
-        <a:cs typeface="+mn-cs"/>
-      </a:defRPr>
-    </a:lvl2pPr>
-    <a:lvl3pPr marL="914400" algn="l" defTabSz="914400" rtl="0" eaLnBrk="1" latinLnBrk="0" hangingPunct="1">
-      <a:defRPr sz="1200" kern="1200">
-        <a:solidFill>
-          <a:schemeClr val="tx1"/>
-        </a:solidFill>
-        <a:latin typeface="+mn-lt"/>
-        <a:ea typeface="+mn-ea"/>
-        <a:cs typeface="+mn-cs"/>
-      </a:defRPr>
-    </a:lvl3pPr>
-    <a:lvl4pPr marL="1371600" algn="l" defTabSz="914400" rtl="0" eaLnBrk="1" latinLnBrk="0" hangingPunct="1">
-      <a:defRPr sz="1200" kern="1200">
-        <a:solidFill>
-          <a:schemeClr val="tx1"/>
-        </a:solidFill>
-        <a:latin typeface="+mn-lt"/>
-        <a:ea typeface="+mn-ea"/>
-        <a:cs typeface="+mn-cs"/>
-      </a:defRPr>
-    </a:lvl4pPr>
-    <a:lvl5pPr marL="1828800" algn="l" defTabSz="914400" rtl="0" eaLnBrk="1" latinLnBrk="0" hangingPunct="1">
-      <a:defRPr sz="1200" kern="1200">
-        <a:solidFill>
-          <a:schemeClr val="tx1"/>
-        </a:solidFill>
-        <a:latin typeface="+mn-lt"/>
-        <a:ea typeface="+mn-ea"/>
-        <a:cs typeface="+mn-cs"/>
-      </a:defRPr>
-    </a:lvl5pPr>
-    <a:lvl6pPr marL="2286000" algn="l" defTabSz="914400" rtl="0" eaLnBrk="1" latinLnBrk="0" hangingPunct="1">
-      <a:defRPr sz="1200" kern="1200">
-        <a:solidFill>
-          <a:schemeClr val="tx1"/>
-        </a:solidFill>
-        <a:latin typeface="+mn-lt"/>
-        <a:ea typeface="+mn-ea"/>
-        <a:cs typeface="+mn-cs"/>
-      </a:defRPr>
-    </a:lvl6pPr>
-    <a:lvl7pPr marL="2743200" algn="l" defTabSz="914400" rtl="0" eaLnBrk="1" latinLnBrk="0" hangingPunct="1">
-      <a:defRPr sz="1200" kern="1200">
-        <a:solidFill>
-          <a:schemeClr val="tx1"/>
-        </a:solidFill>
-        <a:latin typeface="+mn-lt"/>
-        <a:ea typeface="+mn-ea"/>
-        <a:cs typeface="+mn-cs"/>
-      </a:defRPr>
-    </a:lvl7pPr>
-    <a:lvl8pPr marL="3200400" algn="l" defTabSz="914400" rtl="0" eaLnBrk="1" latinLnBrk="0" hangingPunct="1">
-      <a:defRPr sz="1200" kern="1200">
-        <a:solidFill>
-          <a:schemeClr val="tx1"/>
-        </a:solidFill>
-        <a:latin typeface="+mn-lt"/>
-        <a:ea typeface="+mn-ea"/>
-        <a:cs typeface="+mn-cs"/>
-      </a:defRPr>
-    </a:lvl8pPr>
-    <a:lvl9pPr marL="3657600" algn="l" defTabSz="914400" rtl="0" eaLnBrk="1" latinLnBrk="0" hangingPunct="1">
-      <a:defRPr sz="1200" kern="1200">
-        <a:solidFill>
-          <a:schemeClr val="tx1"/>
-        </a:solidFill>
-        <a:latin typeface="+mn-lt"/>
-        <a:ea typeface="+mn-ea"/>
-        <a:cs typeface="+mn-cs"/>
-      </a:defRPr>
-    </a:lvl9pPr>
-  </p:notesStyle>
-</p:notesMaster>
-</file>
-
-<file path=ppt/notesSlides/notesSlide1.xml><?xml version="1.0" encoding="utf-8"?>
-<p:notes xmlns:a="http://schemas.openxmlformats.org/drawingml/2006/main" xmlns:r="http://schemas.openxmlformats.org/officeDocument/2006/relationships" xmlns:p="http://schemas.openxmlformats.org/presentationml/2006/main">
-  <p:cSld>
-    <p:spTree>
-      <p:nvGrpSpPr>
-        <p:cNvPr id="1" name=""/>
-        <p:cNvGrpSpPr/>
-        <p:nvPr/>
-      </p:nvGrpSpPr>
-      <p:grpSpPr>
-        <a:xfrm>
-          <a:off x="0" y="0"/>
-          <a:ext cx="0" cy="0"/>
-          <a:chOff x="0" y="0"/>
-          <a:chExt cx="0" cy="0"/>
-        </a:xfrm>
-      </p:grpSpPr>
-      <p:sp>
-        <p:nvSpPr>
-          <p:cNvPr id="2" name="Plassholder for lysbilde 1"/>
-          <p:cNvSpPr>
-            <a:spLocks noGrp="1" noRot="1" noChangeAspect="1"/>
-          </p:cNvSpPr>
-          <p:nvPr>
-            <p:ph type="sldImg"/>
-          </p:nvPr>
-        </p:nvSpPr>
-        <p:spPr/>
-      </p:sp>
-      <p:sp>
-        <p:nvSpPr>
-          <p:cNvPr id="3" name="Plassholder for notater 2"/>
-          <p:cNvSpPr>
-            <a:spLocks noGrp="1"/>
-          </p:cNvSpPr>
-          <p:nvPr>
-            <p:ph type="body" idx="1"/>
-          </p:nvPr>
-        </p:nvSpPr>
-        <p:spPr/>
-        <p:txBody>
-          <a:bodyPr/>
-          <a:lstStyle/>
-          <a:p>
-            <a:r>
-              <a:rPr lang="nb-NO" dirty="0"/>
-              <a:t>Bemerk at en seriell kommunikasjonsprotokoll sender data bitvis, en og en</a:t>
-            </a:r>
-          </a:p>
-        </p:txBody>
-      </p:sp>
-      <p:sp>
-        <p:nvSpPr>
-          <p:cNvPr id="4" name="Plassholder for lysbildenummer 3"/>
-          <p:cNvSpPr>
-            <a:spLocks noGrp="1"/>
-          </p:cNvSpPr>
-          <p:nvPr>
-            <p:ph type="sldNum" sz="quarter" idx="5"/>
-          </p:nvPr>
-        </p:nvSpPr>
-        <p:spPr/>
-        <p:txBody>
-          <a:bodyPr/>
-          <a:lstStyle/>
-          <a:p>
-            <a:fld id="{56CEED96-8DE0-441C-B2ED-FF713A48F07D}" type="slidenum">
-              <a:rPr lang="nb-NO" smtClean="0"/>
-              <a:t>18</a:t>
-            </a:fld>
-            <a:endParaRPr lang="nb-NO"/>
-          </a:p>
-        </p:txBody>
-      </p:sp>
-    </p:spTree>
-    <p:extLst>
-      <p:ext uri="{BB962C8B-B14F-4D97-AF65-F5344CB8AC3E}">
-        <p14:creationId xmlns:p14="http://schemas.microsoft.com/office/powerpoint/2010/main" val="34616909"/>
-      </p:ext>
-    </p:extLst>
-  </p:cSld>
-  <p:clrMapOvr>
-    <a:masterClrMapping/>
-  </p:clrMapOvr>
-</p:notes>
-</file>
-
 <file path=ppt/slideLayouts/slideLayout1.xml><?xml version="1.0" encoding="utf-8"?>
 <p:sldLayout xmlns:a="http://schemas.openxmlformats.org/drawingml/2006/main" xmlns:r="http://schemas.openxmlformats.org/officeDocument/2006/relationships" xmlns:p="http://schemas.openxmlformats.org/presentationml/2006/main" type="title" preserve="1">
   <p:cSld name="Tittellysbilde">
@@ -715,7 +272,7 @@
           <a:p>
             <a:fld id="{B9F7994A-41AD-4027-8E6D-AD66A7C6695C}" type="datetimeFigureOut">
               <a:rPr lang="nb-NO" smtClean="0"/>
-              <a:t>14.03.2026</a:t>
+              <a:t>13.03.2026</a:t>
             </a:fld>
             <a:endParaRPr lang="nb-NO"/>
           </a:p>
@@ -913,7 +470,7 @@
           <a:p>
             <a:fld id="{B9F7994A-41AD-4027-8E6D-AD66A7C6695C}" type="datetimeFigureOut">
               <a:rPr lang="nb-NO" smtClean="0"/>
-              <a:t>14.03.2026</a:t>
+              <a:t>13.03.2026</a:t>
             </a:fld>
             <a:endParaRPr lang="nb-NO"/>
           </a:p>
@@ -1121,7 +678,7 @@
           <a:p>
             <a:fld id="{B9F7994A-41AD-4027-8E6D-AD66A7C6695C}" type="datetimeFigureOut">
               <a:rPr lang="nb-NO" smtClean="0"/>
-              <a:t>14.03.2026</a:t>
+              <a:t>13.03.2026</a:t>
             </a:fld>
             <a:endParaRPr lang="nb-NO"/>
           </a:p>
@@ -1319,7 +876,7 @@
           <a:p>
             <a:fld id="{B9F7994A-41AD-4027-8E6D-AD66A7C6695C}" type="datetimeFigureOut">
               <a:rPr lang="nb-NO" smtClean="0"/>
-              <a:t>14.03.2026</a:t>
+              <a:t>13.03.2026</a:t>
             </a:fld>
             <a:endParaRPr lang="nb-NO"/>
           </a:p>
@@ -1594,7 +1151,7 @@
           <a:p>
             <a:fld id="{B9F7994A-41AD-4027-8E6D-AD66A7C6695C}" type="datetimeFigureOut">
               <a:rPr lang="nb-NO" smtClean="0"/>
-              <a:t>14.03.2026</a:t>
+              <a:t>13.03.2026</a:t>
             </a:fld>
             <a:endParaRPr lang="nb-NO"/>
           </a:p>
@@ -1859,7 +1416,7 @@
           <a:p>
             <a:fld id="{B9F7994A-41AD-4027-8E6D-AD66A7C6695C}" type="datetimeFigureOut">
               <a:rPr lang="nb-NO" smtClean="0"/>
-              <a:t>14.03.2026</a:t>
+              <a:t>13.03.2026</a:t>
             </a:fld>
             <a:endParaRPr lang="nb-NO"/>
           </a:p>
@@ -2271,7 +1828,7 @@
           <a:p>
             <a:fld id="{B9F7994A-41AD-4027-8E6D-AD66A7C6695C}" type="datetimeFigureOut">
               <a:rPr lang="nb-NO" smtClean="0"/>
-              <a:t>14.03.2026</a:t>
+              <a:t>13.03.2026</a:t>
             </a:fld>
             <a:endParaRPr lang="nb-NO"/>
           </a:p>
@@ -2412,7 +1969,7 @@
           <a:p>
             <a:fld id="{B9F7994A-41AD-4027-8E6D-AD66A7C6695C}" type="datetimeFigureOut">
               <a:rPr lang="nb-NO" smtClean="0"/>
-              <a:t>14.03.2026</a:t>
+              <a:t>13.03.2026</a:t>
             </a:fld>
             <a:endParaRPr lang="nb-NO"/>
           </a:p>
@@ -2525,7 +2082,7 @@
           <a:p>
             <a:fld id="{B9F7994A-41AD-4027-8E6D-AD66A7C6695C}" type="datetimeFigureOut">
               <a:rPr lang="nb-NO" smtClean="0"/>
-              <a:t>14.03.2026</a:t>
+              <a:t>13.03.2026</a:t>
             </a:fld>
             <a:endParaRPr lang="nb-NO"/>
           </a:p>
@@ -2836,7 +2393,7 @@
           <a:p>
             <a:fld id="{B9F7994A-41AD-4027-8E6D-AD66A7C6695C}" type="datetimeFigureOut">
               <a:rPr lang="nb-NO" smtClean="0"/>
-              <a:t>14.03.2026</a:t>
+              <a:t>13.03.2026</a:t>
             </a:fld>
             <a:endParaRPr lang="nb-NO"/>
           </a:p>
@@ -3124,7 +2681,7 @@
           <a:p>
             <a:fld id="{B9F7994A-41AD-4027-8E6D-AD66A7C6695C}" type="datetimeFigureOut">
               <a:rPr lang="nb-NO" smtClean="0"/>
-              <a:t>14.03.2026</a:t>
+              <a:t>13.03.2026</a:t>
             </a:fld>
             <a:endParaRPr lang="nb-NO"/>
           </a:p>
@@ -3365,7 +2922,7 @@
           <a:p>
             <a:fld id="{B9F7994A-41AD-4027-8E6D-AD66A7C6695C}" type="datetimeFigureOut">
               <a:rPr lang="nb-NO" smtClean="0"/>
-              <a:t>14.03.2026</a:t>
+              <a:t>13.03.2026</a:t>
             </a:fld>
             <a:endParaRPr lang="nb-NO"/>
           </a:p>
@@ -3941,153 +3498,6 @@
   <p:cSld>
     <p:spTree>
       <p:nvGrpSpPr>
-        <p:cNvPr id="1" name=""/>
-        <p:cNvGrpSpPr/>
-        <p:nvPr/>
-      </p:nvGrpSpPr>
-      <p:grpSpPr>
-        <a:xfrm>
-          <a:off x="0" y="0"/>
-          <a:ext cx="0" cy="0"/>
-          <a:chOff x="0" y="0"/>
-          <a:chExt cx="0" cy="0"/>
-        </a:xfrm>
-      </p:grpSpPr>
-      <p:sp>
-        <p:nvSpPr>
-          <p:cNvPr id="2" name="Tittel 1">
-            <a:extLst>
-              <a:ext uri="{FF2B5EF4-FFF2-40B4-BE49-F238E27FC236}">
-                <a16:creationId xmlns:a16="http://schemas.microsoft.com/office/drawing/2014/main" id="{6287AB4D-FBC1-DE6B-F806-E6B2EC6AAF9E}"/>
-              </a:ext>
-            </a:extLst>
-          </p:cNvPr>
-          <p:cNvSpPr>
-            <a:spLocks noGrp="1"/>
-          </p:cNvSpPr>
-          <p:nvPr>
-            <p:ph type="title"/>
-          </p:nvPr>
-        </p:nvSpPr>
-        <p:spPr/>
-        <p:txBody>
-          <a:bodyPr/>
-          <a:lstStyle/>
-          <a:p>
-            <a:r>
-              <a:rPr lang="nb-NO" dirty="0"/>
-              <a:t>Konfigurering - MCC</a:t>
-            </a:r>
-          </a:p>
-        </p:txBody>
-      </p:sp>
-      <p:sp>
-        <p:nvSpPr>
-          <p:cNvPr id="3" name="Plassholder for innhold 2">
-            <a:extLst>
-              <a:ext uri="{FF2B5EF4-FFF2-40B4-BE49-F238E27FC236}">
-                <a16:creationId xmlns:a16="http://schemas.microsoft.com/office/drawing/2014/main" id="{52BBE370-2AFA-931B-E991-D2534F9AA97D}"/>
-              </a:ext>
-            </a:extLst>
-          </p:cNvPr>
-          <p:cNvSpPr>
-            <a:spLocks noGrp="1"/>
-          </p:cNvSpPr>
-          <p:nvPr>
-            <p:ph idx="1"/>
-          </p:nvPr>
-        </p:nvSpPr>
-        <p:spPr/>
-        <p:txBody>
-          <a:bodyPr/>
-          <a:lstStyle/>
-          <a:p>
-            <a:r>
-              <a:rPr lang="nb-NO" dirty="0"/>
-              <a:t>Legg til ADC som komponent</a:t>
-            </a:r>
-          </a:p>
-        </p:txBody>
-      </p:sp>
-      <p:pic>
-        <p:nvPicPr>
-          <p:cNvPr id="5" name="Bilde 4">
-            <a:extLst>
-              <a:ext uri="{FF2B5EF4-FFF2-40B4-BE49-F238E27FC236}">
-                <a16:creationId xmlns:a16="http://schemas.microsoft.com/office/drawing/2014/main" id="{E4A6B338-0160-ABCB-2C33-D032A4DDE7E1}"/>
-              </a:ext>
-            </a:extLst>
-          </p:cNvPr>
-          <p:cNvPicPr>
-            <a:picLocks noChangeAspect="1"/>
-          </p:cNvPicPr>
-          <p:nvPr/>
-        </p:nvPicPr>
-        <p:blipFill>
-          <a:blip r:embed="rId2"/>
-          <a:stretch>
-            <a:fillRect/>
-          </a:stretch>
-        </p:blipFill>
-        <p:spPr>
-          <a:xfrm>
-            <a:off x="152400" y="4922280"/>
-            <a:ext cx="9929720" cy="1905165"/>
-          </a:xfrm>
-          <a:prstGeom prst="rect">
-            <a:avLst/>
-          </a:prstGeom>
-        </p:spPr>
-      </p:pic>
-      <p:pic>
-        <p:nvPicPr>
-          <p:cNvPr id="7" name="Bilde 6">
-            <a:extLst>
-              <a:ext uri="{FF2B5EF4-FFF2-40B4-BE49-F238E27FC236}">
-                <a16:creationId xmlns:a16="http://schemas.microsoft.com/office/drawing/2014/main" id="{BB5C1C8B-1D78-0384-5D81-8A619E87EC6A}"/>
-              </a:ext>
-            </a:extLst>
-          </p:cNvPr>
-          <p:cNvPicPr>
-            <a:picLocks noChangeAspect="1"/>
-          </p:cNvPicPr>
-          <p:nvPr/>
-        </p:nvPicPr>
-        <p:blipFill>
-          <a:blip r:embed="rId3"/>
-          <a:srcRect r="39600" b="25299"/>
-          <a:stretch>
-            <a:fillRect/>
-          </a:stretch>
-        </p:blipFill>
-        <p:spPr>
-          <a:xfrm>
-            <a:off x="6096000" y="1027906"/>
-            <a:ext cx="5546488" cy="3404235"/>
-          </a:xfrm>
-          <a:prstGeom prst="rect">
-            <a:avLst/>
-          </a:prstGeom>
-        </p:spPr>
-      </p:pic>
-    </p:spTree>
-    <p:extLst>
-      <p:ext uri="{BB962C8B-B14F-4D97-AF65-F5344CB8AC3E}">
-        <p14:creationId xmlns:p14="http://schemas.microsoft.com/office/powerpoint/2010/main" val="523849282"/>
-      </p:ext>
-    </p:extLst>
-  </p:cSld>
-  <p:clrMapOvr>
-    <a:masterClrMapping/>
-  </p:clrMapOvr>
-</p:sld>
-</file>
-
-<file path=ppt/slides/slide11.xml><?xml version="1.0" encoding="utf-8"?>
-<p:sld xmlns:a="http://schemas.openxmlformats.org/drawingml/2006/main" xmlns:r="http://schemas.openxmlformats.org/officeDocument/2006/relationships" xmlns:p="http://schemas.openxmlformats.org/presentationml/2006/main">
-  <p:cSld>
-    <p:spTree>
-      <p:nvGrpSpPr>
         <p:cNvPr id="1" name="">
           <a:extLst>
             <a:ext uri="{FF2B5EF4-FFF2-40B4-BE49-F238E27FC236}">
@@ -4164,21 +3574,21 @@
             <a:pPr lvl="1"/>
             <a:r>
               <a:rPr lang="nb-NO" dirty="0"/>
-              <a:t>Hvilken digitalpinne hver Ain er koblet </a:t>
+              <a:t>Hvilken pinne hver inngang går til står i </a:t>
             </a:r>
             <a:br>
               <a:rPr lang="nb-NO" dirty="0"/>
             </a:br>
             <a:r>
               <a:rPr lang="nb-NO" dirty="0"/>
-              <a:t>til dukker opp nederst på</a:t>
+              <a:t>databladet, og dukker opp nederst på</a:t>
             </a:r>
             <a:br>
               <a:rPr lang="nb-NO" dirty="0"/>
             </a:br>
             <a:r>
               <a:rPr lang="nb-NO" dirty="0"/>
-              <a:t>skjermen, og finnes i databladet</a:t>
+              <a:t>skjermen</a:t>
             </a:r>
           </a:p>
         </p:txBody>
@@ -4226,7 +3636,7 @@
 </p:sld>
 </file>
 
-<file path=ppt/slides/slide12.xml><?xml version="1.0" encoding="utf-8"?>
+<file path=ppt/slides/slide11.xml><?xml version="1.0" encoding="utf-8"?>
 <p:sld xmlns:a="http://schemas.openxmlformats.org/drawingml/2006/main" xmlns:r="http://schemas.openxmlformats.org/officeDocument/2006/relationships" xmlns:p="http://schemas.openxmlformats.org/presentationml/2006/main">
   <p:cSld>
     <p:spTree>
@@ -4307,65 +3717,6 @@
               <a:t> og grenseverdier</a:t>
             </a:r>
           </a:p>
-          <a:p>
-            <a:pPr lvl="1">
-              <a:lnSpc>
-                <a:spcPct val="150000"/>
-              </a:lnSpc>
-            </a:pPr>
-            <a:r>
-              <a:rPr lang="nb-NO" dirty="0"/>
-              <a:t>Over nedre grenseverdi</a:t>
-            </a:r>
-          </a:p>
-          <a:p>
-            <a:pPr lvl="1">
-              <a:lnSpc>
-                <a:spcPct val="150000"/>
-              </a:lnSpc>
-            </a:pPr>
-            <a:r>
-              <a:rPr lang="nb-NO" dirty="0"/>
-              <a:t>Under øvre grenseverdi</a:t>
-            </a:r>
-          </a:p>
-          <a:p>
-            <a:pPr lvl="1">
-              <a:lnSpc>
-                <a:spcPct val="150000"/>
-              </a:lnSpc>
-            </a:pPr>
-            <a:r>
-              <a:rPr lang="nb-NO" dirty="0"/>
-              <a:t>Mellom grenseverdiene</a:t>
-            </a:r>
-          </a:p>
-          <a:p>
-            <a:pPr lvl="1">
-              <a:lnSpc>
-                <a:spcPct val="100000"/>
-              </a:lnSpc>
-            </a:pPr>
-            <a:r>
-              <a:rPr lang="nb-NO" dirty="0"/>
-              <a:t>Større enn øvre eller</a:t>
-            </a:r>
-            <a:br>
-              <a:rPr lang="nb-NO" dirty="0"/>
-            </a:br>
-            <a:r>
-              <a:rPr lang="nb-NO" dirty="0"/>
-              <a:t>mindre enn </a:t>
-            </a:r>
-            <a:r>
-              <a:rPr lang="nb-NO" dirty="0" err="1"/>
-              <a:t>lavre</a:t>
-            </a:r>
-            <a:r>
-              <a:rPr lang="nb-NO" dirty="0"/>
-              <a:t> grenseverdi</a:t>
-            </a:r>
-          </a:p>
         </p:txBody>
       </p:sp>
       <p:pic>
@@ -4390,7 +3741,7 @@
         </p:blipFill>
         <p:spPr>
           <a:xfrm>
-            <a:off x="5688946" y="1825625"/>
+            <a:off x="5669281" y="1308000"/>
             <a:ext cx="6156960" cy="4242000"/>
           </a:xfrm>
           <a:prstGeom prst="rect">
@@ -4411,7 +3762,7 @@
 </p:sld>
 </file>
 
-<file path=ppt/slides/slide13.xml><?xml version="1.0" encoding="utf-8"?>
+<file path=ppt/slides/slide12.xml><?xml version="1.0" encoding="utf-8"?>
 <p:sld xmlns:a="http://schemas.openxmlformats.org/drawingml/2006/main" xmlns:r="http://schemas.openxmlformats.org/officeDocument/2006/relationships" xmlns:p="http://schemas.openxmlformats.org/presentationml/2006/main">
   <p:cSld>
     <p:spTree>
@@ -4497,14 +3848,22 @@
             <a:pPr lvl="1"/>
             <a:r>
               <a:rPr lang="nb-NO" dirty="0"/>
-              <a:t>Justerer hvor raskt </a:t>
+              <a:t>Justerer over hvor lang </a:t>
             </a:r>
             <a:br>
               <a:rPr lang="nb-NO" dirty="0"/>
             </a:br>
             <a:r>
               <a:rPr lang="nb-NO" dirty="0"/>
-              <a:t>målingen utføres</a:t>
+              <a:t>tid </a:t>
+            </a:r>
+            <a:r>
+              <a:rPr lang="nb-NO" dirty="0" err="1"/>
+              <a:t>ADCen</a:t>
+            </a:r>
+            <a:r>
+              <a:rPr lang="nb-NO" dirty="0"/>
+              <a:t> måler</a:t>
             </a:r>
           </a:p>
         </p:txBody>
@@ -4552,6 +3911,92 @@
 </p:sld>
 </file>
 
+<file path=ppt/slides/slide13.xml><?xml version="1.0" encoding="utf-8"?>
+<p:sld xmlns:a="http://schemas.openxmlformats.org/drawingml/2006/main" xmlns:r="http://schemas.openxmlformats.org/officeDocument/2006/relationships" xmlns:p="http://schemas.openxmlformats.org/presentationml/2006/main">
+  <p:cSld>
+    <p:spTree>
+      <p:nvGrpSpPr>
+        <p:cNvPr id="1" name=""/>
+        <p:cNvGrpSpPr/>
+        <p:nvPr/>
+      </p:nvGrpSpPr>
+      <p:grpSpPr>
+        <a:xfrm>
+          <a:off x="0" y="0"/>
+          <a:ext cx="0" cy="0"/>
+          <a:chOff x="0" y="0"/>
+          <a:chExt cx="0" cy="0"/>
+        </a:xfrm>
+      </p:grpSpPr>
+      <p:sp>
+        <p:nvSpPr>
+          <p:cNvPr id="2" name="Tittel 1">
+            <a:extLst>
+              <a:ext uri="{FF2B5EF4-FFF2-40B4-BE49-F238E27FC236}">
+                <a16:creationId xmlns:a16="http://schemas.microsoft.com/office/drawing/2014/main" id="{E3CC2766-9F34-9AE6-7CF7-9524B9CDC5BD}"/>
+              </a:ext>
+            </a:extLst>
+          </p:cNvPr>
+          <p:cNvSpPr>
+            <a:spLocks noGrp="1"/>
+          </p:cNvSpPr>
+          <p:nvPr>
+            <p:ph type="title"/>
+          </p:nvPr>
+        </p:nvSpPr>
+        <p:spPr/>
+        <p:txBody>
+          <a:bodyPr/>
+          <a:lstStyle/>
+          <a:p>
+            <a:r>
+              <a:rPr lang="nb-NO" dirty="0"/>
+              <a:t>Kode</a:t>
+            </a:r>
+          </a:p>
+        </p:txBody>
+      </p:sp>
+      <p:sp>
+        <p:nvSpPr>
+          <p:cNvPr id="3" name="Plassholder for innhold 2">
+            <a:extLst>
+              <a:ext uri="{FF2B5EF4-FFF2-40B4-BE49-F238E27FC236}">
+                <a16:creationId xmlns:a16="http://schemas.microsoft.com/office/drawing/2014/main" id="{6299A0F9-3095-6AB3-BFBE-EF5513911279}"/>
+              </a:ext>
+            </a:extLst>
+          </p:cNvPr>
+          <p:cNvSpPr>
+            <a:spLocks noGrp="1"/>
+          </p:cNvSpPr>
+          <p:nvPr>
+            <p:ph idx="1"/>
+          </p:nvPr>
+        </p:nvSpPr>
+        <p:spPr/>
+        <p:txBody>
+          <a:bodyPr/>
+          <a:lstStyle/>
+          <a:p>
+            <a:r>
+              <a:rPr lang="nb-NO" dirty="0"/>
+              <a:t>Viktig kode her</a:t>
+            </a:r>
+          </a:p>
+        </p:txBody>
+      </p:sp>
+    </p:spTree>
+    <p:extLst>
+      <p:ext uri="{BB962C8B-B14F-4D97-AF65-F5344CB8AC3E}">
+        <p14:creationId xmlns:p14="http://schemas.microsoft.com/office/powerpoint/2010/main" val="104226834"/>
+      </p:ext>
+    </p:extLst>
+  </p:cSld>
+  <p:clrMapOvr>
+    <a:masterClrMapping/>
+  </p:clrMapOvr>
+</p:sld>
+</file>
+
 <file path=ppt/slides/slide14.xml><?xml version="1.0" encoding="utf-8"?>
 <p:sld xmlns:a="http://schemas.openxmlformats.org/drawingml/2006/main" xmlns:r="http://schemas.openxmlformats.org/officeDocument/2006/relationships" xmlns:p="http://schemas.openxmlformats.org/presentationml/2006/main">
   <p:cSld>
@@ -4574,7 +4019,7 @@
           <p:cNvPr id="2" name="Tittel 1">
             <a:extLst>
               <a:ext uri="{FF2B5EF4-FFF2-40B4-BE49-F238E27FC236}">
-                <a16:creationId xmlns:a16="http://schemas.microsoft.com/office/drawing/2014/main" id="{E3CC2766-9F34-9AE6-7CF7-9524B9CDC5BD}"/>
+                <a16:creationId xmlns:a16="http://schemas.microsoft.com/office/drawing/2014/main" id="{56A8F48D-AD2E-A23C-9842-E1B1A67318DA}"/>
               </a:ext>
             </a:extLst>
           </p:cNvPr>
@@ -4592,123 +4037,7 @@
           <a:p>
             <a:r>
               <a:rPr lang="nb-NO" dirty="0"/>
-              <a:t>Kode</a:t>
-            </a:r>
-          </a:p>
-        </p:txBody>
-      </p:sp>
-      <p:sp>
-        <p:nvSpPr>
-          <p:cNvPr id="3" name="Plassholder for innhold 2">
-            <a:extLst>
-              <a:ext uri="{FF2B5EF4-FFF2-40B4-BE49-F238E27FC236}">
-                <a16:creationId xmlns:a16="http://schemas.microsoft.com/office/drawing/2014/main" id="{6299A0F9-3095-6AB3-BFBE-EF5513911279}"/>
-              </a:ext>
-            </a:extLst>
-          </p:cNvPr>
-          <p:cNvSpPr>
-            <a:spLocks noGrp="1"/>
-          </p:cNvSpPr>
-          <p:nvPr>
-            <p:ph idx="1"/>
-          </p:nvPr>
-        </p:nvSpPr>
-        <p:spPr/>
-        <p:txBody>
-          <a:bodyPr/>
-          <a:lstStyle/>
-          <a:p>
-            <a:r>
-              <a:rPr lang="nb-NO" dirty="0"/>
-              <a:t>MCC genererte funksjoner</a:t>
-            </a:r>
-          </a:p>
-        </p:txBody>
-      </p:sp>
-      <p:pic>
-        <p:nvPicPr>
-          <p:cNvPr id="5" name="Bilde 4">
-            <a:extLst>
-              <a:ext uri="{FF2B5EF4-FFF2-40B4-BE49-F238E27FC236}">
-                <a16:creationId xmlns:a16="http://schemas.microsoft.com/office/drawing/2014/main" id="{D83505C7-A04A-3A53-B569-2EFC0CA1EEFC}"/>
-              </a:ext>
-            </a:extLst>
-          </p:cNvPr>
-          <p:cNvPicPr>
-            <a:picLocks noChangeAspect="1"/>
-          </p:cNvPicPr>
-          <p:nvPr/>
-        </p:nvPicPr>
-        <p:blipFill>
-          <a:blip r:embed="rId2"/>
-          <a:stretch>
-            <a:fillRect/>
-          </a:stretch>
-        </p:blipFill>
-        <p:spPr>
-          <a:xfrm>
-            <a:off x="732676" y="2772397"/>
-            <a:ext cx="10726647" cy="2457793"/>
-          </a:xfrm>
-          <a:prstGeom prst="rect">
-            <a:avLst/>
-          </a:prstGeom>
-        </p:spPr>
-      </p:pic>
-    </p:spTree>
-    <p:extLst>
-      <p:ext uri="{BB962C8B-B14F-4D97-AF65-F5344CB8AC3E}">
-        <p14:creationId xmlns:p14="http://schemas.microsoft.com/office/powerpoint/2010/main" val="104226834"/>
-      </p:ext>
-    </p:extLst>
-  </p:cSld>
-  <p:clrMapOvr>
-    <a:masterClrMapping/>
-  </p:clrMapOvr>
-</p:sld>
-</file>
-
-<file path=ppt/slides/slide15.xml><?xml version="1.0" encoding="utf-8"?>
-<p:sld xmlns:a="http://schemas.openxmlformats.org/drawingml/2006/main" xmlns:r="http://schemas.openxmlformats.org/officeDocument/2006/relationships" xmlns:p="http://schemas.openxmlformats.org/presentationml/2006/main">
-  <p:cSld>
-    <p:spTree>
-      <p:nvGrpSpPr>
-        <p:cNvPr id="1" name=""/>
-        <p:cNvGrpSpPr/>
-        <p:nvPr/>
-      </p:nvGrpSpPr>
-      <p:grpSpPr>
-        <a:xfrm>
-          <a:off x="0" y="0"/>
-          <a:ext cx="0" cy="0"/>
-          <a:chOff x="0" y="0"/>
-          <a:chExt cx="0" cy="0"/>
-        </a:xfrm>
-      </p:grpSpPr>
-      <p:sp>
-        <p:nvSpPr>
-          <p:cNvPr id="2" name="Tittel 1">
-            <a:extLst>
-              <a:ext uri="{FF2B5EF4-FFF2-40B4-BE49-F238E27FC236}">
-                <a16:creationId xmlns:a16="http://schemas.microsoft.com/office/drawing/2014/main" id="{56A8F48D-AD2E-A23C-9842-E1B1A67318DA}"/>
-              </a:ext>
-            </a:extLst>
-          </p:cNvPr>
-          <p:cNvSpPr>
-            <a:spLocks noGrp="1"/>
-          </p:cNvSpPr>
-          <p:nvPr>
-            <p:ph type="title"/>
-          </p:nvPr>
-        </p:nvSpPr>
-        <p:spPr/>
-        <p:txBody>
-          <a:bodyPr/>
-          <a:lstStyle/>
-          <a:p>
-            <a:r>
-              <a:rPr lang="nb-NO" dirty="0"/>
-              <a:t>Teller/Timer</a:t>
+              <a:t>Teller</a:t>
             </a:r>
           </a:p>
         </p:txBody>
@@ -4743,38 +4072,6 @@
             <a:r>
               <a:rPr lang="nb-NO" dirty="0"/>
               <a:t>Vi fokuserer på type A (TCA0 og TCA1)</a:t>
-            </a:r>
-          </a:p>
-          <a:p>
-            <a:r>
-              <a:rPr lang="nb-NO" dirty="0"/>
-              <a:t>I16-biters register</a:t>
-            </a:r>
-          </a:p>
-          <a:p>
-            <a:pPr lvl="1"/>
-            <a:r>
-              <a:rPr lang="nb-NO" dirty="0"/>
-              <a:t>Kan deles i to 8-bit tellere</a:t>
-            </a:r>
-          </a:p>
-          <a:p>
-            <a:r>
-              <a:rPr lang="nb-NO" dirty="0"/>
-              <a:t>Verdien økes med 1 ved gitte</a:t>
-            </a:r>
-            <a:br>
-              <a:rPr lang="nb-NO" dirty="0"/>
-            </a:br>
-            <a:r>
-              <a:rPr lang="nb-NO" dirty="0"/>
-              <a:t>tilfeller </a:t>
-            </a:r>
-          </a:p>
-          <a:p>
-            <a:r>
-              <a:rPr lang="nb-NO" dirty="0"/>
-              <a:t>Tellerverdien kan leses av manuelt, eller automatikk kan gjennomføres når den når visse verdier</a:t>
             </a:r>
           </a:p>
         </p:txBody>
@@ -4793,7 +4090,7 @@
         </p:nvGrpSpPr>
         <p:grpSpPr>
           <a:xfrm>
-            <a:off x="5647600" y="2853932"/>
+            <a:off x="4545206" y="2917682"/>
             <a:ext cx="6308426" cy="1390157"/>
             <a:chOff x="5491868" y="2409683"/>
             <a:chExt cx="4625587" cy="1019318"/>
@@ -4874,427 +4171,6 @@
 </p:sld>
 </file>
 
-<file path=ppt/slides/slide16.xml><?xml version="1.0" encoding="utf-8"?>
-<p:sld xmlns:a="http://schemas.openxmlformats.org/drawingml/2006/main" xmlns:r="http://schemas.openxmlformats.org/officeDocument/2006/relationships" xmlns:p="http://schemas.openxmlformats.org/presentationml/2006/main">
-  <p:cSld>
-    <p:spTree>
-      <p:nvGrpSpPr>
-        <p:cNvPr id="1" name=""/>
-        <p:cNvGrpSpPr/>
-        <p:nvPr/>
-      </p:nvGrpSpPr>
-      <p:grpSpPr>
-        <a:xfrm>
-          <a:off x="0" y="0"/>
-          <a:ext cx="0" cy="0"/>
-          <a:chOff x="0" y="0"/>
-          <a:chExt cx="0" cy="0"/>
-        </a:xfrm>
-      </p:grpSpPr>
-      <p:sp>
-        <p:nvSpPr>
-          <p:cNvPr id="2" name="Tittel 1">
-            <a:extLst>
-              <a:ext uri="{FF2B5EF4-FFF2-40B4-BE49-F238E27FC236}">
-                <a16:creationId xmlns:a16="http://schemas.microsoft.com/office/drawing/2014/main" id="{166B4FD7-2B0F-EF85-8C22-D719CF0B97B7}"/>
-              </a:ext>
-            </a:extLst>
-          </p:cNvPr>
-          <p:cNvSpPr>
-            <a:spLocks noGrp="1"/>
-          </p:cNvSpPr>
-          <p:nvPr>
-            <p:ph type="title"/>
-          </p:nvPr>
-        </p:nvSpPr>
-        <p:spPr/>
-        <p:txBody>
-          <a:bodyPr/>
-          <a:lstStyle/>
-          <a:p>
-            <a:r>
-              <a:rPr lang="nb-NO" dirty="0"/>
-              <a:t>Teller</a:t>
-            </a:r>
-          </a:p>
-        </p:txBody>
-      </p:sp>
-      <p:sp>
-        <p:nvSpPr>
-          <p:cNvPr id="3" name="Plassholder for innhold 2">
-            <a:extLst>
-              <a:ext uri="{FF2B5EF4-FFF2-40B4-BE49-F238E27FC236}">
-                <a16:creationId xmlns:a16="http://schemas.microsoft.com/office/drawing/2014/main" id="{C659E690-B089-6306-B129-9385C388F676}"/>
-              </a:ext>
-            </a:extLst>
-          </p:cNvPr>
-          <p:cNvSpPr>
-            <a:spLocks noGrp="1"/>
-          </p:cNvSpPr>
-          <p:nvPr>
-            <p:ph idx="1"/>
-          </p:nvPr>
-        </p:nvSpPr>
-        <p:spPr/>
-        <p:txBody>
-          <a:bodyPr/>
-          <a:lstStyle/>
-          <a:p>
-            <a:r>
-              <a:rPr lang="nb-NO" dirty="0"/>
-              <a:t>Betegnes som regel når registeret øker verdi ved gitte hendelser</a:t>
-            </a:r>
-          </a:p>
-          <a:p>
-            <a:r>
-              <a:rPr lang="nb-NO" dirty="0"/>
-              <a:t>Konfigureres gjennom </a:t>
-            </a:r>
-            <a:r>
-              <a:rPr lang="nb-NO" dirty="0" err="1"/>
-              <a:t>eventsystem</a:t>
-            </a:r>
-            <a:endParaRPr lang="nb-NO" dirty="0"/>
-          </a:p>
-          <a:p>
-            <a:endParaRPr lang="nb-NO" dirty="0"/>
-          </a:p>
-          <a:p>
-            <a:r>
-              <a:rPr lang="nb-NO" dirty="0"/>
-              <a:t>Eks. </a:t>
-            </a:r>
-          </a:p>
-          <a:p>
-            <a:pPr lvl="1"/>
-            <a:r>
-              <a:rPr lang="nb-NO" dirty="0"/>
-              <a:t>Tell antall knappetrykk og utfør kommando når det passerer 20</a:t>
-            </a:r>
-          </a:p>
-        </p:txBody>
-      </p:sp>
-    </p:spTree>
-    <p:extLst>
-      <p:ext uri="{BB962C8B-B14F-4D97-AF65-F5344CB8AC3E}">
-        <p14:creationId xmlns:p14="http://schemas.microsoft.com/office/powerpoint/2010/main" val="960884609"/>
-      </p:ext>
-    </p:extLst>
-  </p:cSld>
-  <p:clrMapOvr>
-    <a:masterClrMapping/>
-  </p:clrMapOvr>
-</p:sld>
-</file>
-
-<file path=ppt/slides/slide17.xml><?xml version="1.0" encoding="utf-8"?>
-<p:sld xmlns:a="http://schemas.openxmlformats.org/drawingml/2006/main" xmlns:r="http://schemas.openxmlformats.org/officeDocument/2006/relationships" xmlns:p="http://schemas.openxmlformats.org/presentationml/2006/main">
-  <p:cSld>
-    <p:spTree>
-      <p:nvGrpSpPr>
-        <p:cNvPr id="1" name=""/>
-        <p:cNvGrpSpPr/>
-        <p:nvPr/>
-      </p:nvGrpSpPr>
-      <p:grpSpPr>
-        <a:xfrm>
-          <a:off x="0" y="0"/>
-          <a:ext cx="0" cy="0"/>
-          <a:chOff x="0" y="0"/>
-          <a:chExt cx="0" cy="0"/>
-        </a:xfrm>
-      </p:grpSpPr>
-      <p:sp>
-        <p:nvSpPr>
-          <p:cNvPr id="2" name="Tittel 1">
-            <a:extLst>
-              <a:ext uri="{FF2B5EF4-FFF2-40B4-BE49-F238E27FC236}">
-                <a16:creationId xmlns:a16="http://schemas.microsoft.com/office/drawing/2014/main" id="{1D94A9E1-E6D9-1388-EE9E-B3052F57975C}"/>
-              </a:ext>
-            </a:extLst>
-          </p:cNvPr>
-          <p:cNvSpPr>
-            <a:spLocks noGrp="1"/>
-          </p:cNvSpPr>
-          <p:nvPr>
-            <p:ph type="title"/>
-          </p:nvPr>
-        </p:nvSpPr>
-        <p:spPr/>
-        <p:txBody>
-          <a:bodyPr/>
-          <a:lstStyle/>
-          <a:p>
-            <a:r>
-              <a:rPr lang="nb-NO" dirty="0"/>
-              <a:t>Timer – Denne er litt lang, bør deles, fler bilder</a:t>
-            </a:r>
-          </a:p>
-        </p:txBody>
-      </p:sp>
-      <p:sp>
-        <p:nvSpPr>
-          <p:cNvPr id="3" name="Plassholder for innhold 2">
-            <a:extLst>
-              <a:ext uri="{FF2B5EF4-FFF2-40B4-BE49-F238E27FC236}">
-                <a16:creationId xmlns:a16="http://schemas.microsoft.com/office/drawing/2014/main" id="{ED7B5FE9-127F-6C1B-B4CA-508C3446EC21}"/>
-              </a:ext>
-            </a:extLst>
-          </p:cNvPr>
-          <p:cNvSpPr>
-            <a:spLocks noGrp="1"/>
-          </p:cNvSpPr>
-          <p:nvPr>
-            <p:ph idx="1"/>
-          </p:nvPr>
-        </p:nvSpPr>
-        <p:spPr/>
-        <p:txBody>
-          <a:bodyPr/>
-          <a:lstStyle/>
-          <a:p>
-            <a:r>
-              <a:rPr lang="nb-NO" dirty="0"/>
-              <a:t>Teller oppover per </a:t>
-            </a:r>
-            <a:r>
-              <a:rPr lang="nb-NO" i="1" dirty="0"/>
-              <a:t>n</a:t>
-            </a:r>
-            <a:r>
-              <a:rPr lang="nb-NO" dirty="0"/>
-              <a:t> antall klokkeslag</a:t>
-            </a:r>
-          </a:p>
-          <a:p>
-            <a:r>
-              <a:rPr lang="nb-NO" dirty="0"/>
-              <a:t>Egen klokke, skjer automatisk</a:t>
-            </a:r>
-          </a:p>
-          <a:p>
-            <a:r>
-              <a:rPr lang="nb-NO" i="1" dirty="0"/>
-              <a:t>n </a:t>
-            </a:r>
-            <a:r>
-              <a:rPr lang="nb-NO" dirty="0"/>
-              <a:t>gis av </a:t>
-            </a:r>
-            <a:r>
-              <a:rPr lang="nb-NO" dirty="0" err="1"/>
-              <a:t>prescaler</a:t>
-            </a:r>
-            <a:r>
-              <a:rPr lang="nb-NO" dirty="0"/>
-              <a:t>, hvor mange ganger skal klokkesignalet </a:t>
-            </a:r>
-            <a:r>
-              <a:rPr lang="nb-NO" dirty="0" err="1"/>
-              <a:t>halvveres</a:t>
-            </a:r>
-            <a:endParaRPr lang="nb-NO" dirty="0"/>
-          </a:p>
-          <a:p>
-            <a:pPr lvl="1"/>
-            <a:r>
-              <a:rPr lang="nb-NO" i="1" dirty="0"/>
-              <a:t>n = </a:t>
-            </a:r>
-            <a:r>
-              <a:rPr lang="nb-NO" dirty="0"/>
-              <a:t>2, 4, 8, 16, 32…</a:t>
-            </a:r>
-          </a:p>
-          <a:p>
-            <a:r>
-              <a:rPr lang="nb-NO" dirty="0"/>
-              <a:t>Lengre periode, lavere oppløsning</a:t>
-            </a:r>
-          </a:p>
-          <a:p>
-            <a:r>
-              <a:rPr lang="nb-NO" dirty="0"/>
-              <a:t>Flere </a:t>
-            </a:r>
-            <a:r>
-              <a:rPr lang="nb-NO" dirty="0" err="1"/>
-              <a:t>interrupts</a:t>
-            </a:r>
-            <a:r>
-              <a:rPr lang="nb-NO" dirty="0"/>
-              <a:t>, utføring av kommandoer med presis </a:t>
-            </a:r>
-          </a:p>
-        </p:txBody>
-      </p:sp>
-    </p:spTree>
-    <p:extLst>
-      <p:ext uri="{BB962C8B-B14F-4D97-AF65-F5344CB8AC3E}">
-        <p14:creationId xmlns:p14="http://schemas.microsoft.com/office/powerpoint/2010/main" val="1897542684"/>
-      </p:ext>
-    </p:extLst>
-  </p:cSld>
-  <p:clrMapOvr>
-    <a:masterClrMapping/>
-  </p:clrMapOvr>
-</p:sld>
-</file>
-
-<file path=ppt/slides/slide18.xml><?xml version="1.0" encoding="utf-8"?>
-<p:sld xmlns:a="http://schemas.openxmlformats.org/drawingml/2006/main" xmlns:r="http://schemas.openxmlformats.org/officeDocument/2006/relationships" xmlns:p="http://schemas.openxmlformats.org/presentationml/2006/main">
-  <p:cSld>
-    <p:spTree>
-      <p:nvGrpSpPr>
-        <p:cNvPr id="1" name=""/>
-        <p:cNvGrpSpPr/>
-        <p:nvPr/>
-      </p:nvGrpSpPr>
-      <p:grpSpPr>
-        <a:xfrm>
-          <a:off x="0" y="0"/>
-          <a:ext cx="0" cy="0"/>
-          <a:chOff x="0" y="0"/>
-          <a:chExt cx="0" cy="0"/>
-        </a:xfrm>
-      </p:grpSpPr>
-      <p:sp>
-        <p:nvSpPr>
-          <p:cNvPr id="2" name="Tittel 1">
-            <a:extLst>
-              <a:ext uri="{FF2B5EF4-FFF2-40B4-BE49-F238E27FC236}">
-                <a16:creationId xmlns:a16="http://schemas.microsoft.com/office/drawing/2014/main" id="{89114275-8F53-5A5B-0B26-723B5F426A45}"/>
-              </a:ext>
-            </a:extLst>
-          </p:cNvPr>
-          <p:cNvSpPr>
-            <a:spLocks noGrp="1"/>
-          </p:cNvSpPr>
-          <p:nvPr>
-            <p:ph type="title"/>
-          </p:nvPr>
-        </p:nvSpPr>
-        <p:spPr/>
-        <p:txBody>
-          <a:bodyPr/>
-          <a:lstStyle/>
-          <a:p>
-            <a:r>
-              <a:rPr lang="nb-NO" dirty="0"/>
-              <a:t>USART/UART</a:t>
-            </a:r>
-          </a:p>
-        </p:txBody>
-      </p:sp>
-      <p:sp>
-        <p:nvSpPr>
-          <p:cNvPr id="3" name="Plassholder for innhold 2">
-            <a:extLst>
-              <a:ext uri="{FF2B5EF4-FFF2-40B4-BE49-F238E27FC236}">
-                <a16:creationId xmlns:a16="http://schemas.microsoft.com/office/drawing/2014/main" id="{3D304FCB-FCE3-5BD9-D7F2-4E5117B9370A}"/>
-              </a:ext>
-            </a:extLst>
-          </p:cNvPr>
-          <p:cNvSpPr>
-            <a:spLocks noGrp="1"/>
-          </p:cNvSpPr>
-          <p:nvPr>
-            <p:ph idx="1"/>
-          </p:nvPr>
-        </p:nvSpPr>
-        <p:spPr/>
-        <p:txBody>
-          <a:bodyPr/>
-          <a:lstStyle/>
-          <a:p>
-            <a:r>
-              <a:rPr lang="nb-NO" dirty="0"/>
-              <a:t>Universal (</a:t>
-            </a:r>
-            <a:r>
-              <a:rPr lang="nb-NO" dirty="0" err="1"/>
-              <a:t>Synchronous</a:t>
-            </a:r>
-            <a:r>
-              <a:rPr lang="nb-NO" dirty="0"/>
-              <a:t>/)</a:t>
-            </a:r>
-            <a:r>
-              <a:rPr lang="nb-NO" dirty="0" err="1"/>
-              <a:t>Asynchronous</a:t>
-            </a:r>
-            <a:r>
-              <a:rPr lang="nb-NO" dirty="0"/>
-              <a:t> </a:t>
-            </a:r>
-            <a:r>
-              <a:rPr lang="nb-NO" dirty="0" err="1"/>
-              <a:t>Reciever</a:t>
-            </a:r>
-            <a:r>
-              <a:rPr lang="nb-NO" dirty="0"/>
-              <a:t>-Transmitter</a:t>
-            </a:r>
-          </a:p>
-          <a:p>
-            <a:r>
-              <a:rPr lang="nb-NO" dirty="0"/>
-              <a:t>Seriell kommunikasjonsprotokoll</a:t>
-            </a:r>
-          </a:p>
-          <a:p>
-            <a:r>
-              <a:rPr lang="nb-NO" dirty="0"/>
-              <a:t>Rx og </a:t>
-            </a:r>
-            <a:r>
-              <a:rPr lang="nb-NO" dirty="0" err="1"/>
-              <a:t>Tx</a:t>
-            </a:r>
-            <a:r>
-              <a:rPr lang="nb-NO" dirty="0"/>
-              <a:t> (Full Duplex) eller én leder(Halv Duplex)</a:t>
-            </a:r>
-          </a:p>
-          <a:p>
-            <a:r>
-              <a:rPr lang="nb-NO" dirty="0"/>
-              <a:t>Forhåndsgitt baud</a:t>
-            </a:r>
-          </a:p>
-          <a:p>
-            <a:pPr lvl="1"/>
-            <a:r>
-              <a:rPr lang="nb-NO" dirty="0"/>
-              <a:t>Baud = bits/sekund</a:t>
-            </a:r>
-          </a:p>
-          <a:p>
-            <a:pPr lvl="1"/>
-            <a:endParaRPr lang="nb-NO" dirty="0"/>
-          </a:p>
-          <a:p>
-            <a:r>
-              <a:rPr lang="nb-NO"/>
-              <a:t>Sende informasjon til </a:t>
-            </a:r>
-            <a:endParaRPr lang="nb-NO" dirty="0"/>
-          </a:p>
-        </p:txBody>
-      </p:sp>
-    </p:spTree>
-    <p:extLst>
-      <p:ext uri="{BB962C8B-B14F-4D97-AF65-F5344CB8AC3E}">
-        <p14:creationId xmlns:p14="http://schemas.microsoft.com/office/powerpoint/2010/main" val="979311525"/>
-      </p:ext>
-    </p:extLst>
-  </p:cSld>
-  <p:clrMapOvr>
-    <a:masterClrMapping/>
-  </p:clrMapOvr>
-</p:sld>
-</file>
-
 <file path=ppt/slides/slide2.xml><?xml version="1.0" encoding="utf-8"?>
 <p:sld xmlns:a="http://schemas.openxmlformats.org/drawingml/2006/main" xmlns:r="http://schemas.openxmlformats.org/officeDocument/2006/relationships" xmlns:p="http://schemas.openxmlformats.org/presentationml/2006/main">
   <p:cSld>
@@ -5685,12 +4561,6 @@
           </a:p>
           <a:p>
             <a:r>
-              <a:rPr lang="nb-NO" dirty="0"/>
-              <a:t>Tilsvarer en dedikert adresse i minnet</a:t>
-            </a:r>
-          </a:p>
-          <a:p>
-            <a:r>
               <a:rPr lang="nb-NO" i="1" dirty="0" err="1">
                 <a:solidFill>
                   <a:schemeClr val="bg1">
@@ -5729,28 +4599,45 @@
               <a:rPr lang="nb-NO" dirty="0"/>
               <a:t>Vektornavn finnes i beskrivelsen for hver </a:t>
             </a:r>
-            <a:br>
-              <a:rPr lang="nb-NO" dirty="0"/>
-            </a:br>
+          </a:p>
+          <a:p>
             <a:r>
               <a:rPr lang="nb-NO" dirty="0"/>
               <a:t>periferienhet</a:t>
             </a:r>
           </a:p>
-          <a:p>
-            <a:pPr marL="0" indent="0">
-              <a:buNone/>
-            </a:pPr>
-            <a:endParaRPr lang="nb-NO" dirty="0"/>
-          </a:p>
-          <a:p>
-            <a:r>
-              <a:rPr lang="nb-NO" dirty="0"/>
-              <a:t>Funksjoner bør være korte, «flagg» kan vurderes</a:t>
-            </a:r>
-          </a:p>
-        </p:txBody>
-      </p:sp>
+        </p:txBody>
+      </p:sp>
+      <p:pic>
+        <p:nvPicPr>
+          <p:cNvPr id="5" name="Bilde 4">
+            <a:extLst>
+              <a:ext uri="{FF2B5EF4-FFF2-40B4-BE49-F238E27FC236}">
+                <a16:creationId xmlns:a16="http://schemas.microsoft.com/office/drawing/2014/main" id="{8B62ABFA-0191-C477-7E00-6328B5501D75}"/>
+              </a:ext>
+            </a:extLst>
+          </p:cNvPr>
+          <p:cNvPicPr>
+            <a:picLocks noChangeAspect="1"/>
+          </p:cNvPicPr>
+          <p:nvPr/>
+        </p:nvPicPr>
+        <p:blipFill>
+          <a:blip r:embed="rId2"/>
+          <a:stretch>
+            <a:fillRect/>
+          </a:stretch>
+        </p:blipFill>
+        <p:spPr>
+          <a:xfrm>
+            <a:off x="7300919" y="3425397"/>
+            <a:ext cx="4315427" cy="3067478"/>
+          </a:xfrm>
+          <a:prstGeom prst="rect">
+            <a:avLst/>
+          </a:prstGeom>
+        </p:spPr>
+      </p:pic>
     </p:spTree>
     <p:extLst>
       <p:ext uri="{BB962C8B-B14F-4D97-AF65-F5344CB8AC3E}">
@@ -5765,183 +4652,6 @@
 </file>
 
 <file path=ppt/slides/slide5.xml><?xml version="1.0" encoding="utf-8"?>
-<p:sld xmlns:a="http://schemas.openxmlformats.org/drawingml/2006/main" xmlns:r="http://schemas.openxmlformats.org/officeDocument/2006/relationships" xmlns:p="http://schemas.openxmlformats.org/presentationml/2006/main">
-  <p:cSld>
-    <p:spTree>
-      <p:nvGrpSpPr>
-        <p:cNvPr id="1" name=""/>
-        <p:cNvGrpSpPr/>
-        <p:nvPr/>
-      </p:nvGrpSpPr>
-      <p:grpSpPr>
-        <a:xfrm>
-          <a:off x="0" y="0"/>
-          <a:ext cx="0" cy="0"/>
-          <a:chOff x="0" y="0"/>
-          <a:chExt cx="0" cy="0"/>
-        </a:xfrm>
-      </p:grpSpPr>
-      <p:sp>
-        <p:nvSpPr>
-          <p:cNvPr id="2" name="Tittel 1">
-            <a:extLst>
-              <a:ext uri="{FF2B5EF4-FFF2-40B4-BE49-F238E27FC236}">
-                <a16:creationId xmlns:a16="http://schemas.microsoft.com/office/drawing/2014/main" id="{89E49625-2BD4-EF7C-25A6-43EEDDBE740A}"/>
-              </a:ext>
-            </a:extLst>
-          </p:cNvPr>
-          <p:cNvSpPr>
-            <a:spLocks noGrp="1"/>
-          </p:cNvSpPr>
-          <p:nvPr>
-            <p:ph type="title"/>
-          </p:nvPr>
-        </p:nvSpPr>
-        <p:spPr/>
-        <p:txBody>
-          <a:bodyPr/>
-          <a:lstStyle/>
-          <a:p>
-            <a:r>
-              <a:rPr lang="nb-NO" dirty="0" err="1"/>
-              <a:t>Interrupt</a:t>
-            </a:r>
-            <a:r>
-              <a:rPr lang="nb-NO" dirty="0"/>
-              <a:t> vektor – Eksempel</a:t>
-            </a:r>
-          </a:p>
-        </p:txBody>
-      </p:sp>
-      <p:sp>
-        <p:nvSpPr>
-          <p:cNvPr id="3" name="Plassholder for innhold 2">
-            <a:extLst>
-              <a:ext uri="{FF2B5EF4-FFF2-40B4-BE49-F238E27FC236}">
-                <a16:creationId xmlns:a16="http://schemas.microsoft.com/office/drawing/2014/main" id="{66B72835-6CD2-245E-8B36-0123C3B5BF06}"/>
-              </a:ext>
-            </a:extLst>
-          </p:cNvPr>
-          <p:cNvSpPr>
-            <a:spLocks noGrp="1"/>
-          </p:cNvSpPr>
-          <p:nvPr>
-            <p:ph idx="1"/>
-          </p:nvPr>
-        </p:nvSpPr>
-        <p:spPr/>
-        <p:txBody>
-          <a:bodyPr/>
-          <a:lstStyle/>
-          <a:p>
-            <a:r>
-              <a:rPr lang="nb-NO" dirty="0"/>
-              <a:t>OVF – </a:t>
-            </a:r>
-            <a:r>
-              <a:rPr lang="nb-NO" dirty="0" err="1"/>
-              <a:t>Overflow</a:t>
-            </a:r>
-            <a:r>
-              <a:rPr lang="nb-NO" dirty="0"/>
-              <a:t> i TCA0 periferienheten</a:t>
-            </a:r>
-            <a:br>
-              <a:rPr lang="nb-NO" dirty="0"/>
-            </a:br>
-            <a:endParaRPr lang="nb-NO" dirty="0"/>
-          </a:p>
-          <a:p>
-            <a:endParaRPr lang="nb-NO" dirty="0"/>
-          </a:p>
-          <a:p>
-            <a:endParaRPr lang="nb-NO" dirty="0"/>
-          </a:p>
-          <a:p>
-            <a:endParaRPr lang="nb-NO" dirty="0"/>
-          </a:p>
-          <a:p>
-            <a:pPr marL="0" indent="0">
-              <a:buNone/>
-            </a:pPr>
-            <a:endParaRPr lang="nb-NO" dirty="0"/>
-          </a:p>
-        </p:txBody>
-      </p:sp>
-      <p:pic>
-        <p:nvPicPr>
-          <p:cNvPr id="5" name="Bilde 4">
-            <a:extLst>
-              <a:ext uri="{FF2B5EF4-FFF2-40B4-BE49-F238E27FC236}">
-                <a16:creationId xmlns:a16="http://schemas.microsoft.com/office/drawing/2014/main" id="{8B62ABFA-0191-C477-7E00-6328B5501D75}"/>
-              </a:ext>
-            </a:extLst>
-          </p:cNvPr>
-          <p:cNvPicPr>
-            <a:picLocks noChangeAspect="1"/>
-          </p:cNvPicPr>
-          <p:nvPr/>
-        </p:nvPicPr>
-        <p:blipFill>
-          <a:blip r:embed="rId2"/>
-          <a:stretch>
-            <a:fillRect/>
-          </a:stretch>
-        </p:blipFill>
-        <p:spPr>
-          <a:xfrm>
-            <a:off x="7222261" y="2766636"/>
-            <a:ext cx="4315427" cy="3067478"/>
-          </a:xfrm>
-          <a:prstGeom prst="rect">
-            <a:avLst/>
-          </a:prstGeom>
-        </p:spPr>
-      </p:pic>
-      <p:pic>
-        <p:nvPicPr>
-          <p:cNvPr id="6" name="Bilde 5">
-            <a:extLst>
-              <a:ext uri="{FF2B5EF4-FFF2-40B4-BE49-F238E27FC236}">
-                <a16:creationId xmlns:a16="http://schemas.microsoft.com/office/drawing/2014/main" id="{CDE06E3C-D854-6EF1-C1F5-6497903DC584}"/>
-              </a:ext>
-            </a:extLst>
-          </p:cNvPr>
-          <p:cNvPicPr>
-            <a:picLocks noChangeAspect="1"/>
-          </p:cNvPicPr>
-          <p:nvPr/>
-        </p:nvPicPr>
-        <p:blipFill>
-          <a:blip r:embed="rId3"/>
-          <a:stretch>
-            <a:fillRect/>
-          </a:stretch>
-        </p:blipFill>
-        <p:spPr>
-          <a:xfrm>
-            <a:off x="838200" y="2796226"/>
-            <a:ext cx="5486285" cy="2591945"/>
-          </a:xfrm>
-          <a:prstGeom prst="rect">
-            <a:avLst/>
-          </a:prstGeom>
-        </p:spPr>
-      </p:pic>
-    </p:spTree>
-    <p:extLst>
-      <p:ext uri="{BB962C8B-B14F-4D97-AF65-F5344CB8AC3E}">
-        <p14:creationId xmlns:p14="http://schemas.microsoft.com/office/powerpoint/2010/main" val="4118092742"/>
-      </p:ext>
-    </p:extLst>
-  </p:cSld>
-  <p:clrMapOvr>
-    <a:masterClrMapping/>
-  </p:clrMapOvr>
-</p:sld>
-</file>
-
-<file path=ppt/slides/slide6.xml><?xml version="1.0" encoding="utf-8"?>
 <p:sld xmlns:a="http://schemas.openxmlformats.org/drawingml/2006/main" xmlns:r="http://schemas.openxmlformats.org/officeDocument/2006/relationships" xmlns:p="http://schemas.openxmlformats.org/presentationml/2006/main">
   <p:cSld>
     <p:spTree>
@@ -6054,7 +4764,7 @@
 </p:sld>
 </file>
 
-<file path=ppt/slides/slide7.xml><?xml version="1.0" encoding="utf-8"?>
+<file path=ppt/slides/slide6.xml><?xml version="1.0" encoding="utf-8"?>
 <p:sld xmlns:a="http://schemas.openxmlformats.org/drawingml/2006/main" xmlns:r="http://schemas.openxmlformats.org/officeDocument/2006/relationships" xmlns:p="http://schemas.openxmlformats.org/presentationml/2006/main">
   <p:cSld>
     <p:spTree>
@@ -6144,6 +4854,192 @@
 </p:sld>
 </file>
 
+<file path=ppt/slides/slide7.xml><?xml version="1.0" encoding="utf-8"?>
+<p:sld xmlns:a="http://schemas.openxmlformats.org/drawingml/2006/main" xmlns:r="http://schemas.openxmlformats.org/officeDocument/2006/relationships" xmlns:p="http://schemas.openxmlformats.org/presentationml/2006/main">
+  <p:cSld>
+    <p:spTree>
+      <p:nvGrpSpPr>
+        <p:cNvPr id="1" name=""/>
+        <p:cNvGrpSpPr/>
+        <p:nvPr/>
+      </p:nvGrpSpPr>
+      <p:grpSpPr>
+        <a:xfrm>
+          <a:off x="0" y="0"/>
+          <a:ext cx="0" cy="0"/>
+          <a:chOff x="0" y="0"/>
+          <a:chExt cx="0" cy="0"/>
+        </a:xfrm>
+      </p:grpSpPr>
+      <p:sp>
+        <p:nvSpPr>
+          <p:cNvPr id="2" name="Tittel 1">
+            <a:extLst>
+              <a:ext uri="{FF2B5EF4-FFF2-40B4-BE49-F238E27FC236}">
+                <a16:creationId xmlns:a16="http://schemas.microsoft.com/office/drawing/2014/main" id="{A3F42A14-5A1D-2B2F-9B62-21091DF636CB}"/>
+              </a:ext>
+            </a:extLst>
+          </p:cNvPr>
+          <p:cNvSpPr>
+            <a:spLocks noGrp="1"/>
+          </p:cNvSpPr>
+          <p:nvPr>
+            <p:ph type="title"/>
+          </p:nvPr>
+        </p:nvSpPr>
+        <p:spPr/>
+        <p:txBody>
+          <a:bodyPr/>
+          <a:lstStyle/>
+          <a:p>
+            <a:r>
+              <a:rPr lang="nb-NO" dirty="0"/>
+              <a:t>Analog til Digital omformer</a:t>
+            </a:r>
+          </a:p>
+        </p:txBody>
+      </p:sp>
+      <p:sp>
+        <p:nvSpPr>
+          <p:cNvPr id="3" name="Plassholder for innhold 2">
+            <a:extLst>
+              <a:ext uri="{FF2B5EF4-FFF2-40B4-BE49-F238E27FC236}">
+                <a16:creationId xmlns:a16="http://schemas.microsoft.com/office/drawing/2014/main" id="{14267687-8471-6F56-F665-1D7F7073ED8A}"/>
+              </a:ext>
+            </a:extLst>
+          </p:cNvPr>
+          <p:cNvSpPr>
+            <a:spLocks noGrp="1"/>
+          </p:cNvSpPr>
+          <p:nvPr>
+            <p:ph idx="1"/>
+          </p:nvPr>
+        </p:nvSpPr>
+        <p:spPr>
+          <a:xfrm>
+            <a:off x="838200" y="1470025"/>
+            <a:ext cx="10515600" cy="4351338"/>
+          </a:xfrm>
+        </p:spPr>
+        <p:txBody>
+          <a:bodyPr/>
+          <a:lstStyle/>
+          <a:p>
+            <a:pPr>
+              <a:lnSpc>
+                <a:spcPts val="4200"/>
+              </a:lnSpc>
+            </a:pPr>
+            <a:r>
+              <a:rPr lang="nb-NO" dirty="0"/>
+              <a:t>Måler spenning på en Input-pinne</a:t>
+            </a:r>
+          </a:p>
+          <a:p>
+            <a:pPr>
+              <a:lnSpc>
+                <a:spcPts val="4200"/>
+              </a:lnSpc>
+            </a:pPr>
+            <a:r>
+              <a:rPr lang="nb-NO" dirty="0"/>
+              <a:t>12-bits oppløsning – 1.2mV presisjon 0-5V</a:t>
+            </a:r>
+          </a:p>
+          <a:p>
+            <a:pPr>
+              <a:lnSpc>
+                <a:spcPts val="4200"/>
+              </a:lnSpc>
+            </a:pPr>
+            <a:r>
+              <a:rPr lang="nb-NO" dirty="0"/>
+              <a:t>Måler i forhold til justerbar VREF</a:t>
+            </a:r>
+          </a:p>
+          <a:p>
+            <a:pPr>
+              <a:lnSpc>
+                <a:spcPts val="4200"/>
+              </a:lnSpc>
+            </a:pPr>
+            <a:r>
+              <a:rPr lang="nb-NO" dirty="0"/>
+              <a:t>Kan gi </a:t>
+            </a:r>
+            <a:r>
+              <a:rPr lang="nb-NO" dirty="0" err="1"/>
+              <a:t>interrupt</a:t>
+            </a:r>
+            <a:r>
+              <a:rPr lang="nb-NO" dirty="0"/>
+              <a:t> når den har målt ferdig</a:t>
+            </a:r>
+          </a:p>
+          <a:p>
+            <a:pPr lvl="1">
+              <a:lnSpc>
+                <a:spcPts val="4200"/>
+              </a:lnSpc>
+            </a:pPr>
+            <a:r>
+              <a:rPr lang="nb-NO" dirty="0"/>
+              <a:t>Også om målingen er over/under/mellom referanseverdier</a:t>
+            </a:r>
+          </a:p>
+          <a:p>
+            <a:pPr>
+              <a:lnSpc>
+                <a:spcPts val="4200"/>
+              </a:lnSpc>
+            </a:pPr>
+            <a:endParaRPr lang="nb-NO" dirty="0"/>
+          </a:p>
+        </p:txBody>
+      </p:sp>
+      <p:pic>
+        <p:nvPicPr>
+          <p:cNvPr id="7" name="Bilde 6">
+            <a:extLst>
+              <a:ext uri="{FF2B5EF4-FFF2-40B4-BE49-F238E27FC236}">
+                <a16:creationId xmlns:a16="http://schemas.microsoft.com/office/drawing/2014/main" id="{5D21904E-8171-77E5-7F03-D60ED5DB90F4}"/>
+              </a:ext>
+            </a:extLst>
+          </p:cNvPr>
+          <p:cNvPicPr>
+            <a:picLocks noChangeAspect="1"/>
+          </p:cNvPicPr>
+          <p:nvPr/>
+        </p:nvPicPr>
+        <p:blipFill>
+          <a:blip r:embed="rId2"/>
+          <a:stretch>
+            <a:fillRect/>
+          </a:stretch>
+        </p:blipFill>
+        <p:spPr>
+          <a:xfrm>
+            <a:off x="838200" y="4480078"/>
+            <a:ext cx="8220778" cy="2682570"/>
+          </a:xfrm>
+          <a:prstGeom prst="rect">
+            <a:avLst/>
+          </a:prstGeom>
+        </p:spPr>
+      </p:pic>
+    </p:spTree>
+    <p:extLst>
+      <p:ext uri="{BB962C8B-B14F-4D97-AF65-F5344CB8AC3E}">
+        <p14:creationId xmlns:p14="http://schemas.microsoft.com/office/powerpoint/2010/main" val="3155134844"/>
+      </p:ext>
+    </p:extLst>
+  </p:cSld>
+  <p:clrMapOvr>
+    <a:masterClrMapping/>
+  </p:clrMapOvr>
+</p:sld>
+</file>
+
 <file path=ppt/slides/slide8.xml><?xml version="1.0" encoding="utf-8"?>
 <p:sld xmlns:a="http://schemas.openxmlformats.org/drawingml/2006/main" xmlns:r="http://schemas.openxmlformats.org/officeDocument/2006/relationships" xmlns:p="http://schemas.openxmlformats.org/presentationml/2006/main">
   <p:cSld>
@@ -6166,7 +5062,7 @@
           <p:cNvPr id="2" name="Tittel 1">
             <a:extLst>
               <a:ext uri="{FF2B5EF4-FFF2-40B4-BE49-F238E27FC236}">
-                <a16:creationId xmlns:a16="http://schemas.microsoft.com/office/drawing/2014/main" id="{A3F42A14-5A1D-2B2F-9B62-21091DF636CB}"/>
+                <a16:creationId xmlns:a16="http://schemas.microsoft.com/office/drawing/2014/main" id="{454B47F0-0A6E-C15C-A97D-CB63FAFD33B0}"/>
               </a:ext>
             </a:extLst>
           </p:cNvPr>
@@ -6184,7 +5080,7 @@
           <a:p>
             <a:r>
               <a:rPr lang="nb-NO" dirty="0"/>
-              <a:t>Analog til Digital omformer</a:t>
+              <a:t>Virkemåte</a:t>
             </a:r>
           </a:p>
         </p:txBody>
@@ -6194,7 +5090,7 @@
           <p:cNvPr id="3" name="Plassholder for innhold 2">
             <a:extLst>
               <a:ext uri="{FF2B5EF4-FFF2-40B4-BE49-F238E27FC236}">
-                <a16:creationId xmlns:a16="http://schemas.microsoft.com/office/drawing/2014/main" id="{14267687-8471-6F56-F665-1D7F7073ED8A}"/>
+                <a16:creationId xmlns:a16="http://schemas.microsoft.com/office/drawing/2014/main" id="{34B09470-779E-C63D-ADDE-B2C92CEC69A9}"/>
               </a:ext>
             </a:extLst>
           </p:cNvPr>
@@ -6205,83 +5101,47 @@
             <p:ph idx="1"/>
           </p:nvPr>
         </p:nvSpPr>
-        <p:spPr>
-          <a:xfrm>
-            <a:off x="838200" y="1470025"/>
-            <a:ext cx="10515600" cy="4351338"/>
-          </a:xfrm>
-        </p:spPr>
-        <p:txBody>
-          <a:bodyPr/>
-          <a:lstStyle/>
-          <a:p>
-            <a:pPr>
-              <a:lnSpc>
-                <a:spcPts val="4200"/>
-              </a:lnSpc>
-            </a:pPr>
+        <p:spPr/>
+        <p:txBody>
+          <a:bodyPr/>
+          <a:lstStyle/>
+          <a:p>
+            <a:r>
+              <a:rPr lang="nb-NO" dirty="0" err="1"/>
+              <a:t>Successive</a:t>
+            </a:r>
             <a:r>
               <a:rPr lang="nb-NO" dirty="0"/>
-              <a:t>Måler spenning på en Input-pinne</a:t>
-            </a:r>
-          </a:p>
-          <a:p>
-            <a:pPr>
-              <a:lnSpc>
-                <a:spcPts val="4200"/>
-              </a:lnSpc>
-            </a:pPr>
-            <a:r>
+              <a:t> </a:t>
+            </a:r>
+            <a:r>
+              <a:rPr lang="nb-NO" dirty="0" err="1"/>
+              <a:t>approximation</a:t>
+            </a:r>
+            <a:br>
               <a:rPr lang="nb-NO" dirty="0"/>
-              <a:t>12-bits oppløsning – 1.2mV presisjon 0-5V</a:t>
-            </a:r>
-          </a:p>
-          <a:p>
-            <a:pPr>
-              <a:lnSpc>
-                <a:spcPts val="4200"/>
-              </a:lnSpc>
-            </a:pPr>
+            </a:br>
             <a:r>
               <a:rPr lang="nb-NO" dirty="0"/>
-              <a:t>Måler i forhold til justerbar VREF</a:t>
-            </a:r>
-          </a:p>
-          <a:p>
-            <a:pPr>
-              <a:lnSpc>
-                <a:spcPts val="4200"/>
-              </a:lnSpc>
-            </a:pPr>
+              <a:t>(SAR)</a:t>
+            </a:r>
+          </a:p>
+          <a:p>
             <a:r>
               <a:rPr lang="nb-NO" dirty="0"/>
-              <a:t>Kan gi </a:t>
-            </a:r>
-            <a:r>
-              <a:rPr lang="nb-NO" dirty="0" err="1"/>
-              <a:t>interrupt</a:t>
-            </a:r>
-            <a:r>
+              <a:t>Bruker en DAC for å tilnærme</a:t>
+            </a:r>
+            <a:br>
               <a:rPr lang="nb-NO" dirty="0"/>
-              <a:t> når den har målt ferdig</a:t>
-            </a:r>
-          </a:p>
-          <a:p>
-            <a:pPr lvl="1">
-              <a:lnSpc>
-                <a:spcPts val="4200"/>
-              </a:lnSpc>
-            </a:pPr>
+            </a:br>
             <a:r>
               <a:rPr lang="nb-NO" dirty="0"/>
-              <a:t>Også om målingen er over/under/mellom referanseverdier</a:t>
-            </a:r>
-          </a:p>
-          <a:p>
-            <a:pPr>
-              <a:lnSpc>
-                <a:spcPts val="4200"/>
-              </a:lnSpc>
+              <a:t>seg verdien i mindre steg</a:t>
+            </a:r>
+          </a:p>
+          <a:p>
+            <a:pPr marL="0" indent="0">
+              <a:buNone/>
             </a:pPr>
             <a:endParaRPr lang="nb-NO" dirty="0"/>
           </a:p>
@@ -6289,38 +5149,111 @@
       </p:sp>
       <p:pic>
         <p:nvPicPr>
-          <p:cNvPr id="7" name="Bilde 6">
-            <a:extLst>
-              <a:ext uri="{FF2B5EF4-FFF2-40B4-BE49-F238E27FC236}">
-                <a16:creationId xmlns:a16="http://schemas.microsoft.com/office/drawing/2014/main" id="{5D21904E-8171-77E5-7F03-D60ED5DB90F4}"/>
+          <p:cNvPr id="2050" name="Picture 2">
+            <a:extLst>
+              <a:ext uri="{FF2B5EF4-FFF2-40B4-BE49-F238E27FC236}">
+                <a16:creationId xmlns:a16="http://schemas.microsoft.com/office/drawing/2014/main" id="{DCEADE59-FD6F-4D3A-883B-16A06F5796E3}"/>
               </a:ext>
             </a:extLst>
           </p:cNvPr>
           <p:cNvPicPr>
-            <a:picLocks noChangeAspect="1"/>
+            <a:picLocks noChangeAspect="1" noChangeArrowheads="1"/>
           </p:cNvPicPr>
           <p:nvPr/>
         </p:nvPicPr>
-        <p:blipFill>
-          <a:blip r:embed="rId2"/>
+        <p:blipFill rotWithShape="1">
+          <a:blip r:embed="rId2">
+            <a:extLst>
+              <a:ext uri="{28A0092B-C50C-407E-A947-70E740481C1C}">
+                <a14:useLocalDpi xmlns:a14="http://schemas.microsoft.com/office/drawing/2010/main" val="0"/>
+              </a:ext>
+            </a:extLst>
+          </a:blip>
+          <a:srcRect t="13334"/>
           <a:stretch>
             <a:fillRect/>
           </a:stretch>
         </p:blipFill>
-        <p:spPr>
+        <p:spPr bwMode="auto">
           <a:xfrm>
-            <a:off x="1732935" y="4480078"/>
-            <a:ext cx="8220778" cy="2682570"/>
+            <a:off x="5643721" y="1690688"/>
+            <a:ext cx="6202839" cy="4248669"/>
           </a:xfrm>
           <a:prstGeom prst="rect">
             <a:avLst/>
           </a:prstGeom>
+          <a:noFill/>
+          <a:extLst>
+            <a:ext uri="{909E8E84-426E-40DD-AFC4-6F175D3DCCD1}">
+              <a14:hiddenFill xmlns:a14="http://schemas.microsoft.com/office/drawing/2010/main">
+                <a:solidFill>
+                  <a:srgbClr val="FFFFFF"/>
+                </a:solidFill>
+              </a14:hiddenFill>
+            </a:ext>
+          </a:extLst>
         </p:spPr>
       </p:pic>
+      <p:sp>
+        <p:nvSpPr>
+          <p:cNvPr id="4" name="TekstSylinder 3">
+            <a:extLst>
+              <a:ext uri="{FF2B5EF4-FFF2-40B4-BE49-F238E27FC236}">
+                <a16:creationId xmlns:a16="http://schemas.microsoft.com/office/drawing/2014/main" id="{410B0CC8-2A18-5047-D6F6-132BB837A8FF}"/>
+              </a:ext>
+            </a:extLst>
+          </p:cNvPr>
+          <p:cNvSpPr txBox="1"/>
+          <p:nvPr/>
+        </p:nvSpPr>
+        <p:spPr>
+          <a:xfrm>
+            <a:off x="4033520" y="6211669"/>
+            <a:ext cx="8265148" cy="646331"/>
+          </a:xfrm>
+          <a:prstGeom prst="rect">
+            <a:avLst/>
+          </a:prstGeom>
+          <a:noFill/>
+        </p:spPr>
+        <p:txBody>
+          <a:bodyPr wrap="none" rtlCol="0">
+            <a:spAutoFit/>
+          </a:bodyPr>
+          <a:lstStyle/>
+          <a:p>
+            <a:pPr algn="ctr"/>
+            <a:r>
+              <a:rPr lang="nb-NO" dirty="0"/>
+              <a:t>Animasjon av </a:t>
+            </a:r>
+            <a:r>
+              <a:rPr lang="nb-NO" dirty="0" err="1"/>
+              <a:t>Uwezi</a:t>
+            </a:r>
+            <a:r>
+              <a:rPr lang="nb-NO" dirty="0"/>
+              <a:t>, </a:t>
+            </a:r>
+          </a:p>
+          <a:p>
+            <a:r>
+              <a:rPr lang="nb-NO" dirty="0">
+                <a:hlinkClick r:id="rId3"/>
+              </a:rPr>
+              <a:t>https://en.wikipedia.org/wiki/Successive-approximation_ADC</a:t>
+            </a:r>
+            <a:r>
+              <a:rPr lang="nb-NO" dirty="0"/>
+              <a:t> (hentet 13.03.2026)</a:t>
+            </a:r>
+          </a:p>
+        </p:txBody>
+      </p:sp>
     </p:spTree>
     <p:extLst>
       <p:ext uri="{BB962C8B-B14F-4D97-AF65-F5344CB8AC3E}">
-        <p14:creationId xmlns:p14="http://schemas.microsoft.com/office/powerpoint/2010/main" val="3155134844"/>
+        <p14:creationId xmlns:p14="http://schemas.microsoft.com/office/powerpoint/2010/main" val="1171314811"/>
       </p:ext>
     </p:extLst>
   </p:cSld>
@@ -6352,7 +5285,7 @@
           <p:cNvPr id="2" name="Tittel 1">
             <a:extLst>
               <a:ext uri="{FF2B5EF4-FFF2-40B4-BE49-F238E27FC236}">
-                <a16:creationId xmlns:a16="http://schemas.microsoft.com/office/drawing/2014/main" id="{454B47F0-0A6E-C15C-A97D-CB63FAFD33B0}"/>
+                <a16:creationId xmlns:a16="http://schemas.microsoft.com/office/drawing/2014/main" id="{6287AB4D-FBC1-DE6B-F806-E6B2EC6AAF9E}"/>
               </a:ext>
             </a:extLst>
           </p:cNvPr>
@@ -6370,7 +5303,7 @@
           <a:p>
             <a:r>
               <a:rPr lang="nb-NO" dirty="0"/>
-              <a:t>Virkemåte</a:t>
+              <a:t>Konfigurering - MCC</a:t>
             </a:r>
           </a:p>
         </p:txBody>
@@ -6380,7 +5313,7 @@
           <p:cNvPr id="3" name="Plassholder for innhold 2">
             <a:extLst>
               <a:ext uri="{FF2B5EF4-FFF2-40B4-BE49-F238E27FC236}">
-                <a16:creationId xmlns:a16="http://schemas.microsoft.com/office/drawing/2014/main" id="{34B09470-779E-C63D-ADDE-B2C92CEC69A9}"/>
+                <a16:creationId xmlns:a16="http://schemas.microsoft.com/office/drawing/2014/main" id="{52BBE370-2AFA-931B-E991-D2534F9AA97D}"/>
               </a:ext>
             </a:extLst>
           </p:cNvPr>
@@ -6397,153 +5330,77 @@
           <a:lstStyle/>
           <a:p>
             <a:r>
-              <a:rPr lang="nb-NO" dirty="0" err="1"/>
-              <a:t>Successive</a:t>
-            </a:r>
-            <a:r>
               <a:rPr lang="nb-NO" dirty="0"/>
-              <a:t> </a:t>
-            </a:r>
-            <a:r>
-              <a:rPr lang="nb-NO" dirty="0" err="1"/>
-              <a:t>approximation</a:t>
-            </a:r>
-            <a:br>
-              <a:rPr lang="nb-NO" dirty="0"/>
-            </a:br>
-            <a:r>
-              <a:rPr lang="nb-NO" dirty="0"/>
-              <a:t>(SAR)</a:t>
-            </a:r>
-          </a:p>
-          <a:p>
-            <a:r>
-              <a:rPr lang="nb-NO" dirty="0"/>
-              <a:t>Bruker en DAC for å tilnærme</a:t>
-            </a:r>
-            <a:br>
-              <a:rPr lang="nb-NO" dirty="0"/>
-            </a:br>
-            <a:r>
-              <a:rPr lang="nb-NO" dirty="0"/>
-              <a:t>seg verdien i mindre steg</a:t>
-            </a:r>
-          </a:p>
-          <a:p>
-            <a:pPr marL="0" indent="0">
-              <a:buNone/>
-            </a:pPr>
-            <a:endParaRPr lang="nb-NO" dirty="0"/>
+              <a:t>Legg til ADC som komponent</a:t>
+            </a:r>
           </a:p>
         </p:txBody>
       </p:sp>
       <p:pic>
         <p:nvPicPr>
-          <p:cNvPr id="2050" name="Picture 2">
-            <a:extLst>
-              <a:ext uri="{FF2B5EF4-FFF2-40B4-BE49-F238E27FC236}">
-                <a16:creationId xmlns:a16="http://schemas.microsoft.com/office/drawing/2014/main" id="{DCEADE59-FD6F-4D3A-883B-16A06F5796E3}"/>
+          <p:cNvPr id="5" name="Bilde 4">
+            <a:extLst>
+              <a:ext uri="{FF2B5EF4-FFF2-40B4-BE49-F238E27FC236}">
+                <a16:creationId xmlns:a16="http://schemas.microsoft.com/office/drawing/2014/main" id="{E4A6B338-0160-ABCB-2C33-D032A4DDE7E1}"/>
               </a:ext>
             </a:extLst>
           </p:cNvPr>
           <p:cNvPicPr>
-            <a:picLocks noChangeAspect="1" noChangeArrowheads="1"/>
+            <a:picLocks noChangeAspect="1"/>
           </p:cNvPicPr>
           <p:nvPr/>
         </p:nvPicPr>
-        <p:blipFill rotWithShape="1">
-          <a:blip r:embed="rId2">
-            <a:extLst>
-              <a:ext uri="{28A0092B-C50C-407E-A947-70E740481C1C}">
-                <a14:useLocalDpi xmlns:a14="http://schemas.microsoft.com/office/drawing/2010/main" val="0"/>
-              </a:ext>
-            </a:extLst>
-          </a:blip>
-          <a:srcRect t="13334"/>
+        <p:blipFill>
+          <a:blip r:embed="rId2"/>
           <a:stretch>
             <a:fillRect/>
           </a:stretch>
         </p:blipFill>
-        <p:spPr bwMode="auto">
+        <p:spPr>
           <a:xfrm>
-            <a:off x="5643721" y="1690688"/>
-            <a:ext cx="6202839" cy="4248669"/>
+            <a:off x="152400" y="4922280"/>
+            <a:ext cx="9929720" cy="1905165"/>
           </a:xfrm>
           <a:prstGeom prst="rect">
             <a:avLst/>
           </a:prstGeom>
-          <a:noFill/>
-          <a:extLst>
-            <a:ext uri="{909E8E84-426E-40DD-AFC4-6F175D3DCCD1}">
-              <a14:hiddenFill xmlns:a14="http://schemas.microsoft.com/office/drawing/2010/main">
-                <a:solidFill>
-                  <a:srgbClr val="FFFFFF"/>
-                </a:solidFill>
-              </a14:hiddenFill>
-            </a:ext>
-          </a:extLst>
         </p:spPr>
       </p:pic>
-      <p:sp>
-        <p:nvSpPr>
-          <p:cNvPr id="4" name="TekstSylinder 3">
-            <a:extLst>
-              <a:ext uri="{FF2B5EF4-FFF2-40B4-BE49-F238E27FC236}">
-                <a16:creationId xmlns:a16="http://schemas.microsoft.com/office/drawing/2014/main" id="{410B0CC8-2A18-5047-D6F6-132BB837A8FF}"/>
-              </a:ext>
-            </a:extLst>
-          </p:cNvPr>
-          <p:cNvSpPr txBox="1"/>
+      <p:pic>
+        <p:nvPicPr>
+          <p:cNvPr id="7" name="Bilde 6">
+            <a:extLst>
+              <a:ext uri="{FF2B5EF4-FFF2-40B4-BE49-F238E27FC236}">
+                <a16:creationId xmlns:a16="http://schemas.microsoft.com/office/drawing/2014/main" id="{BB5C1C8B-1D78-0384-5D81-8A619E87EC6A}"/>
+              </a:ext>
+            </a:extLst>
+          </p:cNvPr>
+          <p:cNvPicPr>
+            <a:picLocks noChangeAspect="1"/>
+          </p:cNvPicPr>
           <p:nvPr/>
-        </p:nvSpPr>
+        </p:nvPicPr>
+        <p:blipFill>
+          <a:blip r:embed="rId3"/>
+          <a:srcRect r="39600" b="25299"/>
+          <a:stretch>
+            <a:fillRect/>
+          </a:stretch>
+        </p:blipFill>
         <p:spPr>
           <a:xfrm>
-            <a:off x="4033520" y="6211669"/>
-            <a:ext cx="8265148" cy="646331"/>
+            <a:off x="6096000" y="1027906"/>
+            <a:ext cx="5546488" cy="3404235"/>
           </a:xfrm>
           <a:prstGeom prst="rect">
             <a:avLst/>
           </a:prstGeom>
-          <a:noFill/>
         </p:spPr>
-        <p:txBody>
-          <a:bodyPr wrap="none" rtlCol="0">
-            <a:spAutoFit/>
-          </a:bodyPr>
-          <a:lstStyle/>
-          <a:p>
-            <a:pPr algn="ctr"/>
-            <a:r>
-              <a:rPr lang="nb-NO" dirty="0"/>
-              <a:t>Animasjon av </a:t>
-            </a:r>
-            <a:r>
-              <a:rPr lang="nb-NO" dirty="0" err="1"/>
-              <a:t>Uwezi</a:t>
-            </a:r>
-            <a:r>
-              <a:rPr lang="nb-NO" dirty="0"/>
-              <a:t>, </a:t>
-            </a:r>
-          </a:p>
-          <a:p>
-            <a:r>
-              <a:rPr lang="nb-NO" dirty="0">
-                <a:hlinkClick r:id="rId3"/>
-              </a:rPr>
-              <a:t>https://en.wikipedia.org/wiki/Successive-approximation_ADC</a:t>
-            </a:r>
-            <a:r>
-              <a:rPr lang="nb-NO" dirty="0"/>
-              <a:t> (hentet 13.03.2026)</a:t>
-            </a:r>
-          </a:p>
-        </p:txBody>
-      </p:sp>
+      </p:pic>
     </p:spTree>
     <p:extLst>
       <p:ext uri="{BB962C8B-B14F-4D97-AF65-F5344CB8AC3E}">
-        <p14:creationId xmlns:p14="http://schemas.microsoft.com/office/powerpoint/2010/main" val="1171314811"/>
+        <p14:creationId xmlns:p14="http://schemas.microsoft.com/office/powerpoint/2010/main" val="523849282"/>
       </p:ext>
     </p:extLst>
   </p:cSld>
@@ -6866,319 +5723,4 @@
     </a:ext>
   </a:extLst>
 </a:theme>
-</file>
-
-<file path=ppt/theme/theme2.xml><?xml version="1.0" encoding="utf-8"?>
-<a:theme xmlns:a="http://schemas.openxmlformats.org/drawingml/2006/main" name="Office-tema">
-  <a:themeElements>
-    <a:clrScheme name="Office">
-      <a:dk1>
-        <a:sysClr val="windowText" lastClr="000000"/>
-      </a:dk1>
-      <a:lt1>
-        <a:sysClr val="window" lastClr="FFFFFF"/>
-      </a:lt1>
-      <a:dk2>
-        <a:srgbClr val="0E2841"/>
-      </a:dk2>
-      <a:lt2>
-        <a:srgbClr val="E8E8E8"/>
-      </a:lt2>
-      <a:accent1>
-        <a:srgbClr val="156082"/>
-      </a:accent1>
-      <a:accent2>
-        <a:srgbClr val="E97132"/>
-      </a:accent2>
-      <a:accent3>
-        <a:srgbClr val="196B24"/>
-      </a:accent3>
-      <a:accent4>
-        <a:srgbClr val="0F9ED5"/>
-      </a:accent4>
-      <a:accent5>
-        <a:srgbClr val="A02B93"/>
-      </a:accent5>
-      <a:accent6>
-        <a:srgbClr val="4EA72E"/>
-      </a:accent6>
-      <a:hlink>
-        <a:srgbClr val="467886"/>
-      </a:hlink>
-      <a:folHlink>
-        <a:srgbClr val="96607D"/>
-      </a:folHlink>
-    </a:clrScheme>
-    <a:fontScheme name="Office">
-      <a:majorFont>
-        <a:latin typeface="Aptos Display" panose="02110004020202020204"/>
-        <a:ea typeface=""/>
-        <a:cs typeface=""/>
-        <a:font script="Jpan" typeface="游ゴシック Light"/>
-        <a:font script="Hang" typeface="맑은 고딕"/>
-        <a:font script="Hans" typeface="等线 Light"/>
-        <a:font script="Hant" typeface="新細明體"/>
-        <a:font script="Arab" typeface="Times New Roman"/>
-        <a:font script="Hebr" typeface="Times New Roman"/>
-        <a:font script="Thai" typeface="Angsana New"/>
-        <a:font script="Ethi" typeface="Nyala"/>
-        <a:font script="Beng" typeface="Vrinda"/>
-        <a:font script="Gujr" typeface="Shruti"/>
-        <a:font script="Khmr" typeface="MoolBoran"/>
-        <a:font script="Knda" typeface="Tunga"/>
-        <a:font script="Guru" typeface="Raavi"/>
-        <a:font script="Cans" typeface="Euphemia"/>
-        <a:font script="Cher" typeface="Plantagenet Cherokee"/>
-        <a:font script="Yiii" typeface="Microsoft Yi Baiti"/>
-        <a:font script="Tibt" typeface="Microsoft Himalaya"/>
-        <a:font script="Thaa" typeface="MV Boli"/>
-        <a:font script="Deva" typeface="Mangal"/>
-        <a:font script="Telu" typeface="Gautami"/>
-        <a:font script="Taml" typeface="Latha"/>
-        <a:font script="Syrc" typeface="Estrangelo Edessa"/>
-        <a:font script="Orya" typeface="Kalinga"/>
-        <a:font script="Mlym" typeface="Kartika"/>
-        <a:font script="Laoo" typeface="DokChampa"/>
-        <a:font script="Sinh" typeface="Iskoola Pota"/>
-        <a:font script="Mong" typeface="Mongolian Baiti"/>
-        <a:font script="Viet" typeface="Times New Roman"/>
-        <a:font script="Uigh" typeface="Microsoft Uighur"/>
-        <a:font script="Geor" typeface="Sylfaen"/>
-        <a:font script="Armn" typeface="Arial"/>
-        <a:font script="Bugi" typeface="Leelawadee UI"/>
-        <a:font script="Bopo" typeface="Microsoft JhengHei"/>
-        <a:font script="Java" typeface="Javanese Text"/>
-        <a:font script="Lisu" typeface="Segoe UI"/>
-        <a:font script="Mymr" typeface="Myanmar Text"/>
-        <a:font script="Nkoo" typeface="Ebrima"/>
-        <a:font script="Olck" typeface="Nirmala UI"/>
-        <a:font script="Osma" typeface="Ebrima"/>
-        <a:font script="Phag" typeface="Phagspa"/>
-        <a:font script="Syrn" typeface="Estrangelo Edessa"/>
-        <a:font script="Syrj" typeface="Estrangelo Edessa"/>
-        <a:font script="Syre" typeface="Estrangelo Edessa"/>
-        <a:font script="Sora" typeface="Nirmala UI"/>
-        <a:font script="Tale" typeface="Microsoft Tai Le"/>
-        <a:font script="Talu" typeface="Microsoft New Tai Lue"/>
-        <a:font script="Tfng" typeface="Ebrima"/>
-      </a:majorFont>
-      <a:minorFont>
-        <a:latin typeface="Aptos" panose="02110004020202020204"/>
-        <a:ea typeface=""/>
-        <a:cs typeface=""/>
-        <a:font script="Jpan" typeface="游ゴシック"/>
-        <a:font script="Hang" typeface="맑은 고딕"/>
-        <a:font script="Hans" typeface="等线"/>
-        <a:font script="Hant" typeface="新細明體"/>
-        <a:font script="Arab" typeface="Arial"/>
-        <a:font script="Hebr" typeface="Arial"/>
-        <a:font script="Thai" typeface="Cordia New"/>
-        <a:font script="Ethi" typeface="Nyala"/>
-        <a:font script="Beng" typeface="Vrinda"/>
-        <a:font script="Gujr" typeface="Shruti"/>
-        <a:font script="Khmr" typeface="DaunPenh"/>
-        <a:font script="Knda" typeface="Tunga"/>
-        <a:font script="Guru" typeface="Raavi"/>
-        <a:font script="Cans" typeface="Euphemia"/>
-        <a:font script="Cher" typeface="Plantagenet Cherokee"/>
-        <a:font script="Yiii" typeface="Microsoft Yi Baiti"/>
-        <a:font script="Tibt" typeface="Microsoft Himalaya"/>
-        <a:font script="Thaa" typeface="MV Boli"/>
-        <a:font script="Deva" typeface="Mangal"/>
-        <a:font script="Telu" typeface="Gautami"/>
-        <a:font script="Taml" typeface="Latha"/>
-        <a:font script="Syrc" typeface="Estrangelo Edessa"/>
-        <a:font script="Orya" typeface="Kalinga"/>
-        <a:font script="Mlym" typeface="Kartika"/>
-        <a:font script="Laoo" typeface="DokChampa"/>
-        <a:font script="Sinh" typeface="Iskoola Pota"/>
-        <a:font script="Mong" typeface="Mongolian Baiti"/>
-        <a:font script="Viet" typeface="Arial"/>
-        <a:font script="Uigh" typeface="Microsoft Uighur"/>
-        <a:font script="Geor" typeface="Sylfaen"/>
-        <a:font script="Armn" typeface="Arial"/>
-        <a:font script="Bugi" typeface="Leelawadee UI"/>
-        <a:font script="Bopo" typeface="Microsoft JhengHei"/>
-        <a:font script="Java" typeface="Javanese Text"/>
-        <a:font script="Lisu" typeface="Segoe UI"/>
-        <a:font script="Mymr" typeface="Myanmar Text"/>
-        <a:font script="Nkoo" typeface="Ebrima"/>
-        <a:font script="Olck" typeface="Nirmala UI"/>
-        <a:font script="Osma" typeface="Ebrima"/>
-        <a:font script="Phag" typeface="Phagspa"/>
-        <a:font script="Syrn" typeface="Estrangelo Edessa"/>
-        <a:font script="Syrj" typeface="Estrangelo Edessa"/>
-        <a:font script="Syre" typeface="Estrangelo Edessa"/>
-        <a:font script="Sora" typeface="Nirmala UI"/>
-        <a:font script="Tale" typeface="Microsoft Tai Le"/>
-        <a:font script="Talu" typeface="Microsoft New Tai Lue"/>
-        <a:font script="Tfng" typeface="Ebrima"/>
-      </a:minorFont>
-    </a:fontScheme>
-    <a:fmtScheme name="Office">
-      <a:fillStyleLst>
-        <a:solidFill>
-          <a:schemeClr val="phClr"/>
-        </a:solidFill>
-        <a:gradFill rotWithShape="1">
-          <a:gsLst>
-            <a:gs pos="0">
-              <a:schemeClr val="phClr">
-                <a:lumMod val="110000"/>
-                <a:satMod val="105000"/>
-                <a:tint val="67000"/>
-              </a:schemeClr>
-            </a:gs>
-            <a:gs pos="50000">
-              <a:schemeClr val="phClr">
-                <a:lumMod val="105000"/>
-                <a:satMod val="103000"/>
-                <a:tint val="73000"/>
-              </a:schemeClr>
-            </a:gs>
-            <a:gs pos="100000">
-              <a:schemeClr val="phClr">
-                <a:lumMod val="105000"/>
-                <a:satMod val="109000"/>
-                <a:tint val="81000"/>
-              </a:schemeClr>
-            </a:gs>
-          </a:gsLst>
-          <a:lin ang="5400000" scaled="0"/>
-        </a:gradFill>
-        <a:gradFill rotWithShape="1">
-          <a:gsLst>
-            <a:gs pos="0">
-              <a:schemeClr val="phClr">
-                <a:satMod val="103000"/>
-                <a:lumMod val="102000"/>
-                <a:tint val="94000"/>
-              </a:schemeClr>
-            </a:gs>
-            <a:gs pos="50000">
-              <a:schemeClr val="phClr">
-                <a:satMod val="110000"/>
-                <a:lumMod val="100000"/>
-                <a:shade val="100000"/>
-              </a:schemeClr>
-            </a:gs>
-            <a:gs pos="100000">
-              <a:schemeClr val="phClr">
-                <a:lumMod val="99000"/>
-                <a:satMod val="120000"/>
-                <a:shade val="78000"/>
-              </a:schemeClr>
-            </a:gs>
-          </a:gsLst>
-          <a:lin ang="5400000" scaled="0"/>
-        </a:gradFill>
-      </a:fillStyleLst>
-      <a:lnStyleLst>
-        <a:ln w="12700" cap="flat" cmpd="sng" algn="ctr">
-          <a:solidFill>
-            <a:schemeClr val="phClr"/>
-          </a:solidFill>
-          <a:prstDash val="solid"/>
-          <a:miter lim="800000"/>
-        </a:ln>
-        <a:ln w="19050" cap="flat" cmpd="sng" algn="ctr">
-          <a:solidFill>
-            <a:schemeClr val="phClr"/>
-          </a:solidFill>
-          <a:prstDash val="solid"/>
-          <a:miter lim="800000"/>
-        </a:ln>
-        <a:ln w="25400" cap="flat" cmpd="sng" algn="ctr">
-          <a:solidFill>
-            <a:schemeClr val="phClr"/>
-          </a:solidFill>
-          <a:prstDash val="solid"/>
-          <a:miter lim="800000"/>
-        </a:ln>
-      </a:lnStyleLst>
-      <a:effectStyleLst>
-        <a:effectStyle>
-          <a:effectLst/>
-        </a:effectStyle>
-        <a:effectStyle>
-          <a:effectLst/>
-        </a:effectStyle>
-        <a:effectStyle>
-          <a:effectLst>
-            <a:outerShdw blurRad="57150" dist="19050" dir="5400000" algn="ctr" rotWithShape="0">
-              <a:srgbClr val="000000">
-                <a:alpha val="63000"/>
-              </a:srgbClr>
-            </a:outerShdw>
-          </a:effectLst>
-        </a:effectStyle>
-      </a:effectStyleLst>
-      <a:bgFillStyleLst>
-        <a:solidFill>
-          <a:schemeClr val="phClr"/>
-        </a:solidFill>
-        <a:solidFill>
-          <a:schemeClr val="phClr">
-            <a:tint val="95000"/>
-            <a:satMod val="170000"/>
-          </a:schemeClr>
-        </a:solidFill>
-        <a:gradFill rotWithShape="1">
-          <a:gsLst>
-            <a:gs pos="0">
-              <a:schemeClr val="phClr">
-                <a:tint val="93000"/>
-                <a:satMod val="150000"/>
-                <a:shade val="98000"/>
-                <a:lumMod val="102000"/>
-              </a:schemeClr>
-            </a:gs>
-            <a:gs pos="50000">
-              <a:schemeClr val="phClr">
-                <a:tint val="98000"/>
-                <a:satMod val="130000"/>
-                <a:shade val="90000"/>
-                <a:lumMod val="103000"/>
-              </a:schemeClr>
-            </a:gs>
-            <a:gs pos="100000">
-              <a:schemeClr val="phClr">
-                <a:shade val="63000"/>
-                <a:satMod val="120000"/>
-              </a:schemeClr>
-            </a:gs>
-          </a:gsLst>
-          <a:lin ang="5400000" scaled="0"/>
-        </a:gradFill>
-      </a:bgFillStyleLst>
-    </a:fmtScheme>
-  </a:themeElements>
-  <a:objectDefaults>
-    <a:lnDef>
-      <a:spPr/>
-      <a:bodyPr/>
-      <a:lstStyle/>
-      <a:style>
-        <a:lnRef idx="2">
-          <a:schemeClr val="accent1"/>
-        </a:lnRef>
-        <a:fillRef idx="0">
-          <a:schemeClr val="accent1"/>
-        </a:fillRef>
-        <a:effectRef idx="1">
-          <a:schemeClr val="accent1"/>
-        </a:effectRef>
-        <a:fontRef idx="minor">
-          <a:schemeClr val="tx1"/>
-        </a:fontRef>
-      </a:style>
-    </a:lnDef>
-  </a:objectDefaults>
-  <a:extraClrSchemeLst/>
-  <a:extLst>
-    <a:ext uri="{05A4C25C-085E-4340-85A3-A5531E510DB2}">
-      <thm15:themeFamily xmlns:thm15="http://schemas.microsoft.com/office/thememl/2012/main" name="Office Theme" id="{2E142A2C-CD16-42D6-873A-C26D2A0506FA}" vid="{1BDDFF52-6CD6-40A5-AB3C-68EB2F1E4D0A}"/>
-    </a:ext>
-  </a:extLst>
-</a:theme>
 </file>
</xml_diff>

<commit_message>
Inkluderer datablad, oppdatert presentasjon
</commit_message>
<xml_diff>
--- a/Kursdag 2/Dag to.pptx
+++ b/Kursdag 2/Dag to.pptx
@@ -5,7 +5,7 @@
     <p:sldMasterId id="2147483648" r:id="rId1"/>
   </p:sldMasterIdLst>
   <p:notesMasterIdLst>
-    <p:notesMasterId r:id="rId20"/>
+    <p:notesMasterId r:id="rId22"/>
   </p:notesMasterIdLst>
   <p:sldIdLst>
     <p:sldId id="256" r:id="rId2"/>
@@ -25,7 +25,9 @@
     <p:sldId id="258" r:id="rId16"/>
     <p:sldId id="271" r:id="rId17"/>
     <p:sldId id="272" r:id="rId18"/>
-    <p:sldId id="273" r:id="rId19"/>
+    <p:sldId id="274" r:id="rId19"/>
+    <p:sldId id="275" r:id="rId20"/>
+    <p:sldId id="273" r:id="rId21"/>
   </p:sldIdLst>
   <p:sldSz cx="12192000" cy="6858000"/>
   <p:notesSz cx="6858000" cy="9144000"/>
@@ -214,7 +216,7 @@
           <a:p>
             <a:fld id="{ACB6A25B-A690-4E14-9ED0-D2ECF6431ED6}" type="datetimeFigureOut">
               <a:rPr lang="nb-NO" smtClean="0"/>
-              <a:t>14.03.2026</a:t>
+              <a:t>15.03.2026</a:t>
             </a:fld>
             <a:endParaRPr lang="nb-NO"/>
           </a:p>
@@ -549,7 +551,7 @@
           <a:p>
             <a:fld id="{56CEED96-8DE0-441C-B2ED-FF713A48F07D}" type="slidenum">
               <a:rPr lang="nb-NO" smtClean="0"/>
-              <a:t>18</a:t>
+              <a:t>20</a:t>
             </a:fld>
             <a:endParaRPr lang="nb-NO"/>
           </a:p>
@@ -715,7 +717,7 @@
           <a:p>
             <a:fld id="{B9F7994A-41AD-4027-8E6D-AD66A7C6695C}" type="datetimeFigureOut">
               <a:rPr lang="nb-NO" smtClean="0"/>
-              <a:t>14.03.2026</a:t>
+              <a:t>15.03.2026</a:t>
             </a:fld>
             <a:endParaRPr lang="nb-NO"/>
           </a:p>
@@ -913,7 +915,7 @@
           <a:p>
             <a:fld id="{B9F7994A-41AD-4027-8E6D-AD66A7C6695C}" type="datetimeFigureOut">
               <a:rPr lang="nb-NO" smtClean="0"/>
-              <a:t>14.03.2026</a:t>
+              <a:t>15.03.2026</a:t>
             </a:fld>
             <a:endParaRPr lang="nb-NO"/>
           </a:p>
@@ -1121,7 +1123,7 @@
           <a:p>
             <a:fld id="{B9F7994A-41AD-4027-8E6D-AD66A7C6695C}" type="datetimeFigureOut">
               <a:rPr lang="nb-NO" smtClean="0"/>
-              <a:t>14.03.2026</a:t>
+              <a:t>15.03.2026</a:t>
             </a:fld>
             <a:endParaRPr lang="nb-NO"/>
           </a:p>
@@ -1319,7 +1321,7 @@
           <a:p>
             <a:fld id="{B9F7994A-41AD-4027-8E6D-AD66A7C6695C}" type="datetimeFigureOut">
               <a:rPr lang="nb-NO" smtClean="0"/>
-              <a:t>14.03.2026</a:t>
+              <a:t>15.03.2026</a:t>
             </a:fld>
             <a:endParaRPr lang="nb-NO"/>
           </a:p>
@@ -1594,7 +1596,7 @@
           <a:p>
             <a:fld id="{B9F7994A-41AD-4027-8E6D-AD66A7C6695C}" type="datetimeFigureOut">
               <a:rPr lang="nb-NO" smtClean="0"/>
-              <a:t>14.03.2026</a:t>
+              <a:t>15.03.2026</a:t>
             </a:fld>
             <a:endParaRPr lang="nb-NO"/>
           </a:p>
@@ -1859,7 +1861,7 @@
           <a:p>
             <a:fld id="{B9F7994A-41AD-4027-8E6D-AD66A7C6695C}" type="datetimeFigureOut">
               <a:rPr lang="nb-NO" smtClean="0"/>
-              <a:t>14.03.2026</a:t>
+              <a:t>15.03.2026</a:t>
             </a:fld>
             <a:endParaRPr lang="nb-NO"/>
           </a:p>
@@ -2271,7 +2273,7 @@
           <a:p>
             <a:fld id="{B9F7994A-41AD-4027-8E6D-AD66A7C6695C}" type="datetimeFigureOut">
               <a:rPr lang="nb-NO" smtClean="0"/>
-              <a:t>14.03.2026</a:t>
+              <a:t>15.03.2026</a:t>
             </a:fld>
             <a:endParaRPr lang="nb-NO"/>
           </a:p>
@@ -2412,7 +2414,7 @@
           <a:p>
             <a:fld id="{B9F7994A-41AD-4027-8E6D-AD66A7C6695C}" type="datetimeFigureOut">
               <a:rPr lang="nb-NO" smtClean="0"/>
-              <a:t>14.03.2026</a:t>
+              <a:t>15.03.2026</a:t>
             </a:fld>
             <a:endParaRPr lang="nb-NO"/>
           </a:p>
@@ -2525,7 +2527,7 @@
           <a:p>
             <a:fld id="{B9F7994A-41AD-4027-8E6D-AD66A7C6695C}" type="datetimeFigureOut">
               <a:rPr lang="nb-NO" smtClean="0"/>
-              <a:t>14.03.2026</a:t>
+              <a:t>15.03.2026</a:t>
             </a:fld>
             <a:endParaRPr lang="nb-NO"/>
           </a:p>
@@ -2836,7 +2838,7 @@
           <a:p>
             <a:fld id="{B9F7994A-41AD-4027-8E6D-AD66A7C6695C}" type="datetimeFigureOut">
               <a:rPr lang="nb-NO" smtClean="0"/>
-              <a:t>14.03.2026</a:t>
+              <a:t>15.03.2026</a:t>
             </a:fld>
             <a:endParaRPr lang="nb-NO"/>
           </a:p>
@@ -3124,7 +3126,7 @@
           <a:p>
             <a:fld id="{B9F7994A-41AD-4027-8E6D-AD66A7C6695C}" type="datetimeFigureOut">
               <a:rPr lang="nb-NO" smtClean="0"/>
-              <a:t>14.03.2026</a:t>
+              <a:t>15.03.2026</a:t>
             </a:fld>
             <a:endParaRPr lang="nb-NO"/>
           </a:p>
@@ -3365,7 +3367,7 @@
           <a:p>
             <a:fld id="{B9F7994A-41AD-4027-8E6D-AD66A7C6695C}" type="datetimeFigureOut">
               <a:rPr lang="nb-NO" smtClean="0"/>
-              <a:t>14.03.2026</a:t>
+              <a:t>15.03.2026</a:t>
             </a:fld>
             <a:endParaRPr lang="nb-NO"/>
           </a:p>
@@ -4748,7 +4750,7 @@
           <a:p>
             <a:r>
               <a:rPr lang="nb-NO" dirty="0"/>
-              <a:t>I16-biters register</a:t>
+              <a:t>16-biters register</a:t>
             </a:r>
           </a:p>
           <a:p>
@@ -4969,7 +4971,7 @@
             <a:pPr lvl="1"/>
             <a:r>
               <a:rPr lang="nb-NO" dirty="0"/>
-              <a:t>Tell antall knappetrykk og utfør kommando når det passerer 20</a:t>
+              <a:t>Tell antall knappetrykk og utfør kommando etter 20 trykk</a:t>
             </a:r>
           </a:p>
         </p:txBody>
@@ -5027,7 +5029,7 @@
           <a:p>
             <a:r>
               <a:rPr lang="nb-NO" dirty="0"/>
-              <a:t>Timer – Denne er litt lang, bør deles, fler bilder</a:t>
+              <a:t>Timer</a:t>
             </a:r>
           </a:p>
         </p:txBody>
@@ -5053,9 +5055,14 @@
           <a:bodyPr/>
           <a:lstStyle/>
           <a:p>
-            <a:r>
-              <a:rPr lang="nb-NO" dirty="0"/>
-              <a:t>Teller oppover per </a:t>
+            <a:pPr>
+              <a:lnSpc>
+                <a:spcPct val="150000"/>
+              </a:lnSpc>
+            </a:pPr>
+            <a:r>
+              <a:rPr lang="nb-NO" dirty="0"/>
+              <a:t>Teller per </a:t>
             </a:r>
             <a:r>
               <a:rPr lang="nb-NO" i="1" dirty="0"/>
@@ -5063,71 +5070,87 @@
             </a:r>
             <a:r>
               <a:rPr lang="nb-NO" dirty="0"/>
-              <a:t> antall klokkeslag</a:t>
-            </a:r>
-          </a:p>
-          <a:p>
+              <a:t> klokkeslag</a:t>
+            </a:r>
+          </a:p>
+          <a:p>
+            <a:pPr>
+              <a:lnSpc>
+                <a:spcPct val="150000"/>
+              </a:lnSpc>
+            </a:pPr>
             <a:r>
               <a:rPr lang="nb-NO" dirty="0"/>
               <a:t>Egen klokke, skjer automatisk</a:t>
             </a:r>
           </a:p>
           <a:p>
-            <a:r>
-              <a:rPr lang="nb-NO" i="1" dirty="0"/>
-              <a:t>n </a:t>
-            </a:r>
-            <a:r>
-              <a:rPr lang="nb-NO" dirty="0"/>
-              <a:t>gis av </a:t>
+            <a:pPr>
+              <a:lnSpc>
+                <a:spcPct val="150000"/>
+              </a:lnSpc>
+            </a:pPr>
+            <a:r>
+              <a:rPr lang="nb-NO" dirty="0"/>
+              <a:t>Perioden settes i </a:t>
             </a:r>
             <a:r>
               <a:rPr lang="nb-NO" dirty="0" err="1"/>
-              <a:t>prescaler</a:t>
-            </a:r>
-            <a:r>
-              <a:rPr lang="nb-NO" dirty="0"/>
-              <a:t>, hvor mange ganger skal klokkesignalet </a:t>
-            </a:r>
+              <a:t>TCAn.PER</a:t>
+            </a:r>
+            <a:r>
+              <a:rPr lang="nb-NO" dirty="0"/>
+              <a:t>-register</a:t>
+            </a:r>
+          </a:p>
+          <a:p>
+            <a:pPr lvl="1">
+              <a:lnSpc>
+                <a:spcPct val="150000"/>
+              </a:lnSpc>
+            </a:pPr>
             <a:r>
               <a:rPr lang="nb-NO" dirty="0" err="1"/>
-              <a:t>halvveres</a:t>
-            </a:r>
-            <a:endParaRPr lang="nb-NO" dirty="0"/>
-          </a:p>
-          <a:p>
-            <a:pPr lvl="1"/>
-            <a:r>
-              <a:rPr lang="nb-NO" i="1" dirty="0"/>
-              <a:t>n = </a:t>
-            </a:r>
-            <a:r>
-              <a:rPr lang="nb-NO" dirty="0"/>
-              <a:t>2, 4, 8, 16, 32…</a:t>
-            </a:r>
-          </a:p>
-          <a:p>
-            <a:r>
-              <a:rPr lang="nb-NO" dirty="0"/>
-              <a:t>Lengre periode, lavere oppløsning</a:t>
-            </a:r>
-          </a:p>
-          <a:p>
-            <a:r>
-              <a:rPr lang="nb-NO" dirty="0"/>
-              <a:t>Flere </a:t>
-            </a:r>
-            <a:r>
-              <a:rPr lang="nb-NO" dirty="0" err="1"/>
-              <a:t>interrupts</a:t>
-            </a:r>
-            <a:r>
-              <a:rPr lang="nb-NO" dirty="0"/>
-              <a:t>, utføring av kommandoer med presis </a:t>
-            </a:r>
-          </a:p>
-        </p:txBody>
-      </p:sp>
+              <a:t>Overflow</a:t>
+            </a:r>
+            <a:r>
+              <a:rPr lang="nb-NO" dirty="0"/>
+              <a:t>-vektor</a:t>
+            </a:r>
+          </a:p>
+        </p:txBody>
+      </p:sp>
+      <p:pic>
+        <p:nvPicPr>
+          <p:cNvPr id="5" name="Bilde 4">
+            <a:extLst>
+              <a:ext uri="{FF2B5EF4-FFF2-40B4-BE49-F238E27FC236}">
+                <a16:creationId xmlns:a16="http://schemas.microsoft.com/office/drawing/2014/main" id="{64AD719D-FA67-8E85-B1F7-6890731244A2}"/>
+              </a:ext>
+            </a:extLst>
+          </p:cNvPr>
+          <p:cNvPicPr>
+            <a:picLocks noChangeAspect="1"/>
+          </p:cNvPicPr>
+          <p:nvPr/>
+        </p:nvPicPr>
+        <p:blipFill>
+          <a:blip r:embed="rId2"/>
+          <a:srcRect l="10561" b="5412"/>
+          <a:stretch>
+            <a:fillRect/>
+          </a:stretch>
+        </p:blipFill>
+        <p:spPr>
+          <a:xfrm>
+            <a:off x="6646607" y="3248178"/>
+            <a:ext cx="4471219" cy="2749500"/>
+          </a:xfrm>
+          <a:prstGeom prst="rect">
+            <a:avLst/>
+          </a:prstGeom>
+        </p:spPr>
+      </p:pic>
     </p:spTree>
     <p:extLst>
       <p:ext uri="{BB962C8B-B14F-4D97-AF65-F5344CB8AC3E}">
@@ -5163,7 +5186,7 @@
           <p:cNvPr id="2" name="Tittel 1">
             <a:extLst>
               <a:ext uri="{FF2B5EF4-FFF2-40B4-BE49-F238E27FC236}">
-                <a16:creationId xmlns:a16="http://schemas.microsoft.com/office/drawing/2014/main" id="{89114275-8F53-5A5B-0B26-723B5F426A45}"/>
+                <a16:creationId xmlns:a16="http://schemas.microsoft.com/office/drawing/2014/main" id="{AFE61F01-F3B9-E489-C152-EC87895E64C8}"/>
               </a:ext>
             </a:extLst>
           </p:cNvPr>
@@ -5181,8 +5204,13 @@
           <a:p>
             <a:r>
               <a:rPr lang="nb-NO" dirty="0"/>
-              <a:t>USART/UART</a:t>
-            </a:r>
+              <a:t>Timer – </a:t>
+            </a:r>
+            <a:r>
+              <a:rPr lang="nb-NO" dirty="0" err="1"/>
+              <a:t>Prescaler</a:t>
+            </a:r>
+            <a:endParaRPr lang="nb-NO" dirty="0"/>
           </a:p>
         </p:txBody>
       </p:sp>
@@ -5191,7 +5219,7 @@
           <p:cNvPr id="3" name="Plassholder for innhold 2">
             <a:extLst>
               <a:ext uri="{FF2B5EF4-FFF2-40B4-BE49-F238E27FC236}">
-                <a16:creationId xmlns:a16="http://schemas.microsoft.com/office/drawing/2014/main" id="{3D304FCB-FCE3-5BD9-D7F2-4E5117B9370A}"/>
+                <a16:creationId xmlns:a16="http://schemas.microsoft.com/office/drawing/2014/main" id="{6F0EDD46-31C5-A483-9333-A2ADF625D80B}"/>
               </a:ext>
             </a:extLst>
           </p:cNvPr>
@@ -5202,90 +5230,203 @@
             <p:ph idx="1"/>
           </p:nvPr>
         </p:nvSpPr>
-        <p:spPr/>
-        <p:txBody>
-          <a:bodyPr/>
-          <a:lstStyle/>
-          <a:p>
-            <a:r>
-              <a:rPr lang="nb-NO" dirty="0"/>
-              <a:t>Universal (</a:t>
-            </a:r>
+        <p:spPr>
+          <a:xfrm>
+            <a:off x="6251074" y="1690688"/>
+            <a:ext cx="10515600" cy="4351338"/>
+          </a:xfrm>
+        </p:spPr>
+        <p:txBody>
+          <a:bodyPr/>
+          <a:lstStyle/>
+          <a:p>
+            <a:pPr>
+              <a:lnSpc>
+                <a:spcPct val="150000"/>
+              </a:lnSpc>
+            </a:pPr>
             <a:r>
               <a:rPr lang="nb-NO" dirty="0" err="1"/>
-              <a:t>Synchronous</a:t>
-            </a:r>
-            <a:r>
-              <a:rPr lang="nb-NO" dirty="0"/>
-              <a:t>/)</a:t>
+              <a:t>Timeren</a:t>
+            </a:r>
+            <a:r>
+              <a:rPr lang="nb-NO" dirty="0"/>
+              <a:t> teller opp per </a:t>
+            </a:r>
+            <a:r>
+              <a:rPr lang="nb-NO" i="1"/>
+              <a:t>n </a:t>
+            </a:r>
+            <a:r>
+              <a:rPr lang="nb-NO"/>
+              <a:t>klokkeslag</a:t>
+            </a:r>
+            <a:endParaRPr lang="nb-NO" dirty="0"/>
+          </a:p>
+          <a:p>
+            <a:pPr>
+              <a:lnSpc>
+                <a:spcPct val="150000"/>
+              </a:lnSpc>
+            </a:pPr>
+            <a:r>
+              <a:rPr lang="nb-NO" dirty="0"/>
+              <a:t>Lengre periode, lavere oppløsning</a:t>
+            </a:r>
+          </a:p>
+          <a:p>
+            <a:pPr>
+              <a:lnSpc>
+                <a:spcPct val="150000"/>
+              </a:lnSpc>
+            </a:pPr>
+            <a:r>
+              <a:rPr lang="nb-NO" dirty="0"/>
+              <a:t>Flere </a:t>
             </a:r>
             <a:r>
               <a:rPr lang="nb-NO" dirty="0" err="1"/>
-              <a:t>Asynchronous</a:t>
-            </a:r>
-            <a:r>
-              <a:rPr lang="nb-NO" dirty="0"/>
-              <a:t> </a:t>
-            </a:r>
-            <a:r>
-              <a:rPr lang="nb-NO" dirty="0" err="1"/>
-              <a:t>Reciever</a:t>
-            </a:r>
-            <a:r>
-              <a:rPr lang="nb-NO" dirty="0"/>
-              <a:t>-Transmitter</a:t>
-            </a:r>
-          </a:p>
-          <a:p>
-            <a:r>
-              <a:rPr lang="nb-NO" dirty="0"/>
-              <a:t>Seriell kommunikasjonsprotokoll</a:t>
-            </a:r>
-          </a:p>
-          <a:p>
-            <a:r>
-              <a:rPr lang="nb-NO" dirty="0"/>
-              <a:t>Rx og </a:t>
-            </a:r>
-            <a:r>
-              <a:rPr lang="nb-NO" dirty="0" err="1"/>
-              <a:t>Tx</a:t>
-            </a:r>
-            <a:r>
-              <a:rPr lang="nb-NO" dirty="0"/>
-              <a:t> (Full Duplex) eller én leder(Halv Duplex)</a:t>
-            </a:r>
-          </a:p>
-          <a:p>
-            <a:r>
-              <a:rPr lang="nb-NO" dirty="0"/>
-              <a:t>Forhåndsgitt baud</a:t>
-            </a:r>
-          </a:p>
-          <a:p>
-            <a:pPr lvl="1"/>
-            <a:r>
-              <a:rPr lang="nb-NO" dirty="0"/>
-              <a:t>Baud = bits/sekund</a:t>
-            </a:r>
-          </a:p>
-          <a:p>
-            <a:pPr lvl="1"/>
+              <a:t>interrupts</a:t>
+            </a:r>
+            <a:r>
+              <a:rPr lang="nb-NO" dirty="0"/>
+              <a:t>, presis utføring av </a:t>
+            </a:r>
+            <a:br>
+              <a:rPr lang="nb-NO" dirty="0"/>
+            </a:br>
+            <a:r>
+              <a:rPr lang="nb-NO" dirty="0"/>
+              <a:t>kommandoer</a:t>
+            </a:r>
+          </a:p>
+          <a:p>
+            <a:pPr>
+              <a:lnSpc>
+                <a:spcPct val="150000"/>
+              </a:lnSpc>
+            </a:pPr>
             <a:endParaRPr lang="nb-NO" dirty="0"/>
           </a:p>
-          <a:p>
-            <a:r>
-              <a:rPr lang="nb-NO"/>
-              <a:t>Sende informasjon til </a:t>
-            </a:r>
-            <a:endParaRPr lang="nb-NO" dirty="0"/>
-          </a:p>
-        </p:txBody>
-      </p:sp>
+        </p:txBody>
+      </p:sp>
+      <p:pic>
+        <p:nvPicPr>
+          <p:cNvPr id="5" name="Bilde 4">
+            <a:extLst>
+              <a:ext uri="{FF2B5EF4-FFF2-40B4-BE49-F238E27FC236}">
+                <a16:creationId xmlns:a16="http://schemas.microsoft.com/office/drawing/2014/main" id="{90EFDC00-2492-CBB8-A819-FD4C2DFD4523}"/>
+              </a:ext>
+            </a:extLst>
+          </p:cNvPr>
+          <p:cNvPicPr>
+            <a:picLocks noChangeAspect="1"/>
+          </p:cNvPicPr>
+          <p:nvPr/>
+        </p:nvPicPr>
+        <p:blipFill>
+          <a:blip r:embed="rId2"/>
+          <a:stretch>
+            <a:fillRect/>
+          </a:stretch>
+        </p:blipFill>
+        <p:spPr>
+          <a:xfrm>
+            <a:off x="331434" y="1638250"/>
+            <a:ext cx="5838254" cy="3581499"/>
+          </a:xfrm>
+          <a:prstGeom prst="rect">
+            <a:avLst/>
+          </a:prstGeom>
+        </p:spPr>
+      </p:pic>
     </p:spTree>
     <p:extLst>
       <p:ext uri="{BB962C8B-B14F-4D97-AF65-F5344CB8AC3E}">
-        <p14:creationId xmlns:p14="http://schemas.microsoft.com/office/powerpoint/2010/main" val="979311525"/>
+        <p14:creationId xmlns:p14="http://schemas.microsoft.com/office/powerpoint/2010/main" val="1087975376"/>
+      </p:ext>
+    </p:extLst>
+  </p:cSld>
+  <p:clrMapOvr>
+    <a:masterClrMapping/>
+  </p:clrMapOvr>
+</p:sld>
+</file>
+
+<file path=ppt/slides/slide19.xml><?xml version="1.0" encoding="utf-8"?>
+<p:sld xmlns:a="http://schemas.openxmlformats.org/drawingml/2006/main" xmlns:r="http://schemas.openxmlformats.org/officeDocument/2006/relationships" xmlns:p="http://schemas.openxmlformats.org/presentationml/2006/main">
+  <p:cSld>
+    <p:spTree>
+      <p:nvGrpSpPr>
+        <p:cNvPr id="1" name=""/>
+        <p:cNvGrpSpPr/>
+        <p:nvPr/>
+      </p:nvGrpSpPr>
+      <p:grpSpPr>
+        <a:xfrm>
+          <a:off x="0" y="0"/>
+          <a:ext cx="0" cy="0"/>
+          <a:chOff x="0" y="0"/>
+          <a:chExt cx="0" cy="0"/>
+        </a:xfrm>
+      </p:grpSpPr>
+      <p:sp>
+        <p:nvSpPr>
+          <p:cNvPr id="2" name="Tittel 1">
+            <a:extLst>
+              <a:ext uri="{FF2B5EF4-FFF2-40B4-BE49-F238E27FC236}">
+                <a16:creationId xmlns:a16="http://schemas.microsoft.com/office/drawing/2014/main" id="{D98906C0-2F7C-0A51-A561-A5AA0D9E0C6D}"/>
+              </a:ext>
+            </a:extLst>
+          </p:cNvPr>
+          <p:cNvSpPr>
+            <a:spLocks noGrp="1"/>
+          </p:cNvSpPr>
+          <p:nvPr>
+            <p:ph type="title"/>
+          </p:nvPr>
+        </p:nvSpPr>
+        <p:spPr/>
+        <p:txBody>
+          <a:bodyPr/>
+          <a:lstStyle/>
+          <a:p>
+            <a:r>
+              <a:rPr lang="nb-NO" dirty="0"/>
+              <a:t>PWM</a:t>
+            </a:r>
+          </a:p>
+        </p:txBody>
+      </p:sp>
+      <p:sp>
+        <p:nvSpPr>
+          <p:cNvPr id="3" name="Plassholder for innhold 2">
+            <a:extLst>
+              <a:ext uri="{FF2B5EF4-FFF2-40B4-BE49-F238E27FC236}">
+                <a16:creationId xmlns:a16="http://schemas.microsoft.com/office/drawing/2014/main" id="{D18FF9DF-2D0E-764E-13FB-4B2CEF6D4538}"/>
+              </a:ext>
+            </a:extLst>
+          </p:cNvPr>
+          <p:cNvSpPr>
+            <a:spLocks noGrp="1"/>
+          </p:cNvSpPr>
+          <p:nvPr>
+            <p:ph idx="1"/>
+          </p:nvPr>
+        </p:nvSpPr>
+        <p:spPr/>
+        <p:txBody>
+          <a:bodyPr/>
+          <a:lstStyle/>
+          <a:p>
+            <a:endParaRPr lang="nb-NO"/>
+          </a:p>
+        </p:txBody>
+      </p:sp>
+    </p:spTree>
+    <p:extLst>
+      <p:ext uri="{BB962C8B-B14F-4D97-AF65-F5344CB8AC3E}">
+        <p14:creationId xmlns:p14="http://schemas.microsoft.com/office/powerpoint/2010/main" val="3427658505"/>
       </p:ext>
     </p:extLst>
   </p:cSld>
@@ -5472,6 +5613,160 @@
 </p:sld>
 </file>
 
+<file path=ppt/slides/slide20.xml><?xml version="1.0" encoding="utf-8"?>
+<p:sld xmlns:a="http://schemas.openxmlformats.org/drawingml/2006/main" xmlns:r="http://schemas.openxmlformats.org/officeDocument/2006/relationships" xmlns:p="http://schemas.openxmlformats.org/presentationml/2006/main">
+  <p:cSld>
+    <p:spTree>
+      <p:nvGrpSpPr>
+        <p:cNvPr id="1" name=""/>
+        <p:cNvGrpSpPr/>
+        <p:nvPr/>
+      </p:nvGrpSpPr>
+      <p:grpSpPr>
+        <a:xfrm>
+          <a:off x="0" y="0"/>
+          <a:ext cx="0" cy="0"/>
+          <a:chOff x="0" y="0"/>
+          <a:chExt cx="0" cy="0"/>
+        </a:xfrm>
+      </p:grpSpPr>
+      <p:sp>
+        <p:nvSpPr>
+          <p:cNvPr id="2" name="Tittel 1">
+            <a:extLst>
+              <a:ext uri="{FF2B5EF4-FFF2-40B4-BE49-F238E27FC236}">
+                <a16:creationId xmlns:a16="http://schemas.microsoft.com/office/drawing/2014/main" id="{89114275-8F53-5A5B-0B26-723B5F426A45}"/>
+              </a:ext>
+            </a:extLst>
+          </p:cNvPr>
+          <p:cNvSpPr>
+            <a:spLocks noGrp="1"/>
+          </p:cNvSpPr>
+          <p:nvPr>
+            <p:ph type="title"/>
+          </p:nvPr>
+        </p:nvSpPr>
+        <p:spPr/>
+        <p:txBody>
+          <a:bodyPr/>
+          <a:lstStyle/>
+          <a:p>
+            <a:r>
+              <a:rPr lang="nb-NO" dirty="0"/>
+              <a:t>USART/UART</a:t>
+            </a:r>
+          </a:p>
+        </p:txBody>
+      </p:sp>
+      <p:sp>
+        <p:nvSpPr>
+          <p:cNvPr id="3" name="Plassholder for innhold 2">
+            <a:extLst>
+              <a:ext uri="{FF2B5EF4-FFF2-40B4-BE49-F238E27FC236}">
+                <a16:creationId xmlns:a16="http://schemas.microsoft.com/office/drawing/2014/main" id="{3D304FCB-FCE3-5BD9-D7F2-4E5117B9370A}"/>
+              </a:ext>
+            </a:extLst>
+          </p:cNvPr>
+          <p:cNvSpPr>
+            <a:spLocks noGrp="1"/>
+          </p:cNvSpPr>
+          <p:nvPr>
+            <p:ph idx="1"/>
+          </p:nvPr>
+        </p:nvSpPr>
+        <p:spPr/>
+        <p:txBody>
+          <a:bodyPr/>
+          <a:lstStyle/>
+          <a:p>
+            <a:r>
+              <a:rPr lang="nb-NO" dirty="0"/>
+              <a:t>Universal (</a:t>
+            </a:r>
+            <a:r>
+              <a:rPr lang="nb-NO" dirty="0" err="1"/>
+              <a:t>Synchronous</a:t>
+            </a:r>
+            <a:r>
+              <a:rPr lang="nb-NO" dirty="0"/>
+              <a:t>/)</a:t>
+            </a:r>
+            <a:r>
+              <a:rPr lang="nb-NO" dirty="0" err="1"/>
+              <a:t>Asynchronous</a:t>
+            </a:r>
+            <a:r>
+              <a:rPr lang="nb-NO" dirty="0"/>
+              <a:t> </a:t>
+            </a:r>
+            <a:r>
+              <a:rPr lang="nb-NO" dirty="0" err="1"/>
+              <a:t>Reciever</a:t>
+            </a:r>
+            <a:r>
+              <a:rPr lang="nb-NO" dirty="0"/>
+              <a:t>-Transmitter</a:t>
+            </a:r>
+          </a:p>
+          <a:p>
+            <a:r>
+              <a:rPr lang="nb-NO" dirty="0"/>
+              <a:t>Seriell kommunikasjonsprotokoll</a:t>
+            </a:r>
+          </a:p>
+          <a:p>
+            <a:r>
+              <a:rPr lang="nb-NO" dirty="0"/>
+              <a:t>Rx og </a:t>
+            </a:r>
+            <a:r>
+              <a:rPr lang="nb-NO" dirty="0" err="1"/>
+              <a:t>Tx</a:t>
+            </a:r>
+            <a:r>
+              <a:rPr lang="nb-NO" dirty="0"/>
+              <a:t> (Full Duplex) eller én leder(Halv Duplex)</a:t>
+            </a:r>
+          </a:p>
+          <a:p>
+            <a:r>
+              <a:rPr lang="nb-NO" dirty="0"/>
+              <a:t>Forhåndsgitt baud</a:t>
+            </a:r>
+          </a:p>
+          <a:p>
+            <a:pPr lvl="1"/>
+            <a:r>
+              <a:rPr lang="nb-NO" dirty="0"/>
+              <a:t>Baud = bits/sekund</a:t>
+            </a:r>
+          </a:p>
+          <a:p>
+            <a:pPr lvl="1"/>
+            <a:endParaRPr lang="nb-NO" dirty="0"/>
+          </a:p>
+          <a:p>
+            <a:r>
+              <a:rPr lang="nb-NO"/>
+              <a:t>Sende informasjon til </a:t>
+            </a:r>
+            <a:endParaRPr lang="nb-NO" dirty="0"/>
+          </a:p>
+        </p:txBody>
+      </p:sp>
+    </p:spTree>
+    <p:extLst>
+      <p:ext uri="{BB962C8B-B14F-4D97-AF65-F5344CB8AC3E}">
+        <p14:creationId xmlns:p14="http://schemas.microsoft.com/office/powerpoint/2010/main" val="979311525"/>
+      </p:ext>
+    </p:extLst>
+  </p:cSld>
+  <p:clrMapOvr>
+    <a:masterClrMapping/>
+  </p:clrMapOvr>
+</p:sld>
+</file>
+
 <file path=ppt/slides/slide3.xml><?xml version="1.0" encoding="utf-8"?>
 <p:sld xmlns:a="http://schemas.openxmlformats.org/drawingml/2006/main" xmlns:r="http://schemas.openxmlformats.org/officeDocument/2006/relationships" xmlns:p="http://schemas.openxmlformats.org/presentationml/2006/main">
   <p:cSld>
@@ -5541,13 +5836,13 @@
           <a:p>
             <a:r>
               <a:rPr lang="nb-NO" dirty="0"/>
-              <a:t>Signal fra en periferienhet, noe har skjedd</a:t>
-            </a:r>
-          </a:p>
-          <a:p>
-            <a:r>
-              <a:rPr lang="nb-NO" dirty="0"/>
-              <a:t>Høy prioritet, umiddelbar utføring</a:t>
+              <a:t>Signal fra en periferienhet, hendelse</a:t>
+            </a:r>
+          </a:p>
+          <a:p>
+            <a:r>
+              <a:rPr lang="nb-NO" dirty="0"/>
+              <a:t>Høy prioritet, umiddelbar respons</a:t>
             </a:r>
           </a:p>
           <a:p>

</xml_diff>

<commit_message>
Presentasjon ferdig, tror jeg. Kanskje litt puss
</commit_message>
<xml_diff>
--- a/Kursdag 2/Dag to.pptx
+++ b/Kursdag 2/Dag to.pptx
@@ -5,7 +5,7 @@
     <p:sldMasterId id="2147483648" r:id="rId1"/>
   </p:sldMasterIdLst>
   <p:notesMasterIdLst>
-    <p:notesMasterId r:id="rId22"/>
+    <p:notesMasterId r:id="rId31"/>
   </p:notesMasterIdLst>
   <p:sldIdLst>
     <p:sldId id="256" r:id="rId2"/>
@@ -27,7 +27,16 @@
     <p:sldId id="272" r:id="rId18"/>
     <p:sldId id="274" r:id="rId19"/>
     <p:sldId id="275" r:id="rId20"/>
-    <p:sldId id="273" r:id="rId21"/>
+    <p:sldId id="276" r:id="rId21"/>
+    <p:sldId id="277" r:id="rId22"/>
+    <p:sldId id="278" r:id="rId23"/>
+    <p:sldId id="279" r:id="rId24"/>
+    <p:sldId id="280" r:id="rId25"/>
+    <p:sldId id="273" r:id="rId26"/>
+    <p:sldId id="281" r:id="rId27"/>
+    <p:sldId id="282" r:id="rId28"/>
+    <p:sldId id="283" r:id="rId29"/>
+    <p:sldId id="284" r:id="rId30"/>
   </p:sldIdLst>
   <p:sldSz cx="12192000" cy="6858000"/>
   <p:notesSz cx="6858000" cy="9144000"/>
@@ -551,7 +560,7 @@
           <a:p>
             <a:fld id="{56CEED96-8DE0-441C-B2ED-FF713A48F07D}" type="slidenum">
               <a:rPr lang="nb-NO" smtClean="0"/>
-              <a:t>20</a:t>
+              <a:t>25</a:t>
             </a:fld>
             <a:endParaRPr lang="nb-NO"/>
           </a:p>
@@ -5393,7 +5402,7 @@
           <a:p>
             <a:r>
               <a:rPr lang="nb-NO" dirty="0"/>
-              <a:t>PWM</a:t>
+              <a:t>Timer – PWM</a:t>
             </a:r>
           </a:p>
         </p:txBody>
@@ -5419,10 +5428,115 @@
           <a:bodyPr/>
           <a:lstStyle/>
           <a:p>
-            <a:endParaRPr lang="nb-NO"/>
-          </a:p>
-        </p:txBody>
-      </p:sp>
+            <a:pPr>
+              <a:lnSpc>
+                <a:spcPct val="150000"/>
+              </a:lnSpc>
+            </a:pPr>
+            <a:r>
+              <a:rPr lang="nb-NO" dirty="0"/>
+              <a:t>Pulsviddemodulering</a:t>
+            </a:r>
+          </a:p>
+          <a:p>
+            <a:pPr>
+              <a:lnSpc>
+                <a:spcPct val="150000"/>
+              </a:lnSpc>
+            </a:pPr>
+            <a:r>
+              <a:rPr lang="nb-NO" dirty="0"/>
+              <a:t>Stiger jevnt fra 0 til </a:t>
+            </a:r>
+            <a:r>
+              <a:rPr lang="nb-NO" dirty="0" err="1"/>
+              <a:t>TCAn.PER</a:t>
+            </a:r>
+            <a:endParaRPr lang="nb-NO" dirty="0"/>
+          </a:p>
+          <a:p>
+            <a:pPr>
+              <a:lnSpc>
+                <a:spcPct val="150000"/>
+              </a:lnSpc>
+            </a:pPr>
+            <a:r>
+              <a:rPr lang="nb-NO" dirty="0" err="1"/>
+              <a:t>Utang</a:t>
+            </a:r>
+            <a:r>
+              <a:rPr lang="nb-NO" dirty="0"/>
+              <a:t> </a:t>
+            </a:r>
+            <a:r>
+              <a:rPr lang="nb-NO" i="1" dirty="0"/>
+              <a:t>n </a:t>
+            </a:r>
+            <a:r>
+              <a:rPr lang="nb-NO" dirty="0"/>
+              <a:t>høy når CNT under </a:t>
+            </a:r>
+            <a:r>
+              <a:rPr lang="nb-NO" dirty="0" err="1"/>
+              <a:t>CMPn</a:t>
+            </a:r>
+            <a:endParaRPr lang="nb-NO" dirty="0"/>
+          </a:p>
+          <a:p>
+            <a:pPr>
+              <a:lnSpc>
+                <a:spcPct val="150000"/>
+              </a:lnSpc>
+            </a:pPr>
+            <a:r>
+              <a:rPr lang="nb-NO" dirty="0"/>
+              <a:t>En PWM-utgang per CMP-kanal</a:t>
+            </a:r>
+          </a:p>
+          <a:p>
+            <a:pPr lvl="1">
+              <a:lnSpc>
+                <a:spcPct val="150000"/>
+              </a:lnSpc>
+            </a:pPr>
+            <a:r>
+              <a:rPr lang="nb-NO" dirty="0"/>
+              <a:t>Tilsvarende porter finnes i PORTSMUX-register</a:t>
+            </a:r>
+          </a:p>
+        </p:txBody>
+      </p:sp>
+      <p:pic>
+        <p:nvPicPr>
+          <p:cNvPr id="5" name="Bilde 4">
+            <a:extLst>
+              <a:ext uri="{FF2B5EF4-FFF2-40B4-BE49-F238E27FC236}">
+                <a16:creationId xmlns:a16="http://schemas.microsoft.com/office/drawing/2014/main" id="{7A8E9690-892E-8383-B7D4-88FFA3810ACB}"/>
+              </a:ext>
+            </a:extLst>
+          </p:cNvPr>
+          <p:cNvPicPr>
+            <a:picLocks noChangeAspect="1"/>
+          </p:cNvPicPr>
+          <p:nvPr/>
+        </p:nvPicPr>
+        <p:blipFill>
+          <a:blip r:embed="rId2"/>
+          <a:srcRect l="1861"/>
+          <a:stretch>
+            <a:fillRect/>
+          </a:stretch>
+        </p:blipFill>
+        <p:spPr>
+          <a:xfrm>
+            <a:off x="7777316" y="2378814"/>
+            <a:ext cx="3664678" cy="3170756"/>
+          </a:xfrm>
+          <a:prstGeom prst="rect">
+            <a:avLst/>
+          </a:prstGeom>
+        </p:spPr>
+      </p:pic>
     </p:spTree>
     <p:extLst>
       <p:ext uri="{BB962C8B-B14F-4D97-AF65-F5344CB8AC3E}">
@@ -5635,6 +5749,692 @@
           <p:cNvPr id="2" name="Tittel 1">
             <a:extLst>
               <a:ext uri="{FF2B5EF4-FFF2-40B4-BE49-F238E27FC236}">
+                <a16:creationId xmlns:a16="http://schemas.microsoft.com/office/drawing/2014/main" id="{F3D6A184-9804-EAB8-688A-69CADA229765}"/>
+              </a:ext>
+            </a:extLst>
+          </p:cNvPr>
+          <p:cNvSpPr>
+            <a:spLocks noGrp="1"/>
+          </p:cNvSpPr>
+          <p:nvPr>
+            <p:ph type="title"/>
+          </p:nvPr>
+        </p:nvSpPr>
+        <p:spPr/>
+        <p:txBody>
+          <a:bodyPr/>
+          <a:lstStyle/>
+          <a:p>
+            <a:r>
+              <a:rPr lang="nb-NO" dirty="0"/>
+              <a:t>Timer</a:t>
+            </a:r>
+          </a:p>
+        </p:txBody>
+      </p:sp>
+      <p:sp>
+        <p:nvSpPr>
+          <p:cNvPr id="3" name="Plassholder for innhold 2">
+            <a:extLst>
+              <a:ext uri="{FF2B5EF4-FFF2-40B4-BE49-F238E27FC236}">
+                <a16:creationId xmlns:a16="http://schemas.microsoft.com/office/drawing/2014/main" id="{FE4D2DF3-11C8-2D1D-FDB3-61A3C0BF0003}"/>
+              </a:ext>
+            </a:extLst>
+          </p:cNvPr>
+          <p:cNvSpPr>
+            <a:spLocks noGrp="1"/>
+          </p:cNvSpPr>
+          <p:nvPr>
+            <p:ph idx="1"/>
+          </p:nvPr>
+        </p:nvSpPr>
+        <p:spPr>
+          <a:xfrm>
+            <a:off x="6481916" y="1825625"/>
+            <a:ext cx="10515600" cy="4351338"/>
+          </a:xfrm>
+        </p:spPr>
+        <p:txBody>
+          <a:bodyPr/>
+          <a:lstStyle/>
+          <a:p>
+            <a:r>
+              <a:rPr lang="nb-NO" dirty="0"/>
+              <a:t>Skru på timer</a:t>
+            </a:r>
+          </a:p>
+          <a:p>
+            <a:r>
+              <a:rPr lang="nb-NO" dirty="0"/>
+              <a:t>16/8-bit</a:t>
+            </a:r>
+          </a:p>
+          <a:p>
+            <a:r>
+              <a:rPr lang="nb-NO" dirty="0" err="1"/>
+              <a:t>Prescaler</a:t>
+            </a:r>
+            <a:endParaRPr lang="nb-NO" dirty="0"/>
+          </a:p>
+          <a:p>
+            <a:r>
+              <a:rPr lang="nb-NO" dirty="0"/>
+              <a:t>Telleretning</a:t>
+            </a:r>
+          </a:p>
+        </p:txBody>
+      </p:sp>
+      <p:pic>
+        <p:nvPicPr>
+          <p:cNvPr id="5" name="Bilde 4">
+            <a:extLst>
+              <a:ext uri="{FF2B5EF4-FFF2-40B4-BE49-F238E27FC236}">
+                <a16:creationId xmlns:a16="http://schemas.microsoft.com/office/drawing/2014/main" id="{FA891055-ED9C-4A82-6DE8-46BFED6C0D62}"/>
+              </a:ext>
+            </a:extLst>
+          </p:cNvPr>
+          <p:cNvPicPr>
+            <a:picLocks noChangeAspect="1"/>
+          </p:cNvPicPr>
+          <p:nvPr/>
+        </p:nvPicPr>
+        <p:blipFill>
+          <a:blip r:embed="rId2"/>
+          <a:stretch>
+            <a:fillRect/>
+          </a:stretch>
+        </p:blipFill>
+        <p:spPr>
+          <a:xfrm>
+            <a:off x="838200" y="1825625"/>
+            <a:ext cx="5469668" cy="4014736"/>
+          </a:xfrm>
+          <a:prstGeom prst="rect">
+            <a:avLst/>
+          </a:prstGeom>
+        </p:spPr>
+      </p:pic>
+    </p:spTree>
+    <p:extLst>
+      <p:ext uri="{BB962C8B-B14F-4D97-AF65-F5344CB8AC3E}">
+        <p14:creationId xmlns:p14="http://schemas.microsoft.com/office/powerpoint/2010/main" val="1661805145"/>
+      </p:ext>
+    </p:extLst>
+  </p:cSld>
+  <p:clrMapOvr>
+    <a:masterClrMapping/>
+  </p:clrMapOvr>
+</p:sld>
+</file>
+
+<file path=ppt/slides/slide21.xml><?xml version="1.0" encoding="utf-8"?>
+<p:sld xmlns:a="http://schemas.openxmlformats.org/drawingml/2006/main" xmlns:r="http://schemas.openxmlformats.org/officeDocument/2006/relationships" xmlns:p="http://schemas.openxmlformats.org/presentationml/2006/main">
+  <p:cSld>
+    <p:spTree>
+      <p:nvGrpSpPr>
+        <p:cNvPr id="1" name="">
+          <a:extLst>
+            <a:ext uri="{FF2B5EF4-FFF2-40B4-BE49-F238E27FC236}">
+              <a16:creationId xmlns:a16="http://schemas.microsoft.com/office/drawing/2014/main" id="{52195F85-031F-AA0C-8C2B-694DDC62BCB1}"/>
+            </a:ext>
+          </a:extLst>
+        </p:cNvPr>
+        <p:cNvGrpSpPr/>
+        <p:nvPr/>
+      </p:nvGrpSpPr>
+      <p:grpSpPr>
+        <a:xfrm>
+          <a:off x="0" y="0"/>
+          <a:ext cx="0" cy="0"/>
+          <a:chOff x="0" y="0"/>
+          <a:chExt cx="0" cy="0"/>
+        </a:xfrm>
+      </p:grpSpPr>
+      <p:sp>
+        <p:nvSpPr>
+          <p:cNvPr id="2" name="Tittel 1">
+            <a:extLst>
+              <a:ext uri="{FF2B5EF4-FFF2-40B4-BE49-F238E27FC236}">
+                <a16:creationId xmlns:a16="http://schemas.microsoft.com/office/drawing/2014/main" id="{E84F1C42-315E-2C50-EDB2-56EB639F5528}"/>
+              </a:ext>
+            </a:extLst>
+          </p:cNvPr>
+          <p:cNvSpPr>
+            <a:spLocks noGrp="1"/>
+          </p:cNvSpPr>
+          <p:nvPr>
+            <p:ph type="title"/>
+          </p:nvPr>
+        </p:nvSpPr>
+        <p:spPr/>
+        <p:txBody>
+          <a:bodyPr/>
+          <a:lstStyle/>
+          <a:p>
+            <a:r>
+              <a:rPr lang="nb-NO" dirty="0"/>
+              <a:t>Timer</a:t>
+            </a:r>
+          </a:p>
+        </p:txBody>
+      </p:sp>
+      <p:sp>
+        <p:nvSpPr>
+          <p:cNvPr id="3" name="Plassholder for innhold 2">
+            <a:extLst>
+              <a:ext uri="{FF2B5EF4-FFF2-40B4-BE49-F238E27FC236}">
+                <a16:creationId xmlns:a16="http://schemas.microsoft.com/office/drawing/2014/main" id="{24D1BD30-AF1E-E742-CDF1-D42B98980092}"/>
+              </a:ext>
+            </a:extLst>
+          </p:cNvPr>
+          <p:cNvSpPr>
+            <a:spLocks noGrp="1"/>
+          </p:cNvSpPr>
+          <p:nvPr>
+            <p:ph idx="1"/>
+          </p:nvPr>
+        </p:nvSpPr>
+        <p:spPr>
+          <a:xfrm>
+            <a:off x="838200" y="1690688"/>
+            <a:ext cx="10515600" cy="4351338"/>
+          </a:xfrm>
+        </p:spPr>
+        <p:txBody>
+          <a:bodyPr/>
+          <a:lstStyle/>
+          <a:p>
+            <a:r>
+              <a:rPr lang="nb-NO" dirty="0"/>
+              <a:t>Bølgegenerering?</a:t>
+            </a:r>
+          </a:p>
+        </p:txBody>
+      </p:sp>
+      <p:pic>
+        <p:nvPicPr>
+          <p:cNvPr id="6" name="Bilde 5">
+            <a:extLst>
+              <a:ext uri="{FF2B5EF4-FFF2-40B4-BE49-F238E27FC236}">
+                <a16:creationId xmlns:a16="http://schemas.microsoft.com/office/drawing/2014/main" id="{623806C4-D616-7263-E761-B74E116FFC23}"/>
+              </a:ext>
+            </a:extLst>
+          </p:cNvPr>
+          <p:cNvPicPr>
+            <a:picLocks noChangeAspect="1"/>
+          </p:cNvPicPr>
+          <p:nvPr/>
+        </p:nvPicPr>
+        <p:blipFill>
+          <a:blip r:embed="rId2"/>
+          <a:stretch>
+            <a:fillRect/>
+          </a:stretch>
+        </p:blipFill>
+        <p:spPr>
+          <a:xfrm>
+            <a:off x="5201920" y="1690688"/>
+            <a:ext cx="6151880" cy="3392283"/>
+          </a:xfrm>
+          <a:prstGeom prst="rect">
+            <a:avLst/>
+          </a:prstGeom>
+        </p:spPr>
+      </p:pic>
+    </p:spTree>
+    <p:extLst>
+      <p:ext uri="{BB962C8B-B14F-4D97-AF65-F5344CB8AC3E}">
+        <p14:creationId xmlns:p14="http://schemas.microsoft.com/office/powerpoint/2010/main" val="2985046012"/>
+      </p:ext>
+    </p:extLst>
+  </p:cSld>
+  <p:clrMapOvr>
+    <a:masterClrMapping/>
+  </p:clrMapOvr>
+</p:sld>
+</file>
+
+<file path=ppt/slides/slide22.xml><?xml version="1.0" encoding="utf-8"?>
+<p:sld xmlns:a="http://schemas.openxmlformats.org/drawingml/2006/main" xmlns:r="http://schemas.openxmlformats.org/officeDocument/2006/relationships" xmlns:p="http://schemas.openxmlformats.org/presentationml/2006/main">
+  <p:cSld>
+    <p:spTree>
+      <p:nvGrpSpPr>
+        <p:cNvPr id="1" name="">
+          <a:extLst>
+            <a:ext uri="{FF2B5EF4-FFF2-40B4-BE49-F238E27FC236}">
+              <a16:creationId xmlns:a16="http://schemas.microsoft.com/office/drawing/2014/main" id="{3D34D379-E6B1-C230-27F8-193F04EF23AA}"/>
+            </a:ext>
+          </a:extLst>
+        </p:cNvPr>
+        <p:cNvGrpSpPr/>
+        <p:nvPr/>
+      </p:nvGrpSpPr>
+      <p:grpSpPr>
+        <a:xfrm>
+          <a:off x="0" y="0"/>
+          <a:ext cx="0" cy="0"/>
+          <a:chOff x="0" y="0"/>
+          <a:chExt cx="0" cy="0"/>
+        </a:xfrm>
+      </p:grpSpPr>
+      <p:sp>
+        <p:nvSpPr>
+          <p:cNvPr id="2" name="Tittel 1">
+            <a:extLst>
+              <a:ext uri="{FF2B5EF4-FFF2-40B4-BE49-F238E27FC236}">
+                <a16:creationId xmlns:a16="http://schemas.microsoft.com/office/drawing/2014/main" id="{5B4FA5F5-A313-EB92-3CA5-1F1BE936F2CF}"/>
+              </a:ext>
+            </a:extLst>
+          </p:cNvPr>
+          <p:cNvSpPr>
+            <a:spLocks noGrp="1"/>
+          </p:cNvSpPr>
+          <p:nvPr>
+            <p:ph type="title"/>
+          </p:nvPr>
+        </p:nvSpPr>
+        <p:spPr/>
+        <p:txBody>
+          <a:bodyPr/>
+          <a:lstStyle/>
+          <a:p>
+            <a:r>
+              <a:rPr lang="nb-NO" dirty="0"/>
+              <a:t>Timer</a:t>
+            </a:r>
+          </a:p>
+        </p:txBody>
+      </p:sp>
+      <p:sp>
+        <p:nvSpPr>
+          <p:cNvPr id="3" name="Plassholder for innhold 2">
+            <a:extLst>
+              <a:ext uri="{FF2B5EF4-FFF2-40B4-BE49-F238E27FC236}">
+                <a16:creationId xmlns:a16="http://schemas.microsoft.com/office/drawing/2014/main" id="{57CA52B4-33CF-A76D-DD19-1ED7D65D3EBC}"/>
+              </a:ext>
+            </a:extLst>
+          </p:cNvPr>
+          <p:cNvSpPr>
+            <a:spLocks noGrp="1"/>
+          </p:cNvSpPr>
+          <p:nvPr>
+            <p:ph idx="1"/>
+          </p:nvPr>
+        </p:nvSpPr>
+        <p:spPr>
+          <a:xfrm>
+            <a:off x="838200" y="1690688"/>
+            <a:ext cx="10515600" cy="4351338"/>
+          </a:xfrm>
+        </p:spPr>
+        <p:txBody>
+          <a:bodyPr/>
+          <a:lstStyle/>
+          <a:p>
+            <a:r>
+              <a:rPr lang="nb-NO" dirty="0"/>
+              <a:t>Skru på </a:t>
+            </a:r>
+            <a:r>
+              <a:rPr lang="nb-NO" dirty="0" err="1"/>
+              <a:t>CMPn</a:t>
+            </a:r>
+            <a:r>
+              <a:rPr lang="nb-NO" dirty="0"/>
+              <a:t>-kanal</a:t>
+            </a:r>
+          </a:p>
+          <a:p>
+            <a:r>
+              <a:rPr lang="nb-NO" dirty="0"/>
+              <a:t>Still inn </a:t>
+            </a:r>
+            <a:r>
+              <a:rPr lang="nb-NO" dirty="0" err="1"/>
+              <a:t>CMPn</a:t>
+            </a:r>
+            <a:r>
+              <a:rPr lang="nb-NO" dirty="0"/>
+              <a:t>-verdi</a:t>
+            </a:r>
+          </a:p>
+        </p:txBody>
+      </p:sp>
+      <p:pic>
+        <p:nvPicPr>
+          <p:cNvPr id="5" name="Bilde 4">
+            <a:extLst>
+              <a:ext uri="{FF2B5EF4-FFF2-40B4-BE49-F238E27FC236}">
+                <a16:creationId xmlns:a16="http://schemas.microsoft.com/office/drawing/2014/main" id="{0340373F-90E7-71E3-98C6-3B9E21AA6665}"/>
+              </a:ext>
+            </a:extLst>
+          </p:cNvPr>
+          <p:cNvPicPr>
+            <a:picLocks noChangeAspect="1"/>
+          </p:cNvPicPr>
+          <p:nvPr/>
+        </p:nvPicPr>
+        <p:blipFill>
+          <a:blip r:embed="rId2"/>
+          <a:stretch>
+            <a:fillRect/>
+          </a:stretch>
+        </p:blipFill>
+        <p:spPr>
+          <a:xfrm>
+            <a:off x="5299705" y="1690688"/>
+            <a:ext cx="6791632" cy="4130992"/>
+          </a:xfrm>
+          <a:prstGeom prst="rect">
+            <a:avLst/>
+          </a:prstGeom>
+        </p:spPr>
+      </p:pic>
+    </p:spTree>
+    <p:extLst>
+      <p:ext uri="{BB962C8B-B14F-4D97-AF65-F5344CB8AC3E}">
+        <p14:creationId xmlns:p14="http://schemas.microsoft.com/office/powerpoint/2010/main" val="963200478"/>
+      </p:ext>
+    </p:extLst>
+  </p:cSld>
+  <p:clrMapOvr>
+    <a:masterClrMapping/>
+  </p:clrMapOvr>
+</p:sld>
+</file>
+
+<file path=ppt/slides/slide23.xml><?xml version="1.0" encoding="utf-8"?>
+<p:sld xmlns:a="http://schemas.openxmlformats.org/drawingml/2006/main" xmlns:r="http://schemas.openxmlformats.org/officeDocument/2006/relationships" xmlns:p="http://schemas.openxmlformats.org/presentationml/2006/main">
+  <p:cSld>
+    <p:spTree>
+      <p:nvGrpSpPr>
+        <p:cNvPr id="1" name="">
+          <a:extLst>
+            <a:ext uri="{FF2B5EF4-FFF2-40B4-BE49-F238E27FC236}">
+              <a16:creationId xmlns:a16="http://schemas.microsoft.com/office/drawing/2014/main" id="{A34D52D7-27D7-65E0-D569-BDDA71816A92}"/>
+            </a:ext>
+          </a:extLst>
+        </p:cNvPr>
+        <p:cNvGrpSpPr/>
+        <p:nvPr/>
+      </p:nvGrpSpPr>
+      <p:grpSpPr>
+        <a:xfrm>
+          <a:off x="0" y="0"/>
+          <a:ext cx="0" cy="0"/>
+          <a:chOff x="0" y="0"/>
+          <a:chExt cx="0" cy="0"/>
+        </a:xfrm>
+      </p:grpSpPr>
+      <p:sp>
+        <p:nvSpPr>
+          <p:cNvPr id="2" name="Tittel 1">
+            <a:extLst>
+              <a:ext uri="{FF2B5EF4-FFF2-40B4-BE49-F238E27FC236}">
+                <a16:creationId xmlns:a16="http://schemas.microsoft.com/office/drawing/2014/main" id="{D5831986-CBBE-8C8D-4CD5-03320C4A3171}"/>
+              </a:ext>
+            </a:extLst>
+          </p:cNvPr>
+          <p:cNvSpPr>
+            <a:spLocks noGrp="1"/>
+          </p:cNvSpPr>
+          <p:nvPr>
+            <p:ph type="title"/>
+          </p:nvPr>
+        </p:nvSpPr>
+        <p:spPr/>
+        <p:txBody>
+          <a:bodyPr/>
+          <a:lstStyle/>
+          <a:p>
+            <a:r>
+              <a:rPr lang="nb-NO" dirty="0"/>
+              <a:t>Timer</a:t>
+            </a:r>
+          </a:p>
+        </p:txBody>
+      </p:sp>
+      <p:sp>
+        <p:nvSpPr>
+          <p:cNvPr id="3" name="Plassholder for innhold 2">
+            <a:extLst>
+              <a:ext uri="{FF2B5EF4-FFF2-40B4-BE49-F238E27FC236}">
+                <a16:creationId xmlns:a16="http://schemas.microsoft.com/office/drawing/2014/main" id="{41B69EC3-93B2-4921-E6C4-CE56659165BB}"/>
+              </a:ext>
+            </a:extLst>
+          </p:cNvPr>
+          <p:cNvSpPr>
+            <a:spLocks noGrp="1"/>
+          </p:cNvSpPr>
+          <p:nvPr>
+            <p:ph idx="1"/>
+          </p:nvPr>
+        </p:nvSpPr>
+        <p:spPr>
+          <a:xfrm>
+            <a:off x="6481916" y="1825625"/>
+            <a:ext cx="10515600" cy="4351338"/>
+          </a:xfrm>
+        </p:spPr>
+        <p:txBody>
+          <a:bodyPr/>
+          <a:lstStyle/>
+          <a:p>
+            <a:r>
+              <a:rPr lang="nb-NO" dirty="0"/>
+              <a:t>Skru på </a:t>
+            </a:r>
+            <a:r>
+              <a:rPr lang="nb-NO" dirty="0" err="1"/>
+              <a:t>interrupts</a:t>
+            </a:r>
+            <a:endParaRPr lang="nb-NO" dirty="0"/>
+          </a:p>
+        </p:txBody>
+      </p:sp>
+      <p:pic>
+        <p:nvPicPr>
+          <p:cNvPr id="6" name="Bilde 5">
+            <a:extLst>
+              <a:ext uri="{FF2B5EF4-FFF2-40B4-BE49-F238E27FC236}">
+                <a16:creationId xmlns:a16="http://schemas.microsoft.com/office/drawing/2014/main" id="{B68A7E19-B4EA-F2F3-2939-C812FCF04C6B}"/>
+              </a:ext>
+            </a:extLst>
+          </p:cNvPr>
+          <p:cNvPicPr>
+            <a:picLocks noChangeAspect="1"/>
+          </p:cNvPicPr>
+          <p:nvPr/>
+        </p:nvPicPr>
+        <p:blipFill>
+          <a:blip r:embed="rId2"/>
+          <a:stretch>
+            <a:fillRect/>
+          </a:stretch>
+        </p:blipFill>
+        <p:spPr>
+          <a:xfrm>
+            <a:off x="411211" y="1690688"/>
+            <a:ext cx="6070705" cy="3795712"/>
+          </a:xfrm>
+          <a:prstGeom prst="rect">
+            <a:avLst/>
+          </a:prstGeom>
+        </p:spPr>
+      </p:pic>
+    </p:spTree>
+    <p:extLst>
+      <p:ext uri="{BB962C8B-B14F-4D97-AF65-F5344CB8AC3E}">
+        <p14:creationId xmlns:p14="http://schemas.microsoft.com/office/powerpoint/2010/main" val="836735771"/>
+      </p:ext>
+    </p:extLst>
+  </p:cSld>
+  <p:clrMapOvr>
+    <a:masterClrMapping/>
+  </p:clrMapOvr>
+</p:sld>
+</file>
+
+<file path=ppt/slides/slide24.xml><?xml version="1.0" encoding="utf-8"?>
+<p:sld xmlns:a="http://schemas.openxmlformats.org/drawingml/2006/main" xmlns:r="http://schemas.openxmlformats.org/officeDocument/2006/relationships" xmlns:p="http://schemas.openxmlformats.org/presentationml/2006/main">
+  <p:cSld>
+    <p:spTree>
+      <p:nvGrpSpPr>
+        <p:cNvPr id="1" name=""/>
+        <p:cNvGrpSpPr/>
+        <p:nvPr/>
+      </p:nvGrpSpPr>
+      <p:grpSpPr>
+        <a:xfrm>
+          <a:off x="0" y="0"/>
+          <a:ext cx="0" cy="0"/>
+          <a:chOff x="0" y="0"/>
+          <a:chExt cx="0" cy="0"/>
+        </a:xfrm>
+      </p:grpSpPr>
+      <p:sp>
+        <p:nvSpPr>
+          <p:cNvPr id="2" name="Tittel 1">
+            <a:extLst>
+              <a:ext uri="{FF2B5EF4-FFF2-40B4-BE49-F238E27FC236}">
+                <a16:creationId xmlns:a16="http://schemas.microsoft.com/office/drawing/2014/main" id="{13383AEA-FF9E-C04B-80BD-88550C84AAD7}"/>
+              </a:ext>
+            </a:extLst>
+          </p:cNvPr>
+          <p:cNvSpPr>
+            <a:spLocks noGrp="1"/>
+          </p:cNvSpPr>
+          <p:nvPr>
+            <p:ph type="title"/>
+          </p:nvPr>
+        </p:nvSpPr>
+        <p:spPr/>
+        <p:txBody>
+          <a:bodyPr/>
+          <a:lstStyle/>
+          <a:p>
+            <a:r>
+              <a:rPr lang="nb-NO" dirty="0"/>
+              <a:t>Timer</a:t>
+            </a:r>
+          </a:p>
+        </p:txBody>
+      </p:sp>
+      <p:sp>
+        <p:nvSpPr>
+          <p:cNvPr id="3" name="Plassholder for innhold 2">
+            <a:extLst>
+              <a:ext uri="{FF2B5EF4-FFF2-40B4-BE49-F238E27FC236}">
+                <a16:creationId xmlns:a16="http://schemas.microsoft.com/office/drawing/2014/main" id="{40960806-D520-8434-F093-AF93D3D89A7F}"/>
+              </a:ext>
+            </a:extLst>
+          </p:cNvPr>
+          <p:cNvSpPr>
+            <a:spLocks noGrp="1"/>
+          </p:cNvSpPr>
+          <p:nvPr>
+            <p:ph idx="1"/>
+          </p:nvPr>
+        </p:nvSpPr>
+        <p:spPr/>
+        <p:txBody>
+          <a:bodyPr/>
+          <a:lstStyle/>
+          <a:p>
+            <a:r>
+              <a:rPr lang="nb-NO" dirty="0"/>
+              <a:t>Utgang velges i pin-grid </a:t>
+            </a:r>
+            <a:r>
+              <a:rPr lang="nb-NO" dirty="0" err="1"/>
+              <a:t>view</a:t>
+            </a:r>
+            <a:endParaRPr lang="nb-NO" dirty="0"/>
+          </a:p>
+          <a:p>
+            <a:pPr lvl="1"/>
+            <a:r>
+              <a:rPr lang="nb-NO" dirty="0" err="1"/>
+              <a:t>WOn</a:t>
+            </a:r>
+            <a:r>
+              <a:rPr lang="nb-NO" dirty="0"/>
+              <a:t> tilsvarer </a:t>
+            </a:r>
+            <a:r>
+              <a:rPr lang="nb-NO" dirty="0" err="1"/>
+              <a:t>CMPn</a:t>
+            </a:r>
+            <a:endParaRPr lang="nb-NO" dirty="0"/>
+          </a:p>
+        </p:txBody>
+      </p:sp>
+      <p:pic>
+        <p:nvPicPr>
+          <p:cNvPr id="5" name="Bilde 4">
+            <a:extLst>
+              <a:ext uri="{FF2B5EF4-FFF2-40B4-BE49-F238E27FC236}">
+                <a16:creationId xmlns:a16="http://schemas.microsoft.com/office/drawing/2014/main" id="{6445B4DB-DD12-2FFD-90CC-57BAAF2C6EC5}"/>
+              </a:ext>
+            </a:extLst>
+          </p:cNvPr>
+          <p:cNvPicPr>
+            <a:picLocks noChangeAspect="1"/>
+          </p:cNvPicPr>
+          <p:nvPr/>
+        </p:nvPicPr>
+        <p:blipFill>
+          <a:blip r:embed="rId2"/>
+          <a:srcRect r="29671"/>
+          <a:stretch>
+            <a:fillRect/>
+          </a:stretch>
+        </p:blipFill>
+        <p:spPr>
+          <a:xfrm>
+            <a:off x="411480" y="3265153"/>
+            <a:ext cx="10832612" cy="2058687"/>
+          </a:xfrm>
+          <a:prstGeom prst="rect">
+            <a:avLst/>
+          </a:prstGeom>
+        </p:spPr>
+      </p:pic>
+    </p:spTree>
+    <p:extLst>
+      <p:ext uri="{BB962C8B-B14F-4D97-AF65-F5344CB8AC3E}">
+        <p14:creationId xmlns:p14="http://schemas.microsoft.com/office/powerpoint/2010/main" val="106309096"/>
+      </p:ext>
+    </p:extLst>
+  </p:cSld>
+  <p:clrMapOvr>
+    <a:masterClrMapping/>
+  </p:clrMapOvr>
+</p:sld>
+</file>
+
+<file path=ppt/slides/slide25.xml><?xml version="1.0" encoding="utf-8"?>
+<p:sld xmlns:a="http://schemas.openxmlformats.org/drawingml/2006/main" xmlns:r="http://schemas.openxmlformats.org/officeDocument/2006/relationships" xmlns:p="http://schemas.openxmlformats.org/presentationml/2006/main">
+  <p:cSld>
+    <p:spTree>
+      <p:nvGrpSpPr>
+        <p:cNvPr id="1" name=""/>
+        <p:cNvGrpSpPr/>
+        <p:nvPr/>
+      </p:nvGrpSpPr>
+      <p:grpSpPr>
+        <a:xfrm>
+          <a:off x="0" y="0"/>
+          <a:ext cx="0" cy="0"/>
+          <a:chOff x="0" y="0"/>
+          <a:chExt cx="0" cy="0"/>
+        </a:xfrm>
+      </p:grpSpPr>
+      <p:sp>
+        <p:nvSpPr>
+          <p:cNvPr id="2" name="Tittel 1">
+            <a:extLst>
+              <a:ext uri="{FF2B5EF4-FFF2-40B4-BE49-F238E27FC236}">
                 <a16:creationId xmlns:a16="http://schemas.microsoft.com/office/drawing/2014/main" id="{89114275-8F53-5A5B-0B26-723B5F426A45}"/>
               </a:ext>
             </a:extLst>
@@ -5747,10 +6547,17 @@
           </a:p>
           <a:p>
             <a:r>
-              <a:rPr lang="nb-NO"/>
+              <a:rPr lang="nb-NO" dirty="0"/>
               <a:t>Sende informasjon til </a:t>
             </a:r>
-            <a:endParaRPr lang="nb-NO" dirty="0"/>
+            <a:r>
+              <a:rPr lang="nb-NO" dirty="0" err="1"/>
+              <a:t>bl.a</a:t>
+            </a:r>
+            <a:r>
+              <a:rPr lang="nb-NO" dirty="0"/>
+              <a:t> PC</a:t>
+            </a:r>
           </a:p>
         </p:txBody>
       </p:sp>
@@ -5758,6 +6565,676 @@
     <p:extLst>
       <p:ext uri="{BB962C8B-B14F-4D97-AF65-F5344CB8AC3E}">
         <p14:creationId xmlns:p14="http://schemas.microsoft.com/office/powerpoint/2010/main" val="979311525"/>
+      </p:ext>
+    </p:extLst>
+  </p:cSld>
+  <p:clrMapOvr>
+    <a:masterClrMapping/>
+  </p:clrMapOvr>
+</p:sld>
+</file>
+
+<file path=ppt/slides/slide26.xml><?xml version="1.0" encoding="utf-8"?>
+<p:sld xmlns:a="http://schemas.openxmlformats.org/drawingml/2006/main" xmlns:r="http://schemas.openxmlformats.org/officeDocument/2006/relationships" xmlns:p="http://schemas.openxmlformats.org/presentationml/2006/main">
+  <p:cSld>
+    <p:spTree>
+      <p:nvGrpSpPr>
+        <p:cNvPr id="1" name=""/>
+        <p:cNvGrpSpPr/>
+        <p:nvPr/>
+      </p:nvGrpSpPr>
+      <p:grpSpPr>
+        <a:xfrm>
+          <a:off x="0" y="0"/>
+          <a:ext cx="0" cy="0"/>
+          <a:chOff x="0" y="0"/>
+          <a:chExt cx="0" cy="0"/>
+        </a:xfrm>
+      </p:grpSpPr>
+      <p:sp>
+        <p:nvSpPr>
+          <p:cNvPr id="2" name="Tittel 1">
+            <a:extLst>
+              <a:ext uri="{FF2B5EF4-FFF2-40B4-BE49-F238E27FC236}">
+                <a16:creationId xmlns:a16="http://schemas.microsoft.com/office/drawing/2014/main" id="{397C9A48-C326-49F7-402D-5861F5BBF908}"/>
+              </a:ext>
+            </a:extLst>
+          </p:cNvPr>
+          <p:cNvSpPr>
+            <a:spLocks noGrp="1"/>
+          </p:cNvSpPr>
+          <p:nvPr>
+            <p:ph type="title"/>
+          </p:nvPr>
+        </p:nvSpPr>
+        <p:spPr/>
+        <p:txBody>
+          <a:bodyPr/>
+          <a:lstStyle/>
+          <a:p>
+            <a:r>
+              <a:rPr lang="nb-NO" dirty="0"/>
+              <a:t>USART for feilsøking</a:t>
+            </a:r>
+          </a:p>
+        </p:txBody>
+      </p:sp>
+      <p:sp>
+        <p:nvSpPr>
+          <p:cNvPr id="3" name="Plassholder for innhold 2">
+            <a:extLst>
+              <a:ext uri="{FF2B5EF4-FFF2-40B4-BE49-F238E27FC236}">
+                <a16:creationId xmlns:a16="http://schemas.microsoft.com/office/drawing/2014/main" id="{2F224AE8-A97E-2E60-9D81-6FC5DA0990DD}"/>
+              </a:ext>
+            </a:extLst>
+          </p:cNvPr>
+          <p:cNvSpPr>
+            <a:spLocks noGrp="1"/>
+          </p:cNvSpPr>
+          <p:nvPr>
+            <p:ph idx="1"/>
+          </p:nvPr>
+        </p:nvSpPr>
+        <p:spPr/>
+        <p:txBody>
+          <a:bodyPr>
+            <a:normAutofit lnSpcReduction="10000"/>
+          </a:bodyPr>
+          <a:lstStyle/>
+          <a:p>
+            <a:pPr>
+              <a:lnSpc>
+                <a:spcPct val="150000"/>
+              </a:lnSpc>
+            </a:pPr>
+            <a:r>
+              <a:rPr lang="nb-NO" dirty="0"/>
+              <a:t>Skrive data til seriell monitor på PC</a:t>
+            </a:r>
+          </a:p>
+          <a:p>
+            <a:pPr>
+              <a:lnSpc>
+                <a:spcPct val="100000"/>
+              </a:lnSpc>
+            </a:pPr>
+            <a:r>
+              <a:rPr lang="nb-NO" dirty="0"/>
+              <a:t>VIKTIG: USART3-dependency</a:t>
+            </a:r>
+          </a:p>
+          <a:p>
+            <a:pPr lvl="1">
+              <a:lnSpc>
+                <a:spcPct val="100000"/>
+              </a:lnSpc>
+            </a:pPr>
+            <a:r>
+              <a:rPr lang="nb-NO" dirty="0"/>
+              <a:t>Den som er koblet til USB</a:t>
+            </a:r>
+          </a:p>
+          <a:p>
+            <a:pPr lvl="1">
+              <a:lnSpc>
+                <a:spcPct val="100000"/>
+              </a:lnSpc>
+            </a:pPr>
+            <a:r>
+              <a:rPr lang="nb-NO" dirty="0"/>
+              <a:t>Vises i </a:t>
+            </a:r>
+            <a:r>
+              <a:rPr lang="nb-NO" dirty="0" err="1"/>
+              <a:t>CNano</a:t>
+            </a:r>
+            <a:r>
+              <a:rPr lang="nb-NO" dirty="0"/>
+              <a:t> </a:t>
+            </a:r>
+            <a:r>
+              <a:rPr lang="nb-NO" dirty="0" err="1"/>
+              <a:t>Schematic</a:t>
+            </a:r>
+            <a:endParaRPr lang="nb-NO" dirty="0"/>
+          </a:p>
+          <a:p>
+            <a:pPr>
+              <a:lnSpc>
+                <a:spcPct val="150000"/>
+              </a:lnSpc>
+            </a:pPr>
+            <a:r>
+              <a:rPr lang="nb-NO" dirty="0"/>
+              <a:t>MCC innebygde drivere, </a:t>
+            </a:r>
+            <a:r>
+              <a:rPr lang="nb-NO" dirty="0" err="1"/>
+              <a:t>printf</a:t>
+            </a:r>
+            <a:r>
+              <a:rPr lang="nb-NO" dirty="0"/>
+              <a:t>()</a:t>
+            </a:r>
+          </a:p>
+          <a:p>
+            <a:pPr>
+              <a:lnSpc>
+                <a:spcPct val="110000"/>
+              </a:lnSpc>
+            </a:pPr>
+            <a:r>
+              <a:rPr lang="nb-NO" dirty="0"/>
+              <a:t>Motta på PC</a:t>
+            </a:r>
+          </a:p>
+          <a:p>
+            <a:pPr lvl="1">
+              <a:lnSpc>
+                <a:spcPct val="110000"/>
+              </a:lnSpc>
+            </a:pPr>
+            <a:r>
+              <a:rPr lang="nb-NO" dirty="0"/>
+              <a:t>MPLAB Data visualizer</a:t>
+            </a:r>
+          </a:p>
+          <a:p>
+            <a:pPr lvl="1">
+              <a:lnSpc>
+                <a:spcPct val="110000"/>
+              </a:lnSpc>
+            </a:pPr>
+            <a:r>
+              <a:rPr lang="nb-NO" dirty="0" err="1"/>
+              <a:t>VScode</a:t>
+            </a:r>
+            <a:r>
+              <a:rPr lang="nb-NO" dirty="0"/>
+              <a:t> Serial Terminal utvidelse</a:t>
+            </a:r>
+          </a:p>
+        </p:txBody>
+      </p:sp>
+      <p:pic>
+        <p:nvPicPr>
+          <p:cNvPr id="5" name="Bilde 4">
+            <a:extLst>
+              <a:ext uri="{FF2B5EF4-FFF2-40B4-BE49-F238E27FC236}">
+                <a16:creationId xmlns:a16="http://schemas.microsoft.com/office/drawing/2014/main" id="{DBC9A3B3-CF8F-7818-3310-CC0E90AE42B1}"/>
+              </a:ext>
+            </a:extLst>
+          </p:cNvPr>
+          <p:cNvPicPr>
+            <a:picLocks noChangeAspect="1"/>
+          </p:cNvPicPr>
+          <p:nvPr/>
+        </p:nvPicPr>
+        <p:blipFill>
+          <a:blip r:embed="rId2"/>
+          <a:srcRect r="6665"/>
+          <a:stretch>
+            <a:fillRect/>
+          </a:stretch>
+        </p:blipFill>
+        <p:spPr>
+          <a:xfrm>
+            <a:off x="6605549" y="1158413"/>
+            <a:ext cx="5370141" cy="5334462"/>
+          </a:xfrm>
+          <a:prstGeom prst="rect">
+            <a:avLst/>
+          </a:prstGeom>
+        </p:spPr>
+      </p:pic>
+    </p:spTree>
+    <p:extLst>
+      <p:ext uri="{BB962C8B-B14F-4D97-AF65-F5344CB8AC3E}">
+        <p14:creationId xmlns:p14="http://schemas.microsoft.com/office/powerpoint/2010/main" val="2080382621"/>
+      </p:ext>
+    </p:extLst>
+  </p:cSld>
+  <p:clrMapOvr>
+    <a:masterClrMapping/>
+  </p:clrMapOvr>
+</p:sld>
+</file>
+
+<file path=ppt/slides/slide27.xml><?xml version="1.0" encoding="utf-8"?>
+<p:sld xmlns:a="http://schemas.openxmlformats.org/drawingml/2006/main" xmlns:r="http://schemas.openxmlformats.org/officeDocument/2006/relationships" xmlns:p="http://schemas.openxmlformats.org/presentationml/2006/main">
+  <p:cSld>
+    <p:spTree>
+      <p:nvGrpSpPr>
+        <p:cNvPr id="1" name=""/>
+        <p:cNvGrpSpPr/>
+        <p:nvPr/>
+      </p:nvGrpSpPr>
+      <p:grpSpPr>
+        <a:xfrm>
+          <a:off x="0" y="0"/>
+          <a:ext cx="0" cy="0"/>
+          <a:chOff x="0" y="0"/>
+          <a:chExt cx="0" cy="0"/>
+        </a:xfrm>
+      </p:grpSpPr>
+      <p:sp>
+        <p:nvSpPr>
+          <p:cNvPr id="2" name="Tittel 1">
+            <a:extLst>
+              <a:ext uri="{FF2B5EF4-FFF2-40B4-BE49-F238E27FC236}">
+                <a16:creationId xmlns:a16="http://schemas.microsoft.com/office/drawing/2014/main" id="{94A283F6-D128-F6EF-5EC3-40C90E6E6788}"/>
+              </a:ext>
+            </a:extLst>
+          </p:cNvPr>
+          <p:cNvSpPr>
+            <a:spLocks noGrp="1"/>
+          </p:cNvSpPr>
+          <p:nvPr>
+            <p:ph type="title"/>
+          </p:nvPr>
+        </p:nvSpPr>
+        <p:spPr/>
+        <p:txBody>
+          <a:bodyPr/>
+          <a:lstStyle/>
+          <a:p>
+            <a:r>
+              <a:rPr lang="nb-NO" dirty="0"/>
+              <a:t>UART til PC</a:t>
+            </a:r>
+          </a:p>
+        </p:txBody>
+      </p:sp>
+      <p:sp>
+        <p:nvSpPr>
+          <p:cNvPr id="3" name="Plassholder for innhold 2">
+            <a:extLst>
+              <a:ext uri="{FF2B5EF4-FFF2-40B4-BE49-F238E27FC236}">
+                <a16:creationId xmlns:a16="http://schemas.microsoft.com/office/drawing/2014/main" id="{9641E47C-3839-A3EE-38FC-F3E51E7377C2}"/>
+              </a:ext>
+            </a:extLst>
+          </p:cNvPr>
+          <p:cNvSpPr>
+            <a:spLocks noGrp="1"/>
+          </p:cNvSpPr>
+          <p:nvPr>
+            <p:ph idx="1"/>
+          </p:nvPr>
+        </p:nvSpPr>
+        <p:spPr/>
+        <p:txBody>
+          <a:bodyPr/>
+          <a:lstStyle/>
+          <a:p>
+            <a:r>
+              <a:rPr lang="nb-NO" dirty="0"/>
+              <a:t>Legg til UART-komponent</a:t>
+            </a:r>
+          </a:p>
+          <a:p>
+            <a:r>
+              <a:rPr lang="nb-NO" dirty="0"/>
+              <a:t>Tips: UART </a:t>
+            </a:r>
+            <a:r>
+              <a:rPr lang="nb-NO" dirty="0" err="1"/>
+              <a:t>Example</a:t>
+            </a:r>
+            <a:r>
+              <a:rPr lang="nb-NO" dirty="0"/>
+              <a:t> er en god ressurs for oppsett</a:t>
+            </a:r>
+          </a:p>
+        </p:txBody>
+      </p:sp>
+      <p:pic>
+        <p:nvPicPr>
+          <p:cNvPr id="5" name="Bilde 4">
+            <a:extLst>
+              <a:ext uri="{FF2B5EF4-FFF2-40B4-BE49-F238E27FC236}">
+                <a16:creationId xmlns:a16="http://schemas.microsoft.com/office/drawing/2014/main" id="{DEA51BD4-B0AA-E2E8-4E32-704972683966}"/>
+              </a:ext>
+            </a:extLst>
+          </p:cNvPr>
+          <p:cNvPicPr>
+            <a:picLocks noChangeAspect="1"/>
+          </p:cNvPicPr>
+          <p:nvPr/>
+        </p:nvPicPr>
+        <p:blipFill>
+          <a:blip r:embed="rId2"/>
+          <a:stretch>
+            <a:fillRect/>
+          </a:stretch>
+        </p:blipFill>
+        <p:spPr>
+          <a:xfrm>
+            <a:off x="838199" y="4511040"/>
+            <a:ext cx="10504595" cy="2075180"/>
+          </a:xfrm>
+          <a:prstGeom prst="rect">
+            <a:avLst/>
+          </a:prstGeom>
+        </p:spPr>
+      </p:pic>
+    </p:spTree>
+    <p:extLst>
+      <p:ext uri="{BB962C8B-B14F-4D97-AF65-F5344CB8AC3E}">
+        <p14:creationId xmlns:p14="http://schemas.microsoft.com/office/powerpoint/2010/main" val="36855540"/>
+      </p:ext>
+    </p:extLst>
+  </p:cSld>
+  <p:clrMapOvr>
+    <a:masterClrMapping/>
+  </p:clrMapOvr>
+</p:sld>
+</file>
+
+<file path=ppt/slides/slide28.xml><?xml version="1.0" encoding="utf-8"?>
+<p:sld xmlns:a="http://schemas.openxmlformats.org/drawingml/2006/main" xmlns:r="http://schemas.openxmlformats.org/officeDocument/2006/relationships" xmlns:p="http://schemas.openxmlformats.org/presentationml/2006/main">
+  <p:cSld>
+    <p:spTree>
+      <p:nvGrpSpPr>
+        <p:cNvPr id="1" name="">
+          <a:extLst>
+            <a:ext uri="{FF2B5EF4-FFF2-40B4-BE49-F238E27FC236}">
+              <a16:creationId xmlns:a16="http://schemas.microsoft.com/office/drawing/2014/main" id="{4CDAF1CB-6CA1-93F7-867E-6A5E1A6BD991}"/>
+            </a:ext>
+          </a:extLst>
+        </p:cNvPr>
+        <p:cNvGrpSpPr/>
+        <p:nvPr/>
+      </p:nvGrpSpPr>
+      <p:grpSpPr>
+        <a:xfrm>
+          <a:off x="0" y="0"/>
+          <a:ext cx="0" cy="0"/>
+          <a:chOff x="0" y="0"/>
+          <a:chExt cx="0" cy="0"/>
+        </a:xfrm>
+      </p:grpSpPr>
+      <p:sp>
+        <p:nvSpPr>
+          <p:cNvPr id="2" name="Tittel 1">
+            <a:extLst>
+              <a:ext uri="{FF2B5EF4-FFF2-40B4-BE49-F238E27FC236}">
+                <a16:creationId xmlns:a16="http://schemas.microsoft.com/office/drawing/2014/main" id="{2B95F1EE-0630-9964-23CC-D148C7E05000}"/>
+              </a:ext>
+            </a:extLst>
+          </p:cNvPr>
+          <p:cNvSpPr>
+            <a:spLocks noGrp="1"/>
+          </p:cNvSpPr>
+          <p:nvPr>
+            <p:ph type="title"/>
+          </p:nvPr>
+        </p:nvSpPr>
+        <p:spPr/>
+        <p:txBody>
+          <a:bodyPr/>
+          <a:lstStyle/>
+          <a:p>
+            <a:r>
+              <a:rPr lang="nb-NO" dirty="0"/>
+              <a:t>UART til PC</a:t>
+            </a:r>
+          </a:p>
+        </p:txBody>
+      </p:sp>
+      <p:sp>
+        <p:nvSpPr>
+          <p:cNvPr id="3" name="Plassholder for innhold 2">
+            <a:extLst>
+              <a:ext uri="{FF2B5EF4-FFF2-40B4-BE49-F238E27FC236}">
+                <a16:creationId xmlns:a16="http://schemas.microsoft.com/office/drawing/2014/main" id="{6737BF37-5650-B542-0612-1C4ABD29AEB9}"/>
+              </a:ext>
+            </a:extLst>
+          </p:cNvPr>
+          <p:cNvSpPr>
+            <a:spLocks noGrp="1"/>
+          </p:cNvSpPr>
+          <p:nvPr>
+            <p:ph idx="1"/>
+          </p:nvPr>
+        </p:nvSpPr>
+        <p:spPr/>
+        <p:txBody>
+          <a:bodyPr/>
+          <a:lstStyle/>
+          <a:p>
+            <a:r>
+              <a:rPr lang="nb-NO" dirty="0"/>
+              <a:t>VIKTIG: Velg UART3</a:t>
+            </a:r>
+          </a:p>
+          <a:p>
+            <a:r>
+              <a:rPr lang="nb-NO" dirty="0"/>
+              <a:t>TX og RX, PB0 og 1</a:t>
+            </a:r>
+          </a:p>
+        </p:txBody>
+      </p:sp>
+      <p:pic>
+        <p:nvPicPr>
+          <p:cNvPr id="6" name="Bilde 5">
+            <a:extLst>
+              <a:ext uri="{FF2B5EF4-FFF2-40B4-BE49-F238E27FC236}">
+                <a16:creationId xmlns:a16="http://schemas.microsoft.com/office/drawing/2014/main" id="{68918AEB-EC8A-C598-4937-DC6280CEEE4A}"/>
+              </a:ext>
+            </a:extLst>
+          </p:cNvPr>
+          <p:cNvPicPr>
+            <a:picLocks noChangeAspect="1"/>
+          </p:cNvPicPr>
+          <p:nvPr/>
+        </p:nvPicPr>
+        <p:blipFill>
+          <a:blip r:embed="rId2"/>
+          <a:stretch>
+            <a:fillRect/>
+          </a:stretch>
+        </p:blipFill>
+        <p:spPr>
+          <a:xfrm>
+            <a:off x="4419600" y="1825625"/>
+            <a:ext cx="7191050" cy="2514568"/>
+          </a:xfrm>
+          <a:prstGeom prst="rect">
+            <a:avLst/>
+          </a:prstGeom>
+        </p:spPr>
+      </p:pic>
+      <p:pic>
+        <p:nvPicPr>
+          <p:cNvPr id="10" name="Bilde 9">
+            <a:extLst>
+              <a:ext uri="{FF2B5EF4-FFF2-40B4-BE49-F238E27FC236}">
+                <a16:creationId xmlns:a16="http://schemas.microsoft.com/office/drawing/2014/main" id="{D5197CC5-DD6E-4858-AC62-F3C9B0338364}"/>
+              </a:ext>
+            </a:extLst>
+          </p:cNvPr>
+          <p:cNvPicPr>
+            <a:picLocks noChangeAspect="1"/>
+          </p:cNvPicPr>
+          <p:nvPr/>
+        </p:nvPicPr>
+        <p:blipFill>
+          <a:blip r:embed="rId3"/>
+          <a:stretch>
+            <a:fillRect/>
+          </a:stretch>
+        </p:blipFill>
+        <p:spPr>
+          <a:xfrm>
+            <a:off x="1716857" y="4730504"/>
+            <a:ext cx="7173326" cy="1762371"/>
+          </a:xfrm>
+          <a:prstGeom prst="rect">
+            <a:avLst/>
+          </a:prstGeom>
+        </p:spPr>
+      </p:pic>
+    </p:spTree>
+    <p:extLst>
+      <p:ext uri="{BB962C8B-B14F-4D97-AF65-F5344CB8AC3E}">
+        <p14:creationId xmlns:p14="http://schemas.microsoft.com/office/powerpoint/2010/main" val="276364488"/>
+      </p:ext>
+    </p:extLst>
+  </p:cSld>
+  <p:clrMapOvr>
+    <a:masterClrMapping/>
+  </p:clrMapOvr>
+</p:sld>
+</file>
+
+<file path=ppt/slides/slide29.xml><?xml version="1.0" encoding="utf-8"?>
+<p:sld xmlns:a="http://schemas.openxmlformats.org/drawingml/2006/main" xmlns:r="http://schemas.openxmlformats.org/officeDocument/2006/relationships" xmlns:p="http://schemas.openxmlformats.org/presentationml/2006/main">
+  <p:cSld>
+    <p:spTree>
+      <p:nvGrpSpPr>
+        <p:cNvPr id="1" name="">
+          <a:extLst>
+            <a:ext uri="{FF2B5EF4-FFF2-40B4-BE49-F238E27FC236}">
+              <a16:creationId xmlns:a16="http://schemas.microsoft.com/office/drawing/2014/main" id="{2105CD74-BB3B-0BB0-3BEE-C45825010E3F}"/>
+            </a:ext>
+          </a:extLst>
+        </p:cNvPr>
+        <p:cNvGrpSpPr/>
+        <p:nvPr/>
+      </p:nvGrpSpPr>
+      <p:grpSpPr>
+        <a:xfrm>
+          <a:off x="0" y="0"/>
+          <a:ext cx="0" cy="0"/>
+          <a:chOff x="0" y="0"/>
+          <a:chExt cx="0" cy="0"/>
+        </a:xfrm>
+      </p:grpSpPr>
+      <p:sp>
+        <p:nvSpPr>
+          <p:cNvPr id="2" name="Tittel 1">
+            <a:extLst>
+              <a:ext uri="{FF2B5EF4-FFF2-40B4-BE49-F238E27FC236}">
+                <a16:creationId xmlns:a16="http://schemas.microsoft.com/office/drawing/2014/main" id="{18F6FF5A-B5B5-6269-02C7-8577186BF458}"/>
+              </a:ext>
+            </a:extLst>
+          </p:cNvPr>
+          <p:cNvSpPr>
+            <a:spLocks noGrp="1"/>
+          </p:cNvSpPr>
+          <p:nvPr>
+            <p:ph type="title"/>
+          </p:nvPr>
+        </p:nvSpPr>
+        <p:spPr/>
+        <p:txBody>
+          <a:bodyPr/>
+          <a:lstStyle/>
+          <a:p>
+            <a:r>
+              <a:rPr lang="nb-NO" dirty="0"/>
+              <a:t>UART til PC</a:t>
+            </a:r>
+          </a:p>
+        </p:txBody>
+      </p:sp>
+      <p:sp>
+        <p:nvSpPr>
+          <p:cNvPr id="3" name="Plassholder for innhold 2">
+            <a:extLst>
+              <a:ext uri="{FF2B5EF4-FFF2-40B4-BE49-F238E27FC236}">
+                <a16:creationId xmlns:a16="http://schemas.microsoft.com/office/drawing/2014/main" id="{5992EC0A-B948-A06C-E62D-C59040E0EBC8}"/>
+              </a:ext>
+            </a:extLst>
+          </p:cNvPr>
+          <p:cNvSpPr>
+            <a:spLocks noGrp="1"/>
+          </p:cNvSpPr>
+          <p:nvPr>
+            <p:ph idx="1"/>
+          </p:nvPr>
+        </p:nvSpPr>
+        <p:spPr/>
+        <p:txBody>
+          <a:bodyPr/>
+          <a:lstStyle/>
+          <a:p>
+            <a:r>
+              <a:rPr lang="nb-NO" dirty="0"/>
+              <a:t>Velg Baud</a:t>
+            </a:r>
+          </a:p>
+          <a:p>
+            <a:pPr lvl="1"/>
+            <a:r>
+              <a:rPr lang="nb-NO" dirty="0"/>
+              <a:t>9600 og 115200 er vanlig</a:t>
+            </a:r>
+          </a:p>
+          <a:p>
+            <a:r>
+              <a:rPr lang="nb-NO" dirty="0" err="1"/>
+              <a:t>Datalengde</a:t>
+            </a:r>
+            <a:endParaRPr lang="nb-NO" dirty="0"/>
+          </a:p>
+          <a:p>
+            <a:r>
+              <a:rPr lang="nb-NO" dirty="0" err="1"/>
+              <a:t>Parity</a:t>
+            </a:r>
+            <a:endParaRPr lang="nb-NO" dirty="0"/>
+          </a:p>
+          <a:p>
+            <a:endParaRPr lang="nb-NO" dirty="0"/>
+          </a:p>
+          <a:p>
+            <a:r>
+              <a:rPr lang="nb-NO" dirty="0" err="1"/>
+              <a:t>Printf</a:t>
+            </a:r>
+            <a:r>
+              <a:rPr lang="nb-NO" dirty="0"/>
+              <a:t> to UART forenkler sending</a:t>
+            </a:r>
+          </a:p>
+        </p:txBody>
+      </p:sp>
+      <p:pic>
+        <p:nvPicPr>
+          <p:cNvPr id="8" name="Bilde 7">
+            <a:extLst>
+              <a:ext uri="{FF2B5EF4-FFF2-40B4-BE49-F238E27FC236}">
+                <a16:creationId xmlns:a16="http://schemas.microsoft.com/office/drawing/2014/main" id="{A7ED3138-F083-C396-1545-9A64BA582352}"/>
+              </a:ext>
+            </a:extLst>
+          </p:cNvPr>
+          <p:cNvPicPr>
+            <a:picLocks noChangeAspect="1"/>
+          </p:cNvPicPr>
+          <p:nvPr/>
+        </p:nvPicPr>
+        <p:blipFill>
+          <a:blip r:embed="rId2"/>
+          <a:stretch>
+            <a:fillRect/>
+          </a:stretch>
+        </p:blipFill>
+        <p:spPr>
+          <a:xfrm>
+            <a:off x="7155487" y="1504783"/>
+            <a:ext cx="4607418" cy="4672180"/>
+          </a:xfrm>
+          <a:prstGeom prst="rect">
+            <a:avLst/>
+          </a:prstGeom>
+        </p:spPr>
+      </p:pic>
+    </p:spTree>
+    <p:extLst>
+      <p:ext uri="{BB962C8B-B14F-4D97-AF65-F5344CB8AC3E}">
+        <p14:creationId xmlns:p14="http://schemas.microsoft.com/office/powerpoint/2010/main" val="2901486861"/>
       </p:ext>
     </p:extLst>
   </p:cSld>

</xml_diff>

<commit_message>
La til callbackRegister i presentasjon
</commit_message>
<xml_diff>
--- a/Kursdag 2/Dag to.pptx
+++ b/Kursdag 2/Dag to.pptx
@@ -225,7 +225,7 @@
           <a:p>
             <a:fld id="{ACB6A25B-A690-4E14-9ED0-D2ECF6431ED6}" type="datetimeFigureOut">
               <a:rPr lang="nb-NO" smtClean="0"/>
-              <a:t>15.03.2026</a:t>
+              <a:t>19.03.2026</a:t>
             </a:fld>
             <a:endParaRPr lang="nb-NO"/>
           </a:p>
@@ -726,7 +726,7 @@
           <a:p>
             <a:fld id="{B9F7994A-41AD-4027-8E6D-AD66A7C6695C}" type="datetimeFigureOut">
               <a:rPr lang="nb-NO" smtClean="0"/>
-              <a:t>15.03.2026</a:t>
+              <a:t>19.03.2026</a:t>
             </a:fld>
             <a:endParaRPr lang="nb-NO"/>
           </a:p>
@@ -924,7 +924,7 @@
           <a:p>
             <a:fld id="{B9F7994A-41AD-4027-8E6D-AD66A7C6695C}" type="datetimeFigureOut">
               <a:rPr lang="nb-NO" smtClean="0"/>
-              <a:t>15.03.2026</a:t>
+              <a:t>19.03.2026</a:t>
             </a:fld>
             <a:endParaRPr lang="nb-NO"/>
           </a:p>
@@ -1132,7 +1132,7 @@
           <a:p>
             <a:fld id="{B9F7994A-41AD-4027-8E6D-AD66A7C6695C}" type="datetimeFigureOut">
               <a:rPr lang="nb-NO" smtClean="0"/>
-              <a:t>15.03.2026</a:t>
+              <a:t>19.03.2026</a:t>
             </a:fld>
             <a:endParaRPr lang="nb-NO"/>
           </a:p>
@@ -1330,7 +1330,7 @@
           <a:p>
             <a:fld id="{B9F7994A-41AD-4027-8E6D-AD66A7C6695C}" type="datetimeFigureOut">
               <a:rPr lang="nb-NO" smtClean="0"/>
-              <a:t>15.03.2026</a:t>
+              <a:t>19.03.2026</a:t>
             </a:fld>
             <a:endParaRPr lang="nb-NO"/>
           </a:p>
@@ -1605,7 +1605,7 @@
           <a:p>
             <a:fld id="{B9F7994A-41AD-4027-8E6D-AD66A7C6695C}" type="datetimeFigureOut">
               <a:rPr lang="nb-NO" smtClean="0"/>
-              <a:t>15.03.2026</a:t>
+              <a:t>19.03.2026</a:t>
             </a:fld>
             <a:endParaRPr lang="nb-NO"/>
           </a:p>
@@ -1870,7 +1870,7 @@
           <a:p>
             <a:fld id="{B9F7994A-41AD-4027-8E6D-AD66A7C6695C}" type="datetimeFigureOut">
               <a:rPr lang="nb-NO" smtClean="0"/>
-              <a:t>15.03.2026</a:t>
+              <a:t>19.03.2026</a:t>
             </a:fld>
             <a:endParaRPr lang="nb-NO"/>
           </a:p>
@@ -2282,7 +2282,7 @@
           <a:p>
             <a:fld id="{B9F7994A-41AD-4027-8E6D-AD66A7C6695C}" type="datetimeFigureOut">
               <a:rPr lang="nb-NO" smtClean="0"/>
-              <a:t>15.03.2026</a:t>
+              <a:t>19.03.2026</a:t>
             </a:fld>
             <a:endParaRPr lang="nb-NO"/>
           </a:p>
@@ -2423,7 +2423,7 @@
           <a:p>
             <a:fld id="{B9F7994A-41AD-4027-8E6D-AD66A7C6695C}" type="datetimeFigureOut">
               <a:rPr lang="nb-NO" smtClean="0"/>
-              <a:t>15.03.2026</a:t>
+              <a:t>19.03.2026</a:t>
             </a:fld>
             <a:endParaRPr lang="nb-NO"/>
           </a:p>
@@ -2536,7 +2536,7 @@
           <a:p>
             <a:fld id="{B9F7994A-41AD-4027-8E6D-AD66A7C6695C}" type="datetimeFigureOut">
               <a:rPr lang="nb-NO" smtClean="0"/>
-              <a:t>15.03.2026</a:t>
+              <a:t>19.03.2026</a:t>
             </a:fld>
             <a:endParaRPr lang="nb-NO"/>
           </a:p>
@@ -2847,7 +2847,7 @@
           <a:p>
             <a:fld id="{B9F7994A-41AD-4027-8E6D-AD66A7C6695C}" type="datetimeFigureOut">
               <a:rPr lang="nb-NO" smtClean="0"/>
-              <a:t>15.03.2026</a:t>
+              <a:t>19.03.2026</a:t>
             </a:fld>
             <a:endParaRPr lang="nb-NO"/>
           </a:p>
@@ -3135,7 +3135,7 @@
           <a:p>
             <a:fld id="{B9F7994A-41AD-4027-8E6D-AD66A7C6695C}" type="datetimeFigureOut">
               <a:rPr lang="nb-NO" smtClean="0"/>
-              <a:t>15.03.2026</a:t>
+              <a:t>19.03.2026</a:t>
             </a:fld>
             <a:endParaRPr lang="nb-NO"/>
           </a:p>
@@ -3376,7 +3376,7 @@
           <a:p>
             <a:fld id="{B9F7994A-41AD-4027-8E6D-AD66A7C6695C}" type="datetimeFigureOut">
               <a:rPr lang="nb-NO" smtClean="0"/>
-              <a:t>15.03.2026</a:t>
+              <a:t>19.03.2026</a:t>
             </a:fld>
             <a:endParaRPr lang="nb-NO"/>
           </a:p>
@@ -7895,8 +7895,38 @@
         </p:blipFill>
         <p:spPr>
           <a:xfrm>
-            <a:off x="1799880" y="1796689"/>
+            <a:off x="1780216" y="1403398"/>
             <a:ext cx="8061300" cy="4279648"/>
+          </a:xfrm>
+          <a:prstGeom prst="rect">
+            <a:avLst/>
+          </a:prstGeom>
+        </p:spPr>
+      </p:pic>
+      <p:pic>
+        <p:nvPicPr>
+          <p:cNvPr id="4" name="Bilde 3">
+            <a:extLst>
+              <a:ext uri="{FF2B5EF4-FFF2-40B4-BE49-F238E27FC236}">
+                <a16:creationId xmlns:a16="http://schemas.microsoft.com/office/drawing/2014/main" id="{41825512-BFE7-0028-E1D7-04FA84F4DC62}"/>
+              </a:ext>
+            </a:extLst>
+          </p:cNvPr>
+          <p:cNvPicPr>
+            <a:picLocks noChangeAspect="1"/>
+          </p:cNvPicPr>
+          <p:nvPr/>
+        </p:nvPicPr>
+        <p:blipFill>
+          <a:blip r:embed="rId3"/>
+          <a:stretch>
+            <a:fillRect/>
+          </a:stretch>
+        </p:blipFill>
+        <p:spPr>
+          <a:xfrm>
+            <a:off x="2350484" y="5683046"/>
+            <a:ext cx="7491032" cy="756799"/>
           </a:xfrm>
           <a:prstGeom prst="rect">
             <a:avLst/>

</xml_diff>